<commit_message>
submission: deck rewritten as a product presentation with all features by area (19 slides), video link, checklist as evidence map
</commit_message>
<xml_diff>
--- a/docs/submission/rafeeq-deck.pptx
+++ b/docs/submission/rafeeq-deck.pptx
@@ -21,6 +21,9 @@
     <p:sldId id="269" r:id="rId21"/>
     <p:sldId id="270" r:id="rId22"/>
     <p:sldId id="271" r:id="rId23"/>
+    <p:sldId id="272" r:id="rId24"/>
+    <p:sldId id="273" r:id="rId25"/>
+    <p:sldId id="274" r:id="rId26"/>
   </p:sldIdLst>
   <p:sldSz cx="12192000" cy="6858000" type="screen4x3"/>
   <p:notesSz cx="6858000" cy="9144000"/>
@@ -607,47 +610,92 @@
           <a:lstStyle/>
           <a:p>
             <a:r>
-              <a:t>)2 من 1( المرشوع من صور</a:t>
-            </a:r>
-          </a:p>
-          <a:p>
-            <a:r>
-              <a:t>الحي الموقع من</a:t>
-            </a:r>
-          </a:p>
-          <a:p>
-            <a:r>
-              <a:t>وحدها اللغة اختيار :البدايةلأو اً التالية الخطوة :الرئيسية</a:t>
-            </a:r>
-          </a:p>
-          <a:p>
-            <a:r>
-              <a:t>مع البيانات قاعدة من آية :درس</a:t>
-            </a:r>
-          </a:p>
-          <a:p>
-            <a:r>
-              <a:t>تالوتها</a:t>
-            </a:r>
-          </a:p>
-          <a:p>
-            <a:r>
-              <a:t>البطاقات بعد تمرين</a:t>
-            </a:r>
-          </a:p>
-          <a:p>
-            <a:r>
-              <a:t>معها إجابة كل :التعريف صفحة</a:t>
-            </a:r>
-          </a:p>
-          <a:p>
-            <a:r>
-              <a:t>مصدرها</a:t>
-            </a:r>
-          </a:p>
-          <a:p>
-            <a:r>
-              <a:t>10 / 16</a:t>
+              <a:t>)2 من 2( الصطناعي الذكاء</a:t>
+            </a:r>
+          </a:p>
+          <a:p>
+            <a:r>
+              <a:t>التع ّلم خدمة يف الصطناعي الذكاء</a:t>
+            </a:r>
+          </a:p>
+          <a:p>
+            <a:r>
+              <a:t>.التجربة استمرار يضمن ثابت بديل منها ولكل ،وفاحص محدود مدخل منها لكل ،محددة صغرية مهام</a:t>
+            </a:r>
+          </a:p>
+          <a:p>
+            <a:r>
+              <a:t>الخطأ رشح »لماذا؟«</a:t>
+            </a:r>
+          </a:p>
+          <a:p>
+            <a:r>
+              <a:t>على كلمة 60 يف رش ًحا يكتب .المتع ّلم وإجابة والتمرين المعتمدة البطاقة :المدخل</a:t>
+            </a:r>
+          </a:p>
+          <a:p>
+            <a:r>
+              <a:t>.الفحص اجتاز ما إال ُيعرض وال .ٍثا نموذج يفحصه ثم ،األكرث</a:t>
+            </a:r>
+          </a:p>
+          <a:p>
+            <a:r>
+              <a:t>التعليمي المو ّجه</a:t>
+            </a:r>
+          </a:p>
+          <a:p>
+            <a:r>
+              <a:t>من فيه اسم وكل ،جمل 3 يف اآلن يتع ّلمه ما يقرتح ،هوية يحمل ال تع ّلم مل ّخص من</a:t>
+            </a:r>
+          </a:p>
+          <a:p>
+            <a:r>
+              <a:t>.ُيحفظ ال المل ّخص .المل ّخص</a:t>
+            </a:r>
+          </a:p>
+          <a:p>
+            <a:r>
+              <a:t>الرئيسية ترتيب</a:t>
+            </a:r>
+          </a:p>
+          <a:p>
+            <a:r>
+              <a:t>تبقى التالية الخطوة .اليوم يف مرة ،والتق ّدم اليوم وقت بحسب الرئيسية مك ّونات ير ّتب</a:t>
+            </a:r>
+          </a:p>
+          <a:p>
+            <a:r>
+              <a:t>.بديل ثابت ترتيب ومعه ،دائ ًما لأو اً</a:t>
+            </a:r>
+          </a:p>
+          <a:p>
+            <a:r>
+              <a:t>تع ّلمي بهدف السؤال ربط</a:t>
+            </a:r>
+          </a:p>
+          <a:p>
+            <a:r>
+              <a:t>الدرس فيقرتح ،معتمدة قائمة من بهدف المجاب سؤاله يربط :فقط المتع ّلم بإذن</a:t>
+            </a:r>
+          </a:p>
+          <a:p>
+            <a:r>
+              <a:t>.وحده المع ّرف ُيرسل .المناسب</a:t>
+            </a:r>
+          </a:p>
+          <a:p>
+            <a:r>
+              <a:t>المراجعة · ثاب ًتا ر ًدا ويعرض الطلبات يوقف وكلي يومي إنفاق سقف · تعليمات ال بيانات ُيعامل المستخدم نص · طلب أي يف سجل وال مع ّرف وال اسم يدخل ال :مشرتكة ضوابط</a:t>
+            </a:r>
+          </a:p>
+          <a:p>
+            <a:r>
+              <a:t>.لغوي نموذج ال ،مكتوبة خوارزمية التك ّيفية</a:t>
+            </a:r>
+          </a:p>
+          <a:p>
+            <a:r>
+              <a:t>10 / 19</a:t>
             </a:r>
           </a:p>
         </p:txBody>
@@ -717,47 +765,122 @@
           <a:lstStyle/>
           <a:p>
             <a:r>
-              <a:t>)2 من 2( المرشوع من صور</a:t>
-            </a:r>
-          </a:p>
-          <a:p>
-            <a:r>
-              <a:t>الحي الموقع من</a:t>
-            </a:r>
-          </a:p>
-          <a:p>
-            <a:r>
-              <a:t>الجهاز على محسوبة الصالة مواقيت</a:t>
-            </a:r>
-          </a:p>
-          <a:p>
-            <a:r>
-              <a:t>اليومية األذكار</a:t>
-            </a:r>
-          </a:p>
-          <a:p>
-            <a:r>
-              <a:t>المصادر يف والبحث المكتبة</a:t>
-            </a:r>
-          </a:p>
-          <a:p>
-            <a:r>
-              <a:t>واللغة ،حساب بال زائر :حسايب</a:t>
-            </a:r>
-          </a:p>
-          <a:p>
-            <a:r>
-              <a:t>والتزنيالت</a:t>
-            </a:r>
-          </a:p>
-          <a:p>
-            <a:r>
-              <a:t>والخصوصية المحايدة اإلشعارات</a:t>
-            </a:r>
-          </a:p>
-          <a:p>
-            <a:r>
-              <a:t>11 / 16</a:t>
+              <a:t>العلمية والسالمة الموثوقية</a:t>
+            </a:r>
+          </a:p>
+          <a:p>
+            <a:r>
+              <a:t>يحيل؟ أو يمتنع ومىت ،رفيق يجيب مىت</a:t>
+            </a:r>
+          </a:p>
+          <a:p>
+            <a:r>
+              <a:t>.خالفية مسألة يف ير ّجح وال ،شخصية حالة يف يفيت وال ،عنده من حدي ًثا وال آية يكتب ال النموذج</a:t>
+            </a:r>
+          </a:p>
+          <a:p>
+            <a:r>
+              <a:t>اإلجابات يف المعتمدة المصادر</a:t>
+            </a:r>
+          </a:p>
+          <a:p>
+            <a:r>
+              <a:t>المعتمدة وترجماته القرآن نص :QuranEnc</a:t>
+            </a:r>
+          </a:p>
+          <a:p>
+            <a:r>
+              <a:t>ورشحها درجتها مع األحاديث :HadeethEnc</a:t>
+            </a:r>
+          </a:p>
+          <a:p>
+            <a:r>
+              <a:t>الجديد للمسلم المفيد المخترص :IslamHouse موسوعة</a:t>
+            </a:r>
+          </a:p>
+          <a:p>
+            <a:r>
+              <a:t>باز ابن الشيخ موقع فتاوى</a:t>
+            </a:r>
+          </a:p>
+          <a:p>
+            <a:r>
+              <a:t>واإلنجلزيية بالعربية إجابات :وجواب سؤال اإلسالم</a:t>
+            </a:r>
+          </a:p>
+          <a:p>
+            <a:r>
+              <a:t>.وحدها البيانات قاعدة من ُيعرض والحديث القرآن نص</a:t>
+            </a:r>
+          </a:p>
+          <a:p>
+            <a:r>
+              <a:t>الحالة</a:t>
+            </a:r>
+          </a:p>
+          <a:p>
+            <a:r>
+              <a:t>رفيق سلوك</a:t>
+            </a:r>
+          </a:p>
+          <a:p>
+            <a:r>
+              <a:t>مصدر يوجد ال</a:t>
+            </a:r>
+          </a:p>
+          <a:p>
+            <a:r>
+              <a:t>مرشد مع التواصل ويقرتح بوضوح يعتذر</a:t>
+            </a:r>
+          </a:p>
+          <a:p>
+            <a:r>
+              <a:t>شخيص سؤال</a:t>
+            </a:r>
+          </a:p>
+          <a:p>
+            <a:r>
+              <a:t>العلم أهل أو مرشد إىل ويحيله المصادر يف ما يذكر</a:t>
+            </a:r>
+          </a:p>
+          <a:p>
+            <a:r>
+              <a:t>خالفية مسألة</a:t>
+            </a:r>
+          </a:p>
+          <a:p>
+            <a:r>
+              <a:t>ترجيح دون لأقوا اً فيها أن ييب نّ</a:t>
+            </a:r>
+          </a:p>
+          <a:p>
+            <a:r>
+              <a:t>السائل على خطر</a:t>
+            </a:r>
+          </a:p>
+          <a:p>
+            <a:r>
+              <a:t>نموذج دون ،إنسان إىل فورية إحالة</a:t>
+            </a:r>
+          </a:p>
+          <a:p>
+            <a:r>
+              <a:t>الخدمة تعطل</a:t>
+            </a:r>
+          </a:p>
+          <a:p>
+            <a:r>
+              <a:t>المصدر غياب ي ّدعي ال المحاولة؛ وإعادة صادقة رسالة</a:t>
+            </a:r>
+          </a:p>
+          <a:p>
+            <a:r>
+              <a:t>.2026 أكتوبر 6 يف )لغات 3 × أسئلة 3( جاهزة إجابات 9 اعتمد .يعيدها أو الجاهزة واإلجابات والبطاقات الدروس فيها يعتمد مراجعة منصة :الرشعي المراجع</a:t>
+            </a:r>
+          </a:p>
+          <a:p>
+            <a:r>
+              <a:t>11 / 19</a:t>
             </a:r>
           </a:p>
         </p:txBody>
@@ -827,137 +950,112 @@
           <a:lstStyle/>
           <a:p>
             <a:r>
-              <a:t>والخصوصية واإلتاحة المستفيد تجربة</a:t>
-            </a:r>
-          </a:p>
-          <a:p>
-            <a:r>
-              <a:t>وليلى ودانيال لجوزيف مص ّمم</a:t>
-            </a:r>
-          </a:p>
-          <a:p>
-            <a:r>
-              <a:t>.ُيكشف أن من خوف أو ،ضعيف اتصال أو ،لغة :حقيقي مستفيد وضع من جاء الواجهة يف قرار كل</a:t>
-            </a:r>
-          </a:p>
-          <a:p>
-            <a:r>
-              <a:t>واتجاهان لغات ثالث</a:t>
-            </a:r>
-          </a:p>
-          <a:p>
-            <a:r>
-              <a:t>من ،شاشة كل يف والتاغالوغية واإلنجلزيية العربية</a:t>
-            </a:r>
-          </a:p>
-          <a:p>
-            <a:r>
-              <a:t>مع يبقى العريب الرشعي والنص ،اليسار ومن اليمني</a:t>
-            </a:r>
-          </a:p>
-          <a:p>
-            <a:r>
-              <a:t>.معناه</a:t>
-            </a:r>
-          </a:p>
-          <a:p>
-            <a:r>
-              <a:t>اتصال دون يعمل</a:t>
-            </a:r>
-          </a:p>
-          <a:p>
-            <a:r>
-              <a:t>والمواقيت ،المسار من فتحه ما :زيارة أول بعد</a:t>
-            </a:r>
-          </a:p>
-          <a:p>
-            <a:r>
-              <a:t>معه يبقى ما فيه يختار تزنيالت ومركز .واألذكار والقبلة</a:t>
-            </a:r>
-          </a:p>
-          <a:p>
-            <a:r>
-              <a:t>.بحجمه</a:t>
-            </a:r>
-          </a:p>
-          <a:p>
-            <a:r>
-              <a:t>الباقة على خفيف</a:t>
-            </a:r>
-          </a:p>
-          <a:p>
-            <a:r>
-              <a:t>1 قرابة( فتح أول يف وحدها المتع ّلم واجهة</a:t>
-            </a:r>
-          </a:p>
-          <a:p>
-            <a:r>
-              <a:t>عند والفيديو والصوت ،)مضغوطة ميجابايت</a:t>
-            </a:r>
-          </a:p>
-          <a:p>
-            <a:r>
-              <a:t>.فقط التشغيل</a:t>
-            </a:r>
-          </a:p>
-          <a:p>
-            <a:r>
-              <a:t>الرسيع والخروج الخفي الوضع</a:t>
-            </a:r>
-          </a:p>
-          <a:p>
-            <a:r>
-              <a:t>اسم بال واإلشعارات »Notes« يصبح الصفحة عنوان</a:t>
-            </a:r>
-          </a:p>
-          <a:p>
-            <a:r>
-              <a:t>بيانات ومسح ،رسيع خروج وزر ،دينية كلمة وال رفيق</a:t>
-            </a:r>
-          </a:p>
-          <a:p>
-            <a:r>
-              <a:t>.الجهاز</a:t>
-            </a:r>
-          </a:p>
-          <a:p>
-            <a:r>
-              <a:t>البيانات من قدر أقل</a:t>
-            </a:r>
-          </a:p>
-          <a:p>
-            <a:r>
-              <a:t>مستعار اسم الحساب .للتع ّلم مطلوب حساب ال</a:t>
-            </a:r>
-          </a:p>
-          <a:p>
-            <a:r>
-              <a:t>.اختياري والربيد ،مرور وكلمة</a:t>
-            </a:r>
-          </a:p>
-          <a:p>
-            <a:r>
-              <a:t>الجهاز يغادر ال الموقع</a:t>
-            </a:r>
-          </a:p>
-          <a:p>
-            <a:r>
-              <a:t>،مدن قائمة من الجهاز على ُتحسب المواقيت</a:t>
-            </a:r>
-          </a:p>
-          <a:p>
-            <a:r>
-              <a:t>شاشة على ومحايدة ،يف ّعلها حىت مغلقة واإلشعارات</a:t>
-            </a:r>
-          </a:p>
-          <a:p>
-            <a:r>
-              <a:t>.القفل</a:t>
-            </a:r>
-          </a:p>
-          <a:p>
-            <a:r>
-              <a:t>12 / 16</a:t>
+              <a:t>النتائج</a:t>
+            </a:r>
+          </a:p>
+          <a:p>
+            <a:r>
+              <a:t>الفعلي التشغيل من أرقام</a:t>
+            </a:r>
+          </a:p>
+          <a:p>
+            <a:r>
+              <a:t>.2026 أكتوبر 6و 5 يف ،اآللية الختبارات ومن )األسئلة نص دون( الحي الموقع سجالت من</a:t>
+            </a:r>
+          </a:p>
+          <a:p>
+            <a:r>
+              <a:t>14/14</a:t>
+            </a:r>
+          </a:p>
+          <a:p>
+            <a:r>
+              <a:t>يف المصادر من ُأجيب عرب ًيا لسؤا اً</a:t>
+            </a:r>
+          </a:p>
+          <a:p>
+            <a:r>
+              <a:t>)أكتوبر 6( الحي الموقع</a:t>
+            </a:r>
+          </a:p>
+          <a:p>
+            <a:r>
+              <a:t>9/9</a:t>
+            </a:r>
+          </a:p>
+          <a:p>
+            <a:r>
+              <a:t>اختبار يف لألسئلة صحيح تصنيف</a:t>
+            </a:r>
+          </a:p>
+          <a:p>
+            <a:r>
+              <a:t>خطر ،خاليف ،شخيص ،عام :المو ّجه</a:t>
+            </a:r>
+          </a:p>
+          <a:p>
+            <a:r>
+              <a:t>$0.0015</a:t>
+            </a:r>
+          </a:p>
+          <a:p>
+            <a:r>
+              <a:t>وتصل ،تقري ًبا الواحدة اإلجابة تكلفة</a:t>
+            </a:r>
+          </a:p>
+          <a:p>
+            <a:r>
+              <a:t>ثانية 15 إىل 9 يف</a:t>
+            </a:r>
+          </a:p>
+          <a:p>
+            <a:r>
+              <a:t>+1,100</a:t>
+            </a:r>
+          </a:p>
+          <a:p>
+            <a:r>
+              <a:t>وثائق يف مثال لكل ،ناجح آيل اختبار</a:t>
+            </a:r>
+          </a:p>
+          <a:p>
+            <a:r>
+              <a:t>اختبار المزيات</a:t>
+            </a:r>
+          </a:p>
+          <a:p>
+            <a:r>
+              <a:t>تحسني ثم قياس</a:t>
+            </a:r>
+          </a:p>
+          <a:p>
+            <a:r>
+              <a:t>أن وجدنا :اإلنجلزيية اإلجابات رفعنا بهذا .سببها ونعرف مرفوضة إجابة كل نقيس</a:t>
+            </a:r>
+          </a:p>
+          <a:p>
+            <a:r>
+              <a:t>.واحد يوم يف فأصلحناه ،الحديث لنص نس ًخا ُّتع كانت ﷺ النيب على الصالة صيغ</a:t>
+            </a:r>
+          </a:p>
+          <a:p>
+            <a:r>
+              <a:t>تنازل صفر</a:t>
+            </a:r>
+          </a:p>
+          <a:p>
+            <a:r>
+              <a:t>ال يجتاز ال ما .بمصدرها جملة كل يطابق بفحص ثم آلية فحوص بسبعة تمر إجابة كل</a:t>
+            </a:r>
+          </a:p>
+          <a:p>
+            <a:r>
+              <a:t>.إنسان إىل وطريق صادق اعتذار منه لبد اً و ُيعرض ،ُيعرض</a:t>
+            </a:r>
+          </a:p>
+          <a:p>
+            <a:r>
+              <a:t>12 / 19</a:t>
             </a:r>
           </a:p>
         </p:txBody>
@@ -1027,177 +1125,47 @@
           <a:lstStyle/>
           <a:p>
             <a:r>
-              <a:t>والبنية التقنيات</a:t>
-            </a:r>
-          </a:p>
-          <a:p>
-            <a:r>
-              <a:t>وصيانتها تشغيلها يمكن بسيطة بنية</a:t>
-            </a:r>
-          </a:p>
-          <a:p>
-            <a:r>
-              <a:t>.آيل وتراجع صحة فحص مع ،ُينرش ثم ب الختبارات يمر الرئ يس الفرع إىل دفع كل</a:t>
-            </a:r>
-          </a:p>
-          <a:p>
-            <a:r>
-              <a:t>الجوال</a:t>
-            </a:r>
-          </a:p>
-          <a:p>
-            <a:r>
-              <a:t>قابل ويب تطبيق</a:t>
-            </a:r>
-          </a:p>
-          <a:p>
-            <a:r>
-              <a:t>للتثبيت</a:t>
-            </a:r>
-          </a:p>
-          <a:p>
-            <a:r>
-              <a:t>و Vite و React</a:t>
-            </a:r>
-          </a:p>
-          <a:p>
-            <a:r>
-              <a:t>خدمة وعامل ،TypeScript</a:t>
-            </a:r>
-          </a:p>
-          <a:p>
-            <a:r>
-              <a:t>ونظام ،اتصال دون للعمل</a:t>
-            </a:r>
-          </a:p>
-          <a:p>
-            <a:r>
-              <a:t>إشعارات .مو ّحد تصميم</a:t>
-            </a:r>
-          </a:p>
-          <a:p>
-            <a:r>
-              <a:t>.Web Push</a:t>
-            </a:r>
-          </a:p>
-          <a:p>
-            <a:r>
-              <a:t>⇄</a:t>
-            </a:r>
-          </a:p>
-          <a:p>
-            <a:r>
-              <a:t>الخادم</a:t>
-            </a:r>
-          </a:p>
-          <a:p>
-            <a:r>
-              <a:t>FastAPI (Python)</a:t>
-            </a:r>
-          </a:p>
-          <a:p>
-            <a:r>
-              <a:t>،والتحقق السؤال مسار</a:t>
-            </a:r>
-          </a:p>
-          <a:p>
-            <a:r>
-              <a:t>،والمراجعة والمسار</a:t>
-            </a:r>
-          </a:p>
-          <a:p>
-            <a:r>
-              <a:t>النصوص وواجهة ،والمرافقة</a:t>
-            </a:r>
-          </a:p>
-          <a:p>
-            <a:r>
-              <a:t>مجدولة مهام .الرشعية</a:t>
-            </a:r>
-          </a:p>
-          <a:p>
-            <a:r>
-              <a:t>.للفهرسة</a:t>
-            </a:r>
-          </a:p>
-          <a:p>
-            <a:r>
-              <a:t>⇄</a:t>
-            </a:r>
-          </a:p>
-          <a:p>
-            <a:r>
-              <a:t>البيانات</a:t>
-            </a:r>
-          </a:p>
-          <a:p>
-            <a:r>
-              <a:t>PostgreSQL +</a:t>
-            </a:r>
-          </a:p>
-          <a:p>
-            <a:r>
-              <a:t>pgvector</a:t>
-            </a:r>
-          </a:p>
-          <a:p>
-            <a:r>
-              <a:t>ومتجهاتها المعتمدة المقاطع</a:t>
-            </a:r>
-          </a:p>
-          <a:p>
-            <a:r>
-              <a:t>،نيص وفهرس )ُبع ًدا 1024(</a:t>
-            </a:r>
-          </a:p>
-          <a:p>
-            <a:r>
-              <a:t>.نص دون التكلفة وسجل</a:t>
-            </a:r>
-          </a:p>
-          <a:p>
-            <a:r>
-              <a:t>⇄</a:t>
-            </a:r>
-          </a:p>
-          <a:p>
-            <a:r>
-              <a:t>النماذج</a:t>
-            </a:r>
-          </a:p>
-          <a:p>
-            <a:r>
-              <a:t>OpenRouter</a:t>
-            </a:r>
-          </a:p>
-          <a:p>
-            <a:r>
-              <a:t>للتأليف Gemma 4</a:t>
-            </a:r>
-          </a:p>
-          <a:p>
-            <a:r>
-              <a:t>و ،والفحص والتصنيف</a:t>
-            </a:r>
-          </a:p>
-          <a:p>
-            <a:r>
-              <a:t>و ،احتياط ًيا DeepSeek</a:t>
-            </a:r>
-          </a:p>
-          <a:p>
-            <a:r>
-              <a:t>.للمتجهات bge-m3</a:t>
-            </a:r>
-          </a:p>
-          <a:p>
-            <a:r>
-              <a:t>github.com/rafeeq-muslim/rafeeq :الكود .GitHub Actions من آيل ونرش ،واحد خادم على nginx خلف Docker حاويات :الستضافة</a:t>
-            </a:r>
-          </a:p>
-          <a:p>
-            <a:r>
-              <a:t>13 / 16</a:t>
+              <a:t>)2 من 1( المرشوع من صور</a:t>
+            </a:r>
+          </a:p>
+          <a:p>
+            <a:r>
+              <a:t>الحي الموقع من</a:t>
+            </a:r>
+          </a:p>
+          <a:p>
+            <a:r>
+              <a:t>وحدها اللغة اختيار :البدايةلأو اً التالية الخطوة :الرئيسية</a:t>
+            </a:r>
+          </a:p>
+          <a:p>
+            <a:r>
+              <a:t>مع البيانات قاعدة من آية :درس</a:t>
+            </a:r>
+          </a:p>
+          <a:p>
+            <a:r>
+              <a:t>تالوتها</a:t>
+            </a:r>
+          </a:p>
+          <a:p>
+            <a:r>
+              <a:t>البطاقات بعد تمرين</a:t>
+            </a:r>
+          </a:p>
+          <a:p>
+            <a:r>
+              <a:t>معها إجابة كل :التعريف صفحة</a:t>
+            </a:r>
+          </a:p>
+          <a:p>
+            <a:r>
+              <a:t>مصدرها</a:t>
+            </a:r>
+          </a:p>
+          <a:p>
+            <a:r>
+              <a:t>13 / 19</a:t>
             </a:r>
           </a:p>
         </p:txBody>
@@ -1267,172 +1235,47 @@
           <a:lstStyle/>
           <a:p>
             <a:r>
-              <a:t>المضافة القيمة</a:t>
-            </a:r>
-          </a:p>
-          <a:p>
-            <a:r>
-              <a:t>البدائل؟ تق ّدمه وال رفيق يق ّدمه الذي ما</a:t>
-            </a:r>
-          </a:p>
-          <a:p>
-            <a:r>
-              <a:t>.لغات وعدة البرشي والمرشد المو ّثق والمساعد التع ّلمي المسار يجمع منت ًجا نجد لم ،تطبيقات 9و برنام ًجا 14 شمل مسح يف</a:t>
-            </a:r>
-          </a:p>
-          <a:p>
-            <a:r>
-              <a:t>عامة اصطناعي ذكاء محادثة</a:t>
-            </a:r>
-          </a:p>
-          <a:p>
-            <a:r>
-              <a:t>ثابتة ومواقع PDF كتيبات</a:t>
-            </a:r>
-          </a:p>
-          <a:p>
-            <a:r>
-              <a:t>التواصل وسائل</a:t>
-            </a:r>
-          </a:p>
-          <a:p>
-            <a:r>
-              <a:t>رفيق</a:t>
-            </a:r>
-          </a:p>
-          <a:p>
-            <a:r>
-              <a:t>المصدر</a:t>
-            </a:r>
-          </a:p>
-          <a:p>
-            <a:r>
-              <a:t>ن ًص ا يخرتع وقد ،معروف غري</a:t>
-            </a:r>
-          </a:p>
-          <a:p>
-            <a:r>
-              <a:t>موثوق</a:t>
-            </a:r>
-          </a:p>
-          <a:p>
-            <a:r>
-              <a:t>متضارب</a:t>
-            </a:r>
-          </a:p>
-          <a:p>
-            <a:r>
-              <a:t>البيانات قاعدة من والنص ،معتمدة مصادر</a:t>
-            </a:r>
-          </a:p>
-          <a:p>
-            <a:r>
-              <a:t>التد ّرج</a:t>
-            </a:r>
-          </a:p>
-          <a:p>
-            <a:r>
-              <a:t>يوجد ال</a:t>
-            </a:r>
-          </a:p>
-          <a:p>
-            <a:r>
-              <a:t>للجميع واحد كتاب</a:t>
-            </a:r>
-          </a:p>
-          <a:p>
-            <a:r>
-              <a:t>يوجد ال</a:t>
-            </a:r>
-          </a:p>
-          <a:p>
-            <a:r>
-              <a:t>اإلتقان بحسب ومراجعة مسار</a:t>
-            </a:r>
-          </a:p>
-          <a:p>
-            <a:r>
-              <a:t>لغته</a:t>
-            </a:r>
-          </a:p>
-          <a:p>
-            <a:r>
-              <a:t>ضمان دون ،نعم</a:t>
-            </a:r>
-          </a:p>
-          <a:p>
-            <a:r>
-              <a:t>بالتاغالوغية وقليل ،محدود</a:t>
-            </a:r>
-          </a:p>
-          <a:p>
-            <a:r>
-              <a:t>متفاوت</a:t>
-            </a:r>
-          </a:p>
-          <a:p>
-            <a:r>
-              <a:t>معتمدة بمصطلحات لغات ثالث</a:t>
-            </a:r>
-          </a:p>
-          <a:p>
-            <a:r>
-              <a:t>اإلنسان</a:t>
-            </a:r>
-          </a:p>
-          <a:p>
-            <a:r>
-              <a:t>ال</a:t>
-            </a:r>
-          </a:p>
-          <a:p>
-            <a:r>
-              <a:t>ال</a:t>
-            </a:r>
-          </a:p>
-          <a:p>
-            <a:r>
-              <a:t>غرباء</a:t>
-            </a:r>
-          </a:p>
-          <a:p>
-            <a:r>
-              <a:t>الخطر يف وإحالة ،وبلغته جنسه من مرشد</a:t>
-            </a:r>
-          </a:p>
-          <a:p>
-            <a:r>
-              <a:t>الخصوصية</a:t>
-            </a:r>
-          </a:p>
-          <a:p>
-            <a:r>
-              <a:t>ُتحفظ المحادثة</a:t>
-            </a:r>
-          </a:p>
-          <a:p>
-            <a:r>
-              <a:t>جيدة</a:t>
-            </a:r>
-          </a:p>
-          <a:p>
-            <a:r>
-              <a:t>مكشوفة</a:t>
-            </a:r>
-          </a:p>
-          <a:p>
-            <a:r>
-              <a:t>النموذج طلبات يف هوية وال ،خفي وضع</a:t>
-            </a:r>
-          </a:p>
-          <a:p>
-            <a:r>
-              <a:t>.)مكتيب بحث ،2026 أكتوبر ،السوق قسم( docs/agents/evidence.md :المسح</a:t>
-            </a:r>
-          </a:p>
-          <a:p>
-            <a:r>
-              <a:t>14 / 16</a:t>
+              <a:t>)2 من 2( المرشوع من صور</a:t>
+            </a:r>
+          </a:p>
+          <a:p>
+            <a:r>
+              <a:t>الحي الموقع من</a:t>
+            </a:r>
+          </a:p>
+          <a:p>
+            <a:r>
+              <a:t>الجهاز على محسوبة الصالة مواقيت</a:t>
+            </a:r>
+          </a:p>
+          <a:p>
+            <a:r>
+              <a:t>اليومية األذكار</a:t>
+            </a:r>
+          </a:p>
+          <a:p>
+            <a:r>
+              <a:t>المصادر يف والبحث المكتبة</a:t>
+            </a:r>
+          </a:p>
+          <a:p>
+            <a:r>
+              <a:t>واللغة ،حساب بال زائر :حسايب</a:t>
+            </a:r>
+          </a:p>
+          <a:p>
+            <a:r>
+              <a:t>والتزنيالت</a:t>
+            </a:r>
+          </a:p>
+          <a:p>
+            <a:r>
+              <a:t>والخصوصية المحايدة اإلشعارات</a:t>
+            </a:r>
+          </a:p>
+          <a:p>
+            <a:r>
+              <a:t>14 / 19</a:t>
             </a:r>
           </a:p>
         </p:txBody>
@@ -1502,112 +1345,137 @@
           <a:lstStyle/>
           <a:p>
             <a:r>
-              <a:t>الستمرار وخطة التشغيل واقعية</a:t>
-            </a:r>
-          </a:p>
-          <a:p>
-            <a:r>
-              <a:t>الح ًقا يأيت وما ،ُأنجز ما</a:t>
-            </a:r>
-          </a:p>
-          <a:p>
-            <a:r>
-              <a:t>اآلن ويعمل ُأنجز</a:t>
-            </a:r>
-          </a:p>
-          <a:p>
-            <a:r>
-              <a:t>لغات بثالث الحي الموقع</a:t>
-            </a:r>
-          </a:p>
-          <a:p>
-            <a:r>
-              <a:t>تك ّيفية ومراجعة در ًس ا 25و وحدات 6</a:t>
-            </a:r>
-          </a:p>
-          <a:p>
-            <a:r>
-              <a:t>واإلحالة بالتحقق »رفيق اسأل«</a:t>
-            </a:r>
-          </a:p>
-          <a:p>
-            <a:r>
-              <a:t>والمكتبة والقرآن واألذكار المواقيت</a:t>
-            </a:r>
-          </a:p>
-          <a:p>
-            <a:r>
-              <a:t>المراجعة ومنصة والمجموعات المرشد</a:t>
-            </a:r>
-          </a:p>
-          <a:p>
-            <a:r>
-              <a:t>الخفي والوضع اتصال دون العمل</a:t>
-            </a:r>
-          </a:p>
-          <a:p>
-            <a:r>
-              <a:t>أشخا ًص ا ينتظر</a:t>
-            </a:r>
-          </a:p>
-          <a:p>
-            <a:r>
-              <a:t>لغة بكل درس لكل الرشعي المراجع اعتماد</a:t>
-            </a:r>
-          </a:p>
-          <a:p>
-            <a:r>
-              <a:t>أصلي متحدث من التاغالوغية مراجعة</a:t>
-            </a:r>
-          </a:p>
-          <a:p>
-            <a:r>
-              <a:t>المصادر إذن ورسائل islamqa.info إذن</a:t>
-            </a:r>
-          </a:p>
-          <a:p>
-            <a:r>
-              <a:t>للطوارئ دعم وأرقام متطوعون مرشدون</a:t>
-            </a:r>
-          </a:p>
-          <a:p>
-            <a:r>
-              <a:t>التالية الخطوات</a:t>
-            </a:r>
-          </a:p>
-          <a:p>
-            <a:r>
-              <a:t>جدد ومسلمني دعوي مكتب مع ميدانية تجربة</a:t>
-            </a:r>
-          </a:p>
-          <a:p>
-            <a:r>
-              <a:t>اإلجابات لموثوقية الكامل الحي القياس</a:t>
-            </a:r>
-          </a:p>
-          <a:p>
-            <a:r>
-              <a:t>رابط أو برمز الحوار منصات من مبارشة إحالة</a:t>
-            </a:r>
-          </a:p>
-          <a:p>
-            <a:r>
-              <a:t>المعتمدة بالرتجمات أخرى لغات</a:t>
-            </a:r>
-          </a:p>
-          <a:p>
-            <a:r>
-              <a:t>.)حال ًيا 10$( كلي وسقف )للفهرسة 1$و لإلجابات 0.75$( يومي إنفاق سقف مع ،للمصادر األوىل والفهرسة )للسؤال 0.0015$ قرابة( المجابة األسئلة عدد هو يحددها ما :التكلفة</a:t>
-            </a:r>
-          </a:p>
-          <a:p>
-            <a:r>
-              <a:t>.حقيقي استخدام حجم عند شهرية تكلفة بعد نحسب ولم ،واحد الخادم</a:t>
-            </a:r>
-          </a:p>
-          <a:p>
-            <a:r>
-              <a:t>15 / 16</a:t>
+              <a:t>والخصوصية واإلتاحة المستفيد تجربة</a:t>
+            </a:r>
+          </a:p>
+          <a:p>
+            <a:r>
+              <a:t>وليلى ودانيال لجوزيف مص ّمم</a:t>
+            </a:r>
+          </a:p>
+          <a:p>
+            <a:r>
+              <a:t>.ُيكشف أن من خوف أو ،ضعيف اتصال أو ،لغة :حقيقي مستفيد وضع من جاء الواجهة يف قرار كل</a:t>
+            </a:r>
+          </a:p>
+          <a:p>
+            <a:r>
+              <a:t>واتجاهان لغات ثالث</a:t>
+            </a:r>
+          </a:p>
+          <a:p>
+            <a:r>
+              <a:t>من ،شاشة كل يف والتاغالوغية واإلنجلزيية العربية</a:t>
+            </a:r>
+          </a:p>
+          <a:p>
+            <a:r>
+              <a:t>مع يبقى العريب الرشعي والنص ،اليسار ومن اليمني</a:t>
+            </a:r>
+          </a:p>
+          <a:p>
+            <a:r>
+              <a:t>.معناه</a:t>
+            </a:r>
+          </a:p>
+          <a:p>
+            <a:r>
+              <a:t>اتصال دون يعمل</a:t>
+            </a:r>
+          </a:p>
+          <a:p>
+            <a:r>
+              <a:t>والمواقيت ،المسار من فتحه ما :زيارة أول بعد</a:t>
+            </a:r>
+          </a:p>
+          <a:p>
+            <a:r>
+              <a:t>معه يبقى ما فيه يختار تزنيالت ومركز .واألذكار والقبلة</a:t>
+            </a:r>
+          </a:p>
+          <a:p>
+            <a:r>
+              <a:t>.بحجمه</a:t>
+            </a:r>
+          </a:p>
+          <a:p>
+            <a:r>
+              <a:t>الباقة على خفيف</a:t>
+            </a:r>
+          </a:p>
+          <a:p>
+            <a:r>
+              <a:t>1 قرابة( فتح أول يف وحدها المتع ّلم واجهة</a:t>
+            </a:r>
+          </a:p>
+          <a:p>
+            <a:r>
+              <a:t>عند والفيديو والصوت ،)مضغوطة ميجابايت</a:t>
+            </a:r>
+          </a:p>
+          <a:p>
+            <a:r>
+              <a:t>.فقط التشغيل</a:t>
+            </a:r>
+          </a:p>
+          <a:p>
+            <a:r>
+              <a:t>الرسيع والخروج الخفي الوضع</a:t>
+            </a:r>
+          </a:p>
+          <a:p>
+            <a:r>
+              <a:t>اسم بال واإلشعارات »Notes« يصبح الصفحة عنوان</a:t>
+            </a:r>
+          </a:p>
+          <a:p>
+            <a:r>
+              <a:t>بيانات ومسح ،رسيع خروج وزر ،دينية كلمة وال رفيق</a:t>
+            </a:r>
+          </a:p>
+          <a:p>
+            <a:r>
+              <a:t>.الجهاز</a:t>
+            </a:r>
+          </a:p>
+          <a:p>
+            <a:r>
+              <a:t>البيانات من قدر أقل</a:t>
+            </a:r>
+          </a:p>
+          <a:p>
+            <a:r>
+              <a:t>مستعار اسم الحساب .للتع ّلم مطلوب حساب ال</a:t>
+            </a:r>
+          </a:p>
+          <a:p>
+            <a:r>
+              <a:t>.اختياري والربيد ،مرور وكلمة</a:t>
+            </a:r>
+          </a:p>
+          <a:p>
+            <a:r>
+              <a:t>الجهاز يغادر ال الموقع</a:t>
+            </a:r>
+          </a:p>
+          <a:p>
+            <a:r>
+              <a:t>،مدن قائمة من الجهاز على ُتحسب المواقيت</a:t>
+            </a:r>
+          </a:p>
+          <a:p>
+            <a:r>
+              <a:t>شاشة على ومحايدة ،يف ّعلها حىت مغلقة واإلشعارات</a:t>
+            </a:r>
+          </a:p>
+          <a:p>
+            <a:r>
+              <a:t>.القفل</a:t>
+            </a:r>
+          </a:p>
+          <a:p>
+            <a:r>
+              <a:t>15 / 19</a:t>
             </a:r>
           </a:p>
         </p:txBody>
@@ -1677,6 +1545,696 @@
           <a:lstStyle/>
           <a:p>
             <a:r>
+              <a:t>والبنية التقنيات</a:t>
+            </a:r>
+          </a:p>
+          <a:p>
+            <a:r>
+              <a:t>وصيانتها تشغيلها يمكن بسيطة بنية</a:t>
+            </a:r>
+          </a:p>
+          <a:p>
+            <a:r>
+              <a:t>.آيل وتراجع صحة فحص مع ،ُينرش ثم ب الختبارات يمر الرئ يس الفرع إىل دفع كل</a:t>
+            </a:r>
+          </a:p>
+          <a:p>
+            <a:r>
+              <a:t>الجوال</a:t>
+            </a:r>
+          </a:p>
+          <a:p>
+            <a:r>
+              <a:t>قابل ويب تطبيق</a:t>
+            </a:r>
+          </a:p>
+          <a:p>
+            <a:r>
+              <a:t>للتثبيت</a:t>
+            </a:r>
+          </a:p>
+          <a:p>
+            <a:r>
+              <a:t>و Vite و React</a:t>
+            </a:r>
+          </a:p>
+          <a:p>
+            <a:r>
+              <a:t>خدمة وعامل ،TypeScript</a:t>
+            </a:r>
+          </a:p>
+          <a:p>
+            <a:r>
+              <a:t>ونظام ،اتصال دون للعمل</a:t>
+            </a:r>
+          </a:p>
+          <a:p>
+            <a:r>
+              <a:t>إشعارات .مو ّحد تصميم</a:t>
+            </a:r>
+          </a:p>
+          <a:p>
+            <a:r>
+              <a:t>.Web Push</a:t>
+            </a:r>
+          </a:p>
+          <a:p>
+            <a:r>
+              <a:t>⇄</a:t>
+            </a:r>
+          </a:p>
+          <a:p>
+            <a:r>
+              <a:t>الخادم</a:t>
+            </a:r>
+          </a:p>
+          <a:p>
+            <a:r>
+              <a:t>FastAPI (Python)</a:t>
+            </a:r>
+          </a:p>
+          <a:p>
+            <a:r>
+              <a:t>،والتحقق السؤال مسار</a:t>
+            </a:r>
+          </a:p>
+          <a:p>
+            <a:r>
+              <a:t>،والمراجعة والمسار</a:t>
+            </a:r>
+          </a:p>
+          <a:p>
+            <a:r>
+              <a:t>النصوص وواجهة ،والمرافقة</a:t>
+            </a:r>
+          </a:p>
+          <a:p>
+            <a:r>
+              <a:t>مجدولة مهام .الرشعية</a:t>
+            </a:r>
+          </a:p>
+          <a:p>
+            <a:r>
+              <a:t>.للفهرسة</a:t>
+            </a:r>
+          </a:p>
+          <a:p>
+            <a:r>
+              <a:t>⇄</a:t>
+            </a:r>
+          </a:p>
+          <a:p>
+            <a:r>
+              <a:t>البيانات</a:t>
+            </a:r>
+          </a:p>
+          <a:p>
+            <a:r>
+              <a:t>PostgreSQL +</a:t>
+            </a:r>
+          </a:p>
+          <a:p>
+            <a:r>
+              <a:t>pgvector</a:t>
+            </a:r>
+          </a:p>
+          <a:p>
+            <a:r>
+              <a:t>ومتجهاتها المعتمدة المقاطع</a:t>
+            </a:r>
+          </a:p>
+          <a:p>
+            <a:r>
+              <a:t>،نيص وفهرس )ُبع ًدا 1024(</a:t>
+            </a:r>
+          </a:p>
+          <a:p>
+            <a:r>
+              <a:t>.نص دون التكلفة وسجل</a:t>
+            </a:r>
+          </a:p>
+          <a:p>
+            <a:r>
+              <a:t>⇄</a:t>
+            </a:r>
+          </a:p>
+          <a:p>
+            <a:r>
+              <a:t>النماذج</a:t>
+            </a:r>
+          </a:p>
+          <a:p>
+            <a:r>
+              <a:t>OpenRouter</a:t>
+            </a:r>
+          </a:p>
+          <a:p>
+            <a:r>
+              <a:t>للتأليف Gemma 4</a:t>
+            </a:r>
+          </a:p>
+          <a:p>
+            <a:r>
+              <a:t>و ،والفحص والتصنيف</a:t>
+            </a:r>
+          </a:p>
+          <a:p>
+            <a:r>
+              <a:t>و ،احتياط ًيا DeepSeek</a:t>
+            </a:r>
+          </a:p>
+          <a:p>
+            <a:r>
+              <a:t>.للمتجهات bge-m3</a:t>
+            </a:r>
+          </a:p>
+          <a:p>
+            <a:r>
+              <a:t>github.com/rafeeq-muslim/rafeeq :الكود .GitHub Actions من آيل ونرش ،واحد خادم على nginx خلف Docker حاويات :الستضافة</a:t>
+            </a:r>
+          </a:p>
+          <a:p>
+            <a:r>
+              <a:t>16 / 19</a:t>
+            </a:r>
+          </a:p>
+        </p:txBody>
+      </p:sp>
+      <p:sp>
+        <p:nvSpPr>
+          <p:cNvPr id="4" name="Slide Number Placeholder 3"/>
+          <p:cNvSpPr>
+            <a:spLocks noGrp="1"/>
+          </p:cNvSpPr>
+          <p:nvPr>
+            <p:ph type="sldNum" idx="5" sz="quarter"/>
+          </p:nvPr>
+        </p:nvSpPr>
+        <p:spPr/>
+      </p:sp>
+    </p:spTree>
+  </p:cSld>
+  <p:clrMapOvr>
+    <a:masterClrMapping/>
+  </p:clrMapOvr>
+</p:notes>
+</file>
+
+<file path=ppt/notesSlides/notesSlide17.xml><?xml version="1.0" encoding="utf-8"?>
+<p:notes xmlns:a="http://schemas.openxmlformats.org/drawingml/2006/main" xmlns:p="http://schemas.openxmlformats.org/presentationml/2006/main" xmlns:r="http://schemas.openxmlformats.org/officeDocument/2006/relationships">
+  <p:cSld>
+    <p:spTree>
+      <p:nvGrpSpPr>
+        <p:cNvPr id="1" name=""/>
+        <p:cNvGrpSpPr/>
+        <p:nvPr/>
+      </p:nvGrpSpPr>
+      <p:grpSpPr>
+        <a:xfrm>
+          <a:off x="0" y="0"/>
+          <a:ext cx="0" cy="0"/>
+          <a:chOff x="0" y="0"/>
+          <a:chExt cx="0" cy="0"/>
+        </a:xfrm>
+      </p:grpSpPr>
+      <p:sp>
+        <p:nvSpPr>
+          <p:cNvPr id="2" name="Slide Image Placeholder 1"/>
+          <p:cNvSpPr>
+            <a:spLocks noGrp="1"/>
+          </p:cNvSpPr>
+          <p:nvPr>
+            <p:ph type="sldImg" idx="2"/>
+          </p:nvPr>
+        </p:nvSpPr>
+        <p:spPr/>
+      </p:sp>
+      <p:sp>
+        <p:nvSpPr>
+          <p:cNvPr id="3" name="Notes Placeholder 2"/>
+          <p:cNvSpPr>
+            <a:spLocks noGrp="1"/>
+          </p:cNvSpPr>
+          <p:nvPr>
+            <p:ph type="body" idx="3" sz="quarter"/>
+          </p:nvPr>
+        </p:nvSpPr>
+        <p:spPr/>
+        <p:txBody>
+          <a:bodyPr/>
+          <a:lstStyle/>
+          <a:p>
+            <a:r>
+              <a:t>المضافة القيمة</a:t>
+            </a:r>
+          </a:p>
+          <a:p>
+            <a:r>
+              <a:t>البدائل؟ تق ّدمه وال رفيق يق ّدمه الذي ما</a:t>
+            </a:r>
+          </a:p>
+          <a:p>
+            <a:r>
+              <a:t>.لغات وعدة البرشي والمرشد المو ّثق والمساعد التع ّلمي المسار يجمع منت ًجا نجد لم ،تطبيقات 9و برنام ًجا 14 شمل مسح يف</a:t>
+            </a:r>
+          </a:p>
+          <a:p>
+            <a:r>
+              <a:t>عامة اصطناعي ذكاء محادثة</a:t>
+            </a:r>
+          </a:p>
+          <a:p>
+            <a:r>
+              <a:t>ثابتة ومواقع PDF كتيبات</a:t>
+            </a:r>
+          </a:p>
+          <a:p>
+            <a:r>
+              <a:t>التواصل وسائل</a:t>
+            </a:r>
+          </a:p>
+          <a:p>
+            <a:r>
+              <a:t>رفيق</a:t>
+            </a:r>
+          </a:p>
+          <a:p>
+            <a:r>
+              <a:t>المصدر</a:t>
+            </a:r>
+          </a:p>
+          <a:p>
+            <a:r>
+              <a:t>ن ًص ا يخرتع وقد ،معروف غري</a:t>
+            </a:r>
+          </a:p>
+          <a:p>
+            <a:r>
+              <a:t>موثوق</a:t>
+            </a:r>
+          </a:p>
+          <a:p>
+            <a:r>
+              <a:t>متضارب</a:t>
+            </a:r>
+          </a:p>
+          <a:p>
+            <a:r>
+              <a:t>البيانات قاعدة من والنص ،معتمدة مصادر</a:t>
+            </a:r>
+          </a:p>
+          <a:p>
+            <a:r>
+              <a:t>التد ّرج</a:t>
+            </a:r>
+          </a:p>
+          <a:p>
+            <a:r>
+              <a:t>يوجد ال</a:t>
+            </a:r>
+          </a:p>
+          <a:p>
+            <a:r>
+              <a:t>للجميع واحد كتاب</a:t>
+            </a:r>
+          </a:p>
+          <a:p>
+            <a:r>
+              <a:t>يوجد ال</a:t>
+            </a:r>
+          </a:p>
+          <a:p>
+            <a:r>
+              <a:t>اإلتقان بحسب ومراجعة مسار</a:t>
+            </a:r>
+          </a:p>
+          <a:p>
+            <a:r>
+              <a:t>لغته</a:t>
+            </a:r>
+          </a:p>
+          <a:p>
+            <a:r>
+              <a:t>ضمان دون ،نعم</a:t>
+            </a:r>
+          </a:p>
+          <a:p>
+            <a:r>
+              <a:t>بالتاغالوغية وقليل ،محدود</a:t>
+            </a:r>
+          </a:p>
+          <a:p>
+            <a:r>
+              <a:t>متفاوت</a:t>
+            </a:r>
+          </a:p>
+          <a:p>
+            <a:r>
+              <a:t>معتمدة بمصطلحات لغات ثالث</a:t>
+            </a:r>
+          </a:p>
+          <a:p>
+            <a:r>
+              <a:t>اإلنسان</a:t>
+            </a:r>
+          </a:p>
+          <a:p>
+            <a:r>
+              <a:t>ال</a:t>
+            </a:r>
+          </a:p>
+          <a:p>
+            <a:r>
+              <a:t>ال</a:t>
+            </a:r>
+          </a:p>
+          <a:p>
+            <a:r>
+              <a:t>غرباء</a:t>
+            </a:r>
+          </a:p>
+          <a:p>
+            <a:r>
+              <a:t>الخطر يف وإحالة ،وبلغته جنسه من مرشد</a:t>
+            </a:r>
+          </a:p>
+          <a:p>
+            <a:r>
+              <a:t>الخصوصية</a:t>
+            </a:r>
+          </a:p>
+          <a:p>
+            <a:r>
+              <a:t>ُتحفظ المحادثة</a:t>
+            </a:r>
+          </a:p>
+          <a:p>
+            <a:r>
+              <a:t>جيدة</a:t>
+            </a:r>
+          </a:p>
+          <a:p>
+            <a:r>
+              <a:t>مكشوفة</a:t>
+            </a:r>
+          </a:p>
+          <a:p>
+            <a:r>
+              <a:t>النموذج طلبات يف هوية وال ،خفي وضع</a:t>
+            </a:r>
+          </a:p>
+          <a:p>
+            <a:r>
+              <a:t>.)مكتيب بحث ،2026 أكتوبر ،السوق قسم( docs/agents/evidence.md :المسح</a:t>
+            </a:r>
+          </a:p>
+          <a:p>
+            <a:r>
+              <a:t>17 / 19</a:t>
+            </a:r>
+          </a:p>
+        </p:txBody>
+      </p:sp>
+      <p:sp>
+        <p:nvSpPr>
+          <p:cNvPr id="4" name="Slide Number Placeholder 3"/>
+          <p:cNvSpPr>
+            <a:spLocks noGrp="1"/>
+          </p:cNvSpPr>
+          <p:nvPr>
+            <p:ph type="sldNum" idx="5" sz="quarter"/>
+          </p:nvPr>
+        </p:nvSpPr>
+        <p:spPr/>
+      </p:sp>
+    </p:spTree>
+  </p:cSld>
+  <p:clrMapOvr>
+    <a:masterClrMapping/>
+  </p:clrMapOvr>
+</p:notes>
+</file>
+
+<file path=ppt/notesSlides/notesSlide18.xml><?xml version="1.0" encoding="utf-8"?>
+<p:notes xmlns:a="http://schemas.openxmlformats.org/drawingml/2006/main" xmlns:p="http://schemas.openxmlformats.org/presentationml/2006/main" xmlns:r="http://schemas.openxmlformats.org/officeDocument/2006/relationships">
+  <p:cSld>
+    <p:spTree>
+      <p:nvGrpSpPr>
+        <p:cNvPr id="1" name=""/>
+        <p:cNvGrpSpPr/>
+        <p:nvPr/>
+      </p:nvGrpSpPr>
+      <p:grpSpPr>
+        <a:xfrm>
+          <a:off x="0" y="0"/>
+          <a:ext cx="0" cy="0"/>
+          <a:chOff x="0" y="0"/>
+          <a:chExt cx="0" cy="0"/>
+        </a:xfrm>
+      </p:grpSpPr>
+      <p:sp>
+        <p:nvSpPr>
+          <p:cNvPr id="2" name="Slide Image Placeholder 1"/>
+          <p:cNvSpPr>
+            <a:spLocks noGrp="1"/>
+          </p:cNvSpPr>
+          <p:nvPr>
+            <p:ph type="sldImg" idx="2"/>
+          </p:nvPr>
+        </p:nvSpPr>
+        <p:spPr/>
+      </p:sp>
+      <p:sp>
+        <p:nvSpPr>
+          <p:cNvPr id="3" name="Notes Placeholder 2"/>
+          <p:cNvSpPr>
+            <a:spLocks noGrp="1"/>
+          </p:cNvSpPr>
+          <p:nvPr>
+            <p:ph type="body" idx="3" sz="quarter"/>
+          </p:nvPr>
+        </p:nvSpPr>
+        <p:spPr/>
+        <p:txBody>
+          <a:bodyPr/>
+          <a:lstStyle/>
+          <a:p>
+            <a:r>
+              <a:t>الستمرار وخطة التشغيل واقعية</a:t>
+            </a:r>
+          </a:p>
+          <a:p>
+            <a:r>
+              <a:t>ليستمر ومه ّيأ ،اليوم يعمل</a:t>
+            </a:r>
+          </a:p>
+          <a:p>
+            <a:r>
+              <a:t>.المسؤوليات وواضح الكلفة قليل وتشغيله ،اآلن المستخدمني ويخدم منشور رفيق</a:t>
+            </a:r>
+          </a:p>
+          <a:p>
+            <a:r>
+              <a:t>تشغيل</a:t>
+            </a:r>
+          </a:p>
+          <a:p>
+            <a:r>
+              <a:t>آيل ونرش واحد خادم</a:t>
+            </a:r>
+          </a:p>
+          <a:p>
+            <a:r>
+              <a:t>مع ،تلقائ ًيا ُينرش ثم ب الختبارات يمر تحديث كل</a:t>
+            </a:r>
+          </a:p>
+          <a:p>
+            <a:r>
+              <a:t>.يشء اختل إن آيل وتراجع صحة فحص</a:t>
+            </a:r>
+          </a:p>
+          <a:p>
+            <a:r>
+              <a:t>تكلفة</a:t>
+            </a:r>
+          </a:p>
+          <a:p>
+            <a:r>
+              <a:t>لإلجابة سنت من أقل</a:t>
+            </a:r>
+          </a:p>
+          <a:p>
+            <a:r>
+              <a:t>إنفاق سقف مع ،المجاب للسؤال 0.0015$ قرابة</a:t>
+            </a:r>
+          </a:p>
+          <a:p>
+            <a:r>
+              <a:t>يضمن احتياطي ونموذج ،المزيانية يضبط وكلي يومي</a:t>
+            </a:r>
+          </a:p>
+          <a:p>
+            <a:r>
+              <a:t>.الستمرار</a:t>
+            </a:r>
+          </a:p>
+          <a:p>
+            <a:r>
+              <a:t>محتوى</a:t>
+            </a:r>
+          </a:p>
+          <a:p>
+            <a:r>
+              <a:t>المنتج داخل رشعية مراجعة</a:t>
+            </a:r>
+          </a:p>
+          <a:p>
+            <a:r>
+              <a:t>أي ويسحب المحتوى يعتمد الرشعي المراجع مكتب</a:t>
+            </a:r>
+          </a:p>
+          <a:p>
+            <a:r>
+              <a:t>سجل يف مو ّثقة مر ّخصة ومصادر ،بضغطة نسخة</a:t>
+            </a:r>
+          </a:p>
+          <a:p>
+            <a:r>
+              <a:t>.واحد</a:t>
+            </a:r>
+          </a:p>
+          <a:p>
+            <a:r>
+              <a:t>انتشار</a:t>
+            </a:r>
+          </a:p>
+          <a:p>
+            <a:r>
+              <a:t>الدعوية الجهات عرب</a:t>
+            </a:r>
+          </a:p>
+          <a:p>
+            <a:r>
+              <a:t>ويرى ،مرشديه ويدير ،برمز ينضم دعوي مكتب كل</a:t>
+            </a:r>
+          </a:p>
+          <a:p>
+            <a:r>
+              <a:t>.مج ّمعة لوحة يف أثره</a:t>
+            </a:r>
+          </a:p>
+          <a:p>
+            <a:r>
+              <a:t>تو ّس ع</a:t>
+            </a:r>
+          </a:p>
+          <a:p>
+            <a:r>
+              <a:t>نفسها بالبنية جديدة لغات</a:t>
+            </a:r>
+          </a:p>
+          <a:p>
+            <a:r>
+              <a:t>لغة وإضافة ،اللغات عرشات تتيح المعتمدة المصادر</a:t>
+            </a:r>
+          </a:p>
+          <a:p>
+            <a:r>
+              <a:t>.المنتج تغيري تحتاج ال</a:t>
+            </a:r>
+          </a:p>
+          <a:p>
+            <a:r>
+              <a:t>انفتاح</a:t>
+            </a:r>
+          </a:p>
+          <a:p>
+            <a:r>
+              <a:t>ومو ّثق من ّظ م كود</a:t>
+            </a:r>
+          </a:p>
+          <a:p>
+            <a:r>
+              <a:t>يف كلها والتشغيل والمصادر والقواعد المزيات وثائق</a:t>
+            </a:r>
+          </a:p>
+          <a:p>
+            <a:r>
+              <a:t>.تشغيله يستطيع فريق وأي ،المستودع</a:t>
+            </a:r>
+          </a:p>
+          <a:p>
+            <a:r>
+              <a:t>18 / 19</a:t>
+            </a:r>
+          </a:p>
+        </p:txBody>
+      </p:sp>
+      <p:sp>
+        <p:nvSpPr>
+          <p:cNvPr id="4" name="Slide Number Placeholder 3"/>
+          <p:cNvSpPr>
+            <a:spLocks noGrp="1"/>
+          </p:cNvSpPr>
+          <p:nvPr>
+            <p:ph type="sldNum" idx="5" sz="quarter"/>
+          </p:nvPr>
+        </p:nvSpPr>
+        <p:spPr/>
+      </p:sp>
+    </p:spTree>
+  </p:cSld>
+  <p:clrMapOvr>
+    <a:masterClrMapping/>
+  </p:clrMapOvr>
+</p:notes>
+</file>
+
+<file path=ppt/notesSlides/notesSlide19.xml><?xml version="1.0" encoding="utf-8"?>
+<p:notes xmlns:a="http://schemas.openxmlformats.org/drawingml/2006/main" xmlns:p="http://schemas.openxmlformats.org/presentationml/2006/main" xmlns:r="http://schemas.openxmlformats.org/officeDocument/2006/relationships">
+  <p:cSld>
+    <p:spTree>
+      <p:nvGrpSpPr>
+        <p:cNvPr id="1" name=""/>
+        <p:cNvGrpSpPr/>
+        <p:nvPr/>
+      </p:nvGrpSpPr>
+      <p:grpSpPr>
+        <a:xfrm>
+          <a:off x="0" y="0"/>
+          <a:ext cx="0" cy="0"/>
+          <a:chOff x="0" y="0"/>
+          <a:chExt cx="0" cy="0"/>
+        </a:xfrm>
+      </p:grpSpPr>
+      <p:sp>
+        <p:nvSpPr>
+          <p:cNvPr id="2" name="Slide Image Placeholder 1"/>
+          <p:cNvSpPr>
+            <a:spLocks noGrp="1"/>
+          </p:cNvSpPr>
+          <p:nvPr>
+            <p:ph type="sldImg" idx="2"/>
+          </p:nvPr>
+        </p:nvSpPr>
+        <p:spPr/>
+      </p:sp>
+      <p:sp>
+        <p:nvSpPr>
+          <p:cNvPr id="3" name="Notes Placeholder 2"/>
+          <p:cNvSpPr>
+            <a:spLocks noGrp="1"/>
+          </p:cNvSpPr>
+          <p:nvPr>
+            <p:ph type="body" idx="3" sz="quarter"/>
+          </p:nvPr>
+        </p:nvSpPr>
+        <p:spPr/>
+        <p:txBody>
+          <a:bodyPr/>
+          <a:lstStyle/>
+          <a:p>
+            <a:r>
               <a:t>الفريق</a:t>
             </a:r>
           </a:p>
@@ -1743,6 +2301,16 @@
           <a:p>
             <a:r>
               <a:t>rafeeq.nan.sa/app</a:t>
+            </a:r>
+          </a:p>
+          <a:p>
+            <a:r>
+              <a:t>الفيديو</a:t>
+            </a:r>
+          </a:p>
+          <a:p>
+            <a:r>
+              <a:t>youtube.com/shorts/NN3KVPgEf-4</a:t>
             </a:r>
           </a:p>
           <a:p>
@@ -1942,12 +2510,12 @@
           </a:p>
           <a:p>
             <a:r>
-              <a:t>docs/agents/evidence.md يف التفاصيل .البحث على مبنية مسودات الشخصيات .)صغرية عينة ،2015( الغرب يف جدي ًدا مسل ًما 114 على أصول مركز استبانة ؛)2024 يناير ،واس عرب( اإلسالمية الشؤون وزارة :المصادر</a:t>
-            </a:r>
-          </a:p>
-          <a:p>
-            <a:r>
-              <a:t>02 / 16</a:t>
+              <a:t>.)2015( الغرب يف جدي ًدا مسل ًما 114 على أصول مركز استبانة ؛)2024 يناير ،واس عرب( اإلسالمية الشؤون وزارة :المصادر</a:t>
+            </a:r>
+          </a:p>
+          <a:p>
+            <a:r>
+              <a:t>02 / 19</a:t>
             </a:r>
           </a:p>
         </p:txBody>
@@ -2122,12 +2690,7 @@
           </a:p>
           <a:p>
             <a:r>
-              <a:t>.الحقيقي الستخدام وتنتظر التطبيق يف مبنية المؤرشات بعد؛ َُيج لم الجدد المسلمني مع الميداين الختبار</a:t>
-            </a:r>
-          </a:p>
-          <a:p>
-            <a:r>
-              <a:t>03 / 16</a:t>
+              <a:t>03 / 19</a:t>
             </a:r>
           </a:p>
         </p:txBody>
@@ -2292,7 +2855,7 @@
           </a:p>
           <a:p>
             <a:r>
-              <a:t>04 / 16</a:t>
+              <a:t>04 / 19</a:t>
             </a:r>
           </a:p>
         </p:txBody>
@@ -2567,7 +3130,7 @@
           </a:p>
           <a:p>
             <a:r>
-              <a:t>05 / 16</a:t>
+              <a:t>05 / 19</a:t>
             </a:r>
           </a:p>
         </p:txBody>
@@ -2637,157 +3200,142 @@
           <a:lstStyle/>
           <a:p>
             <a:r>
-              <a:t>)2 من 1( الصطناعي الذكاء</a:t>
-            </a:r>
-          </a:p>
-          <a:p>
-            <a:r>
-              <a:t>المصادر يف بما إال يجيب ال :»رفيق اسأل«</a:t>
-            </a:r>
-          </a:p>
-          <a:p>
-            <a:r>
-              <a:t>.ثانية 45و خارجية طلبات 8 :سؤال كل سقف .اإلجابة إيقاف تستطيع مرحلة وكل ،سؤال لكل مراحل ست</a:t>
-            </a:r>
-          </a:p>
-          <a:p>
-            <a:r>
-              <a:t>المرحلة</a:t>
-            </a:r>
-          </a:p>
-          <a:p>
-            <a:r>
-              <a:t>النموذج</a:t>
-            </a:r>
-          </a:p>
-          <a:p>
-            <a:r>
-              <a:t>تفعله ما</a:t>
-            </a:r>
-          </a:p>
-          <a:p>
-            <a:r>
-              <a:t>رفضت أو فشلت إذا</a:t>
-            </a:r>
-          </a:p>
-          <a:p>
-            <a:r>
-              <a:t>الخطر فحص .1نموذج باللأو اً تعمل ،لغات بثالث معتمدة خطر عبارات</a:t>
-            </a:r>
-          </a:p>
-          <a:p>
-            <a:r>
-              <a:t>اتصال أي دون ،إنسان إىل فورية وإحالة ثابت رد</a:t>
-            </a:r>
-          </a:p>
-          <a:p>
-            <a:r>
-              <a:t>بالشبكة</a:t>
-            </a:r>
-          </a:p>
-          <a:p>
-            <a:r>
-              <a:t>المو ّجه .2رسيع</a:t>
-            </a:r>
-          </a:p>
-          <a:p>
-            <a:r>
-              <a:t>ودرجته …تجاوز محاولة ،النطاق خارج ،خطر ،شخيص ،خاليف ،عام :السؤال يص ّنف</a:t>
-            </a:r>
-          </a:p>
-          <a:p>
-            <a:r>
-              <a:t>D إىل A من</a:t>
-            </a:r>
-          </a:p>
-          <a:p>
-            <a:r>
-              <a:t>إنسان إىل والخطر ،مرشد إىل ُيحال الشخيص</a:t>
-            </a:r>
-          </a:p>
-          <a:p>
-            <a:r>
-              <a:t>السرتجاع .3</a:t>
-            </a:r>
-          </a:p>
-          <a:p>
-            <a:r>
-              <a:t>bge-m3مقاطع 8 حىت ،السائل بلغة المعتمدة المصادر يف م ًعا ونيص داليل بحث</a:t>
-            </a:r>
-          </a:p>
-          <a:p>
-            <a:r>
-              <a:t>ذلك و ُيع َلن بالنيص يكمل الداليل البحث تعطل إن</a:t>
-            </a:r>
-          </a:p>
-          <a:p>
-            <a:r>
-              <a:t>المؤلف .4رئ يس</a:t>
-            </a:r>
-          </a:p>
-          <a:p>
-            <a:r>
-              <a:t>كتابة بدل حديث أو آية كل مكان عالمة ويضع ،وحدها المقاطع من اإلجابة يكتب</a:t>
-            </a:r>
-          </a:p>
-          <a:p>
-            <a:r>
-              <a:t>نصه</a:t>
-            </a:r>
-          </a:p>
-          <a:p>
-            <a:r>
-              <a:t>مرشد مع التواصل واقرتاح اعتذار ← »يكفي ال«</a:t>
-            </a:r>
-          </a:p>
-          <a:p>
-            <a:r>
-              <a:t>المدقق .5رسيع + كود</a:t>
-            </a:r>
-          </a:p>
-          <a:p>
-            <a:r>
-              <a:t>كل دعم فحص ثم )…اللغة ،منسوخ نص ال ، لفع اً مسرتجعة المراجع( آلية فحوص 7</a:t>
-            </a:r>
-          </a:p>
-          <a:p>
-            <a:r>
-              <a:t>بالمصدر جملة</a:t>
-            </a:r>
-          </a:p>
-          <a:p>
-            <a:r>
-              <a:t>تظهر ال وإال ،جديد من كامل فحص ثم واحد إصالح</a:t>
-            </a:r>
-          </a:p>
-          <a:p>
-            <a:r>
-              <a:t>اإلجابة</a:t>
-            </a:r>
-          </a:p>
-          <a:p>
-            <a:r>
-              <a:t>العرض .6</a:t>
-            </a:r>
-          </a:p>
-          <a:p>
-            <a:r>
-              <a:t>—المصدر بطاقة مع ،بمع ّرفه البيانات قاعدة من ُيعرض والحديث اآلية نص</a:t>
-            </a:r>
-          </a:p>
-          <a:p>
-            <a:r>
-              <a:t>اإلجابة ُتعرض ال العرض قبل المصدر ُحذف إن</a:t>
-            </a:r>
-          </a:p>
-          <a:p>
-            <a:r>
-              <a:t>docs/engineering/ai-agents.md :المصدر .بالطلبات يحتفظون ال ومز ّودون ،0 حرارة .deepseek-v4-pro و الحتياطي ،gemma-4-26b-a4b-it والرسيع ،gemma-4-31b-it الرئ يس :OpenRouter عرب النماذج</a:t>
-            </a:r>
-          </a:p>
-          <a:p>
-            <a:r>
-              <a:t>06 / 16</a:t>
+              <a:t>)3 من 1( رفيق يف ما</a:t>
+            </a:r>
+          </a:p>
+          <a:p>
+            <a:r>
+              <a:t>واحد مكان يف ويسأل يتع ّلم</a:t>
+            </a:r>
+          </a:p>
+          <a:p>
+            <a:r>
+              <a:t>.إجابة كل مصدر ويعرض المعتمدة المصادر من يجيبه ومساعد ،المتع ّلم وصل أين يعرف متد ّرج مسار</a:t>
+            </a:r>
+          </a:p>
+          <a:p>
+            <a:r>
+              <a:t>التع ّلمي المسار</a:t>
+            </a:r>
+          </a:p>
+          <a:p>
+            <a:r>
+              <a:t>والصالة والطهارة الشهادتني من تبدأ قصرية ودروس وحدات</a:t>
+            </a:r>
+          </a:p>
+          <a:p>
+            <a:r>
+              <a:t>بطاقات مجموعة كل بعد التفاعلية التمارين من أنواع ثالثة</a:t>
+            </a:r>
+          </a:p>
+          <a:p>
+            <a:r>
+              <a:t>الح ًقا السؤال يعود ثم ،وسببه الصواب يرى :آمن الخطأ</a:t>
+            </a:r>
+          </a:p>
+          <a:p>
+            <a:r>
+              <a:t>المناسبة الوحدة يف يضعه اختياري مستوى تحديد اختبار</a:t>
+            </a:r>
+          </a:p>
+          <a:p>
+            <a:r>
+              <a:t>متباعدة فرتات على ،بعد يتقنه لم ما مع تتك ّيف مراجعة</a:t>
+            </a:r>
+          </a:p>
+          <a:p>
+            <a:r>
+              <a:t>نفسه الدرس</a:t>
+            </a:r>
+          </a:p>
+          <a:p>
+            <a:r>
+              <a:t>وتالوتها بلغته معناها ومعها المصحف بخط كاملة آيات بطاقات</a:t>
+            </a:r>
+          </a:p>
+          <a:p>
+            <a:r>
+              <a:t>المعتمدة البطاقة نص من الخطأ لسبب بلغته رشح :»لماذا؟«</a:t>
+            </a:r>
+          </a:p>
+          <a:p>
+            <a:r>
+              <a:t>التالية وخطوته أتقنه بما درس كل بعد يخربه تعليمي مو ّجه</a:t>
+            </a:r>
+          </a:p>
+          <a:p>
+            <a:r>
+              <a:t>والصالة الوضوء لخطوات وصور فيديو</a:t>
+            </a:r>
+          </a:p>
+          <a:p>
+            <a:r>
+              <a:t>يومه يف يحتاجه ما ثم ، لأو اً التالية الخطوة :مر ّتبة رئيسية</a:t>
+            </a:r>
+          </a:p>
+          <a:p>
+            <a:r>
+              <a:t>»رفيق اسأل«</a:t>
+            </a:r>
+          </a:p>
+          <a:p>
+            <a:r>
+              <a:t>مصادرها بطاقات إجابة كل ومع ،وحدها المعتمدة المصادر من إجابة</a:t>
+            </a:r>
+          </a:p>
+          <a:p>
+            <a:r>
+              <a:t>السؤال يحتاج حني المعتمدة الفتوى مواقع يف حي بحث</a:t>
+            </a:r>
+          </a:p>
+          <a:p>
+            <a:r>
+              <a:t>الشائعة لألسئلة الرشعي المراجع اعتمدها جاهزة إجابات</a:t>
+            </a:r>
+          </a:p>
+          <a:p>
+            <a:r>
+              <a:t>بإنسان ويصله الطوارئ أرقام فيعرض ، لأو اً ُيكتشف الخطر</a:t>
+            </a:r>
+          </a:p>
+          <a:p>
+            <a:r>
+              <a:t>اتصال دون إليها للرجوع واألحاديث واآليات اإلجابات حفظ</a:t>
+            </a:r>
+          </a:p>
+          <a:p>
+            <a:r>
+              <a:t>المعرفة</a:t>
+            </a:r>
+          </a:p>
+          <a:p>
+            <a:r>
+              <a:t>حي بحث مع ،الجديد للمسلم معتمدة ومقاطع كتب من مكتبة</a:t>
+            </a:r>
+          </a:p>
+          <a:p>
+            <a:r>
+              <a:t>المتل ّوة اآلية إبراز مع ًآي ًآي ،ق ّراء بعدة القرآن إىل الستماع</a:t>
+            </a:r>
+          </a:p>
+          <a:p>
+            <a:r>
+              <a:t>منها التالوة يبدأ آية أي على الضغط</a:t>
+            </a:r>
+          </a:p>
+          <a:p>
+            <a:r>
+              <a:t>بمعناه قصري حديث أو آية :اليوم بطاقة</a:t>
+            </a:r>
+          </a:p>
+          <a:p>
+            <a:r>
+              <a:t>مصدره ومعه ،دائ ًما البيانات قاعدة من الرشعي النص</a:t>
+            </a:r>
+          </a:p>
+          <a:p>
+            <a:r>
+              <a:t>06 / 19</a:t>
             </a:r>
           </a:p>
         </p:txBody>
@@ -2857,92 +3405,147 @@
           <a:lstStyle/>
           <a:p>
             <a:r>
-              <a:t>)2 من 2( الصطناعي الذكاء</a:t>
-            </a:r>
-          </a:p>
-          <a:p>
-            <a:r>
-              <a:t>التع ّلم خدمة يف الصطناعي الذكاء</a:t>
-            </a:r>
-          </a:p>
-          <a:p>
-            <a:r>
-              <a:t>.ثابت نص إىل رفيق يعود فشلت وإن ،وفاحص محدود مدخل منها لكل ،محددة صغرية مهام</a:t>
-            </a:r>
-          </a:p>
-          <a:p>
-            <a:r>
-              <a:t>الخطأ رشح »لماذا؟«</a:t>
-            </a:r>
-          </a:p>
-          <a:p>
-            <a:r>
-              <a:t>على كلمة 60 يف رش ًحا يكتب .المتع ّلم وإجابة والتمرين المعتمدة البطاقة :المدخل</a:t>
-            </a:r>
-          </a:p>
-          <a:p>
-            <a:r>
-              <a:t>.يشء يظهر ال فشل إن .ٍثا نموذج يفحصه ثم ،األكرث</a:t>
-            </a:r>
-          </a:p>
-          <a:p>
-            <a:r>
-              <a:t>التعليمي المو ّجه</a:t>
-            </a:r>
-          </a:p>
-          <a:p>
-            <a:r>
-              <a:t>من فيه اسم وكل ،جمل 3 يف اآلن يتع ّلمه ما يقرتح ،هوية يحمل ال تع ّلم مل ّخص من</a:t>
-            </a:r>
-          </a:p>
-          <a:p>
-            <a:r>
-              <a:t>.ُيحفظ ال المل ّخص .المل ّخص</a:t>
-            </a:r>
-          </a:p>
-          <a:p>
-            <a:r>
-              <a:t>الرئيسية ترتيب</a:t>
-            </a:r>
-          </a:p>
-          <a:p>
-            <a:r>
-              <a:t>تبقى التالية الخطوة .اليوم يف مرة ،والتق ّدم اليوم وقت بحسب الرئيسية مك ّونات ير ّتب</a:t>
-            </a:r>
-          </a:p>
-          <a:p>
-            <a:r>
-              <a:t>.ثابت ترتيب الفشل وعند ،دائ ًما لأو اً</a:t>
-            </a:r>
-          </a:p>
-          <a:p>
-            <a:r>
-              <a:t>تع ّلمي بهدف السؤال ربط</a:t>
-            </a:r>
-          </a:p>
-          <a:p>
-            <a:r>
-              <a:t>الدرس فيقرتح ،معتمدة قائمة من بهدف المجاب سؤاله يربط :فقط المتع ّلم بإذن</a:t>
-            </a:r>
-          </a:p>
-          <a:p>
-            <a:r>
-              <a:t>.وحده المع ّرف ُيرسل .المناسب</a:t>
-            </a:r>
-          </a:p>
-          <a:p>
-            <a:r>
-              <a:t>المراجعة · ثاب ًتا ر ًدا ويعرض الطلبات يوقف وكلي يومي إنفاق سقف · تعليمات ال بيانات ُيعامل المستخدم نص · طلب أي يف سجل وال مع ّرف وال اسم يدخل ال :مشرتكة ضوابط</a:t>
-            </a:r>
-          </a:p>
-          <a:p>
-            <a:r>
-              <a:t>.لغوي نموذج ال ،مكتوبة خوارزمية التك ّيفية</a:t>
-            </a:r>
-          </a:p>
-          <a:p>
-            <a:r>
-              <a:t>07 / 16</a:t>
+              <a:t>)3 من 2( رفيق يف ما</a:t>
+            </a:r>
+          </a:p>
+          <a:p>
+            <a:r>
+              <a:t>ليومه وأدوات ،يرافقه إنسان</a:t>
+            </a:r>
+          </a:p>
+          <a:p>
+            <a:r>
+              <a:t>.خصوصيته ويحفظ ،اليومية عبادته على ويعينه ،بمرشد يصله :شاشة مع الجديد المسلم يرتك ال رفيق</a:t>
+            </a:r>
+          </a:p>
+          <a:p>
+            <a:r>
+              <a:t>البرشية المرافقة</a:t>
+            </a:r>
+          </a:p>
+          <a:p>
+            <a:r>
+              <a:t>جنسه من مرشد إىل الطلب ويصل ،شاشة كل يف »إنسا ًنا أريد«</a:t>
+            </a:r>
+          </a:p>
+          <a:p>
+            <a:r>
+              <a:t>بلغته صغرية ومجموعات ،بنفسه يختاره مرشد</a:t>
+            </a:r>
+          </a:p>
+          <a:p>
+            <a:r>
+              <a:t>الفريق يتابعه بالغات وطابور ،وحظر تبليغ</a:t>
+            </a:r>
+          </a:p>
+          <a:p>
+            <a:r>
+              <a:t>العلم أهل إىل الشخصية المسألة إحالة</a:t>
+            </a:r>
+          </a:p>
+          <a:p>
+            <a:r>
+              <a:t>اتصال دون حىت حارضة الرسمية الطوارئ أرقام</a:t>
+            </a:r>
+          </a:p>
+          <a:p>
+            <a:r>
+              <a:t>غريه يراه ال خاص دفرت</a:t>
+            </a:r>
+          </a:p>
+          <a:p>
+            <a:r>
+              <a:t>اليومية الممارسة</a:t>
+            </a:r>
+          </a:p>
+          <a:p>
+            <a:r>
+              <a:t>يغادره ال والموقع ،الجهاز على ُتحسب الصالة مواقيت</a:t>
+            </a:r>
+          </a:p>
+          <a:p>
+            <a:r>
+              <a:t>بالبوصلة ح ّية قبلة</a:t>
+            </a:r>
+          </a:p>
+          <a:p>
+            <a:r>
+              <a:t>الوقت بحسب ،والنوم الصالة وبعد والمساء الصباح أذكار</a:t>
+            </a:r>
+          </a:p>
+          <a:p>
+            <a:r>
+              <a:t>والمناسبات رمضان ووضع ،الهجري التاريخ</a:t>
+            </a:r>
+          </a:p>
+          <a:p>
+            <a:r>
+              <a:t>العبادة على نقاط دون ،لنفسه يتابعها عادات</a:t>
+            </a:r>
+          </a:p>
+          <a:p>
+            <a:r>
+              <a:t>التحفزي</a:t>
+            </a:r>
+          </a:p>
+          <a:p>
+            <a:r>
+              <a:t>النقطاع عند لوم بال ،وسلسلتها التع ّلم أيام</a:t>
+            </a:r>
+          </a:p>
+          <a:p>
+            <a:r>
+              <a:t>وحده التع ّلم على أوسمة</a:t>
+            </a:r>
+          </a:p>
+          <a:p>
+            <a:r>
+              <a:t>يختاره الذي الوقت يف محايد بنص لطيف تذكري</a:t>
+            </a:r>
+          </a:p>
+          <a:p>
+            <a:r>
+              <a:t>المجموعة داخل جماعية تع ّلم تحديات</a:t>
+            </a:r>
+          </a:p>
+          <a:p>
+            <a:r>
+              <a:t>المنصة</a:t>
+            </a:r>
+          </a:p>
+          <a:p>
+            <a:r>
+              <a:t>شاشة كل يف والتاغالوغية واإلنجلزيية العربية</a:t>
+            </a:r>
+          </a:p>
+          <a:p>
+            <a:r>
+              <a:t>مرور وكلمة مستعار اسم والحساب ،حساب دون يعمل</a:t>
+            </a:r>
+          </a:p>
+          <a:p>
+            <a:r>
+              <a:t>باألحجام تزنيالت مركز وفيه ،اتصال دون ويفتح ،تطبي ًقا ُيث َّبت</a:t>
+            </a:r>
+          </a:p>
+          <a:p>
+            <a:r>
+              <a:t>واألندرويد اآليفون على تصل إشعارات</a:t>
+            </a:r>
+          </a:p>
+          <a:p>
+            <a:r>
+              <a:t>الجهاز ومسح ،البيانات من ونسخة ،خفي ووضع ،رسيع خروج</a:t>
+            </a:r>
+          </a:p>
+          <a:p>
+            <a:r>
+              <a:t>وداكن فاتح مظهر</a:t>
+            </a:r>
+          </a:p>
+          <a:p>
+            <a:r>
+              <a:t>07 / 19</a:t>
             </a:r>
           </a:p>
         </p:txBody>
@@ -3012,122 +3615,117 @@
           <a:lstStyle/>
           <a:p>
             <a:r>
-              <a:t>العلمية والسالمة الموثوقية</a:t>
-            </a:r>
-          </a:p>
-          <a:p>
-            <a:r>
-              <a:t>يحيل؟ أو يمتنع ومىت ،رفيق يجيب مىت</a:t>
-            </a:r>
-          </a:p>
-          <a:p>
-            <a:r>
-              <a:t>.خالفية مسألة يف ير ّجح وال ،شخصية حالة يف يفيت وال ،عنده من حدي ًثا وال آية يكتب ال النموذج</a:t>
-            </a:r>
-          </a:p>
-          <a:p>
-            <a:r>
-              <a:t>اإلجابات يف المعتمدة المصادر</a:t>
-            </a:r>
-          </a:p>
-          <a:p>
-            <a:r>
-              <a:t>المعتمدة وترجماته القرآن نص :QuranEnc</a:t>
-            </a:r>
-          </a:p>
-          <a:p>
-            <a:r>
-              <a:t>ورشحها درجتها مع األحاديث :HadeethEnc</a:t>
-            </a:r>
-          </a:p>
-          <a:p>
-            <a:r>
-              <a:t>الجديد للمسلم المفيد المخترص :IslamHouse موسوعة</a:t>
-            </a:r>
-          </a:p>
-          <a:p>
-            <a:r>
-              <a:t>باز ابن الشيخ موقع فتاوى</a:t>
-            </a:r>
-          </a:p>
-          <a:p>
-            <a:r>
-              <a:t>بعد يصل لم الموقع وإذن ،المنتج مالك بقرار مضاف :islamqa.info</a:t>
-            </a:r>
-          </a:p>
-          <a:p>
-            <a:r>
-              <a:t>.وحدها البيانات قاعدة من ُيعرض والحديث القرآن نص</a:t>
-            </a:r>
-          </a:p>
-          <a:p>
-            <a:r>
-              <a:t>الحالة</a:t>
-            </a:r>
-          </a:p>
-          <a:p>
-            <a:r>
-              <a:t>رفيق سلوك</a:t>
-            </a:r>
-          </a:p>
-          <a:p>
-            <a:r>
-              <a:t>مصدر يوجد ال</a:t>
-            </a:r>
-          </a:p>
-          <a:p>
-            <a:r>
-              <a:t>مرشد مع التواصل ويقرتح بوضوح يعتذر</a:t>
-            </a:r>
-          </a:p>
-          <a:p>
-            <a:r>
-              <a:t>شخيص سؤال</a:t>
-            </a:r>
-          </a:p>
-          <a:p>
-            <a:r>
-              <a:t>العلم أهل أو مرشد إىل ويحيله المصادر يف ما يذكر</a:t>
-            </a:r>
-          </a:p>
-          <a:p>
-            <a:r>
-              <a:t>خالفية مسألة</a:t>
-            </a:r>
-          </a:p>
-          <a:p>
-            <a:r>
-              <a:t>ترجيح دون لأقوا اً فيها أن ييب نّ</a:t>
-            </a:r>
-          </a:p>
-          <a:p>
-            <a:r>
-              <a:t>السائل على خطر</a:t>
-            </a:r>
-          </a:p>
-          <a:p>
-            <a:r>
-              <a:t>نموذج دون ،إنسان إىل فورية إحالة</a:t>
-            </a:r>
-          </a:p>
-          <a:p>
-            <a:r>
-              <a:t>الخدمة تعطل</a:t>
-            </a:r>
-          </a:p>
-          <a:p>
-            <a:r>
-              <a:t>المصدر غياب ي ّدعي ال المحاولة؛ وإعادة صادقة رسالة</a:t>
-            </a:r>
-          </a:p>
-          <a:p>
-            <a:r>
-              <a:t>.2026 أكتوبر 6 يف )لغات 3 × أسئلة 3( جاهزة إجابات 9 اعتمد .يعيدها أو الجاهزة واإلجابات والبطاقات الدروس فيها يعتمد مراجعة منصة :الرشعي المراجع</a:t>
-            </a:r>
-          </a:p>
-          <a:p>
-            <a:r>
-              <a:t>08 / 16</a:t>
+              <a:t>)3 من 3( رفيق يف ما</a:t>
+            </a:r>
+          </a:p>
+          <a:p>
+            <a:r>
+              <a:t>لوحاتهم الجديد المسلم يخدمون ولمن</a:t>
+            </a:r>
+          </a:p>
+          <a:p>
+            <a:r>
+              <a:t>.المتع ّلم إىل يصل أن قبل يراجعه من محتوى ولكل ،شاشته دور لكل :كاملة منظومة رفيق</a:t>
+            </a:r>
+          </a:p>
+          <a:p>
+            <a:r>
+              <a:t>المرشد لوحة</a:t>
+            </a:r>
+          </a:p>
+          <a:p>
+            <a:r>
+              <a:t>يرشدهم من مع والمحادثات الطلبات صندوق</a:t>
+            </a:r>
+          </a:p>
+          <a:p>
+            <a:r>
+              <a:t>تق ّدمه برؤية المتع ّلم له أذن من تق ّدم</a:t>
+            </a:r>
+          </a:p>
+          <a:p>
+            <a:r>
+              <a:t>وتحدياتها المجموعات إدارة</a:t>
+            </a:r>
+          </a:p>
+          <a:p>
+            <a:r>
+              <a:t>يرشدهم من لعدد أعلى وحد التوفر أوقات</a:t>
+            </a:r>
+          </a:p>
+          <a:p>
+            <a:r>
+              <a:t>الرشعي المراجع مكتب</a:t>
+            </a:r>
+          </a:p>
+          <a:p>
+            <a:r>
+              <a:t>إعادتها أو الجاهزة واإلجابات والبطاقات الدروس اعتماد</a:t>
+            </a:r>
+          </a:p>
+          <a:p>
+            <a:r>
+              <a:t>إتاحتهم قبل الق ّراء عينات إىل الستماع</a:t>
+            </a:r>
+          </a:p>
+          <a:p>
+            <a:r>
+              <a:t>»لماذا؟« رشوح عينات مراجعة</a:t>
+            </a:r>
+          </a:p>
+          <a:p>
+            <a:r>
+              <a:t>المساعد من المحالة والمسائل ،التحديات نصوص</a:t>
+            </a:r>
+          </a:p>
+          <a:p>
+            <a:r>
+              <a:t>واإلدارة الفريق</a:t>
+            </a:r>
+          </a:p>
+          <a:p>
+            <a:r>
+              <a:t>هوية دون ،واألسئلة التع ّلم عن مج ّمعة مؤرشات</a:t>
+            </a:r>
+          </a:p>
+          <a:p>
+            <a:r>
+              <a:t>المرشدين وتغطية البالغات طابور</a:t>
+            </a:r>
+          </a:p>
+          <a:p>
+            <a:r>
+              <a:t>الدعوة ورموز واألدوار المستخدمون</a:t>
+            </a:r>
+          </a:p>
+          <a:p>
+            <a:r>
+              <a:t>األهلة ترايئ متابعة</a:t>
+            </a:r>
+          </a:p>
+          <a:p>
+            <a:r>
+              <a:t>الدعوية الجهة من ّس ق</a:t>
+            </a:r>
+          </a:p>
+          <a:p>
+            <a:r>
+              <a:t>لغة بكل للجهة انضمام وروابط رموز</a:t>
+            </a:r>
+          </a:p>
+          <a:p>
+            <a:r>
+              <a:t>وإدارتهم الجهة مرشدي اعتماد</a:t>
+            </a:r>
+          </a:p>
+          <a:p>
+            <a:r>
+              <a:t>فردية بيانات بال ،الجهة منسويب لنشاط مج ّمعة لوحة</a:t>
+            </a:r>
+          </a:p>
+          <a:p>
+            <a:r>
+              <a:t>08 / 19</a:t>
             </a:r>
           </a:p>
         </p:txBody>
@@ -3197,137 +3795,157 @@
           <a:lstStyle/>
           <a:p>
             <a:r>
-              <a:t>النتائج</a:t>
-            </a:r>
-          </a:p>
-          <a:p>
-            <a:r>
-              <a:t>بعد نقسه لم وما ، لفع اً قسناه ما</a:t>
-            </a:r>
-          </a:p>
-          <a:p>
-            <a:r>
-              <a:t>.2026 أكتوبر 6و 5 يف ،اآللية الختبارات ومن )األسئلة نص دون( اإلنتاج سجالت من أرقام</a:t>
-            </a:r>
-          </a:p>
-          <a:p>
-            <a:r>
-              <a:t>14/14</a:t>
-            </a:r>
-          </a:p>
-          <a:p>
-            <a:r>
-              <a:t>يف التت ّبع بعد ُأجيب عرب ًيا لسؤا اً</a:t>
-            </a:r>
-          </a:p>
-          <a:p>
-            <a:r>
-              <a:t>)أكتوبر 6( اإلنتاج</a:t>
-            </a:r>
-          </a:p>
-          <a:p>
-            <a:r>
-              <a:t>0</a:t>
-            </a:r>
-          </a:p>
-          <a:p>
-            <a:r>
-              <a:t>بالمصادر الدعم فحص رفضها إجابة</a:t>
-            </a:r>
-          </a:p>
-          <a:p>
-            <a:r>
-              <a:t>من كان الرفض كل الفرتة؛ تلك يف</a:t>
-            </a:r>
-          </a:p>
-          <a:p>
-            <a:r>
-              <a:t>اآللية الفحوص</a:t>
-            </a:r>
-          </a:p>
-          <a:p>
-            <a:r>
-              <a:t>9/9</a:t>
-            </a:r>
-          </a:p>
-          <a:p>
-            <a:r>
-              <a:t>مقارنة يف للمو ّجه صحيح تصنيف</a:t>
-            </a:r>
-          </a:p>
-          <a:p>
-            <a:r>
-              <a:t>بعد للمؤلف 9 من 7و ،النماذج</a:t>
-            </a:r>
-          </a:p>
-          <a:p>
-            <a:r>
-              <a:t>التعليمات ضبط</a:t>
-            </a:r>
-          </a:p>
-          <a:p>
-            <a:r>
-              <a:t>$0.0015</a:t>
-            </a:r>
-          </a:p>
-          <a:p>
-            <a:r>
-              <a:t>إىل 9 يف ،تقري ًبا الواحدة اإلجابة تكلفة</a:t>
-            </a:r>
-          </a:p>
-          <a:p>
-            <a:r>
-              <a:t>ثانية 15</a:t>
-            </a:r>
-          </a:p>
-          <a:p>
-            <a:r>
-              <a:t>و ُأصلح قيس</a:t>
-            </a:r>
-          </a:p>
-          <a:p>
-            <a:r>
-              <a:t>ُع ّدت ﷺ النيب على الصالة صيغ( السبب وجدنا . لأو اً أجيبت 8 من 4 :اإلنجلزيية</a:t>
-            </a:r>
-          </a:p>
-          <a:p>
-            <a:r>
-              <a:t>المحاولة من إنجلزيية إجابة 11 من 8 اجتازت بعده وأصلحناه؛ )الحديث لنص نس ًخا</a:t>
-            </a:r>
-          </a:p>
-          <a:p>
-            <a:r>
-              <a:t>.)التطوير بيئة( واحد إصالح بعد الباقية والثالث ،األوىل</a:t>
-            </a:r>
-          </a:p>
-          <a:p>
-            <a:r>
-              <a:t>نعلنها حدود</a:t>
-            </a:r>
-          </a:p>
-          <a:p>
-            <a:r>
-              <a:t>،%95 ≥ األوىل المحاولة نسبة( الكامل الحي القياس بعد ُِنج لم .صغرية العينات</a:t>
-            </a:r>
-          </a:p>
-          <a:p>
-            <a:r>
-              <a:t>يف 335 :اآللية الختبارات .جدد مسلمني مع الختبار وال ،)سؤال لكل مرة 20 تكرار</a:t>
-            </a:r>
-          </a:p>
-          <a:p>
-            <a:r>
-              <a:t>.ناجحة كلها ،الواجهة يف 131و الخادم</a:t>
-            </a:r>
-          </a:p>
-          <a:p>
-            <a:r>
-              <a:t>docs/engineering/implementation/KNW-01-chatbot-reliability-report.md (§12)، docs/engineering/ai-agents.md (§3.2)، docs/engineering/STATUS.md :المصادر</a:t>
-            </a:r>
-          </a:p>
-          <a:p>
-            <a:r>
-              <a:t>09 / 16</a:t>
+              <a:t>)2 من 1( الصطناعي الذكاء</a:t>
+            </a:r>
+          </a:p>
+          <a:p>
+            <a:r>
+              <a:t>المصادر يف بما إال يجيب ال :»رفيق اسأل«</a:t>
+            </a:r>
+          </a:p>
+          <a:p>
+            <a:r>
+              <a:t>.ثانية 45و خارجية طلبات 8 :سؤال كل سقف .اإلجابة إيقاف تستطيع مرحلة وكل ،سؤال لكل مراحل ست</a:t>
+            </a:r>
+          </a:p>
+          <a:p>
+            <a:r>
+              <a:t>المرحلة</a:t>
+            </a:r>
+          </a:p>
+          <a:p>
+            <a:r>
+              <a:t>النموذج</a:t>
+            </a:r>
+          </a:p>
+          <a:p>
+            <a:r>
+              <a:t>تفعله ما</a:t>
+            </a:r>
+          </a:p>
+          <a:p>
+            <a:r>
+              <a:t>رفضت أو فشلت إذا</a:t>
+            </a:r>
+          </a:p>
+          <a:p>
+            <a:r>
+              <a:t>الخطر فحص .1نموذج باللأو اً تعمل ،لغات بثالث معتمدة خطر عبارات</a:t>
+            </a:r>
+          </a:p>
+          <a:p>
+            <a:r>
+              <a:t>اتصال أي دون ،إنسان إىل فورية وإحالة ثابت رد</a:t>
+            </a:r>
+          </a:p>
+          <a:p>
+            <a:r>
+              <a:t>بالشبكة</a:t>
+            </a:r>
+          </a:p>
+          <a:p>
+            <a:r>
+              <a:t>المو ّجه .2رسيع</a:t>
+            </a:r>
+          </a:p>
+          <a:p>
+            <a:r>
+              <a:t>ودرجته …تجاوز محاولة ،النطاق خارج ،خطر ،شخيص ،خاليف ،عام :السؤال يص ّنف</a:t>
+            </a:r>
+          </a:p>
+          <a:p>
+            <a:r>
+              <a:t>D إىل A من</a:t>
+            </a:r>
+          </a:p>
+          <a:p>
+            <a:r>
+              <a:t>إنسان إىل والخطر ،مرشد إىل ُيحال الشخيص</a:t>
+            </a:r>
+          </a:p>
+          <a:p>
+            <a:r>
+              <a:t>السرتجاع .3</a:t>
+            </a:r>
+          </a:p>
+          <a:p>
+            <a:r>
+              <a:t>bge-m3مقاطع 8 حىت ،السائل بلغة المعتمدة المصادر يف م ًعا ونيص داليل بحث</a:t>
+            </a:r>
+          </a:p>
+          <a:p>
+            <a:r>
+              <a:t>ذلك و ُيع َلن بالنيص يكمل الداليل البحث تعطل إن</a:t>
+            </a:r>
+          </a:p>
+          <a:p>
+            <a:r>
+              <a:t>المؤلف .4رئ يس</a:t>
+            </a:r>
+          </a:p>
+          <a:p>
+            <a:r>
+              <a:t>كتابة بدل حديث أو آية كل مكان عالمة ويضع ،وحدها المقاطع من اإلجابة يكتب</a:t>
+            </a:r>
+          </a:p>
+          <a:p>
+            <a:r>
+              <a:t>نصه</a:t>
+            </a:r>
+          </a:p>
+          <a:p>
+            <a:r>
+              <a:t>مرشد مع التواصل واقرتاح اعتذار ← »يكفي ال«</a:t>
+            </a:r>
+          </a:p>
+          <a:p>
+            <a:r>
+              <a:t>المدقق .5رسيع + كود</a:t>
+            </a:r>
+          </a:p>
+          <a:p>
+            <a:r>
+              <a:t>كل دعم فحص ثم )…اللغة ،منسوخ نص ال ، لفع اً مسرتجعة المراجع( آلية فحوص 7</a:t>
+            </a:r>
+          </a:p>
+          <a:p>
+            <a:r>
+              <a:t>بالمصدر جملة</a:t>
+            </a:r>
+          </a:p>
+          <a:p>
+            <a:r>
+              <a:t>تظهر ال وإال ،جديد من كامل فحص ثم واحد إصالح</a:t>
+            </a:r>
+          </a:p>
+          <a:p>
+            <a:r>
+              <a:t>اإلجابة</a:t>
+            </a:r>
+          </a:p>
+          <a:p>
+            <a:r>
+              <a:t>العرض .6</a:t>
+            </a:r>
+          </a:p>
+          <a:p>
+            <a:r>
+              <a:t>—المصدر بطاقة مع ،بمع ّرفه البيانات قاعدة من ُيعرض والحديث اآلية نص</a:t>
+            </a:r>
+          </a:p>
+          <a:p>
+            <a:r>
+              <a:t>اإلجابة ُتعرض ال العرض قبل المصدر ُحذف إن</a:t>
+            </a:r>
+          </a:p>
+          <a:p>
+            <a:r>
+              <a:t>docs/engineering/ai-agents.md :المصدر .بالطلبات يحتفظون ال ومز ّودون ،0 حرارة .deepseek-v4-pro و الحتياطي ،gemma-4-26b-a4b-it والرسيع ،gemma-4-31b-it الرئ يس :OpenRouter عرب النماذج</a:t>
+            </a:r>
+          </a:p>
+          <a:p>
+            <a:r>
+              <a:t>09 / 19</a:t>
             </a:r>
           </a:p>
         </p:txBody>
@@ -6618,6 +7236,132 @@
 </file>
 
 <file path=ppt/slides/slide16.xml><?xml version="1.0" encoding="utf-8"?>
+<p:sld xmlns:a="http://schemas.openxmlformats.org/drawingml/2006/main" xmlns:p="http://schemas.openxmlformats.org/presentationml/2006/main" xmlns:r="http://schemas.openxmlformats.org/officeDocument/2006/relationships">
+  <p:cSld>
+    <p:spTree>
+      <p:nvGrpSpPr>
+        <p:cNvPr id="1" name=""/>
+        <p:cNvGrpSpPr/>
+        <p:nvPr/>
+      </p:nvGrpSpPr>
+      <p:grpSpPr/>
+      <p:pic>
+        <p:nvPicPr>
+          <p:cNvPr id="2" name="Picture 1" descr="image.jpg"/>
+          <p:cNvPicPr>
+            <a:picLocks noChangeAspect="1"/>
+          </p:cNvPicPr>
+          <p:nvPr/>
+        </p:nvPicPr>
+        <p:blipFill>
+          <a:blip r:embed="rId2"/>
+          <a:stretch>
+            <a:fillRect/>
+          </a:stretch>
+        </p:blipFill>
+        <p:spPr>
+          <a:xfrm>
+            <a:off x="0" y="0"/>
+            <a:ext cx="12192000" cy="6858000"/>
+          </a:xfrm>
+          <a:prstGeom prst="rect">
+            <a:avLst/>
+          </a:prstGeom>
+        </p:spPr>
+      </p:pic>
+    </p:spTree>
+  </p:cSld>
+  <p:clrMapOvr>
+    <a:masterClrMapping/>
+  </p:clrMapOvr>
+</p:sld>
+</file>
+
+<file path=ppt/slides/slide17.xml><?xml version="1.0" encoding="utf-8"?>
+<p:sld xmlns:a="http://schemas.openxmlformats.org/drawingml/2006/main" xmlns:p="http://schemas.openxmlformats.org/presentationml/2006/main" xmlns:r="http://schemas.openxmlformats.org/officeDocument/2006/relationships">
+  <p:cSld>
+    <p:spTree>
+      <p:nvGrpSpPr>
+        <p:cNvPr id="1" name=""/>
+        <p:cNvGrpSpPr/>
+        <p:nvPr/>
+      </p:nvGrpSpPr>
+      <p:grpSpPr/>
+      <p:pic>
+        <p:nvPicPr>
+          <p:cNvPr id="2" name="Picture 1" descr="image.jpg"/>
+          <p:cNvPicPr>
+            <a:picLocks noChangeAspect="1"/>
+          </p:cNvPicPr>
+          <p:nvPr/>
+        </p:nvPicPr>
+        <p:blipFill>
+          <a:blip r:embed="rId2"/>
+          <a:stretch>
+            <a:fillRect/>
+          </a:stretch>
+        </p:blipFill>
+        <p:spPr>
+          <a:xfrm>
+            <a:off x="0" y="0"/>
+            <a:ext cx="12192000" cy="6858000"/>
+          </a:xfrm>
+          <a:prstGeom prst="rect">
+            <a:avLst/>
+          </a:prstGeom>
+        </p:spPr>
+      </p:pic>
+    </p:spTree>
+  </p:cSld>
+  <p:clrMapOvr>
+    <a:masterClrMapping/>
+  </p:clrMapOvr>
+</p:sld>
+</file>
+
+<file path=ppt/slides/slide18.xml><?xml version="1.0" encoding="utf-8"?>
+<p:sld xmlns:a="http://schemas.openxmlformats.org/drawingml/2006/main" xmlns:p="http://schemas.openxmlformats.org/presentationml/2006/main" xmlns:r="http://schemas.openxmlformats.org/officeDocument/2006/relationships">
+  <p:cSld>
+    <p:spTree>
+      <p:nvGrpSpPr>
+        <p:cNvPr id="1" name=""/>
+        <p:cNvGrpSpPr/>
+        <p:nvPr/>
+      </p:nvGrpSpPr>
+      <p:grpSpPr/>
+      <p:pic>
+        <p:nvPicPr>
+          <p:cNvPr id="2" name="Picture 1" descr="image.jpg"/>
+          <p:cNvPicPr>
+            <a:picLocks noChangeAspect="1"/>
+          </p:cNvPicPr>
+          <p:nvPr/>
+        </p:nvPicPr>
+        <p:blipFill>
+          <a:blip r:embed="rId2"/>
+          <a:stretch>
+            <a:fillRect/>
+          </a:stretch>
+        </p:blipFill>
+        <p:spPr>
+          <a:xfrm>
+            <a:off x="0" y="0"/>
+            <a:ext cx="12192000" cy="6858000"/>
+          </a:xfrm>
+          <a:prstGeom prst="rect">
+            <a:avLst/>
+          </a:prstGeom>
+        </p:spPr>
+      </p:pic>
+    </p:spTree>
+  </p:cSld>
+  <p:clrMapOvr>
+    <a:masterClrMapping/>
+  </p:clrMapOvr>
+</p:sld>
+</file>
+
+<file path=ppt/slides/slide19.xml><?xml version="1.0" encoding="utf-8"?>
 <p:sld xmlns:a="http://schemas.openxmlformats.org/drawingml/2006/main" xmlns:p="http://schemas.openxmlformats.org/presentationml/2006/main" xmlns:r="http://schemas.openxmlformats.org/officeDocument/2006/relationships">
   <p:cSld>
     <p:spTree>

</xml_diff>

<commit_message>
submission: deck v3 in Rafeeq's own identity, fully rewritten (21 slides)
</commit_message>
<xml_diff>
--- a/docs/submission/rafeeq-deck.pptx
+++ b/docs/submission/rafeeq-deck.pptx
@@ -24,6 +24,8 @@
     <p:sldId id="272" r:id="rId24"/>
     <p:sldId id="273" r:id="rId25"/>
     <p:sldId id="274" r:id="rId26"/>
+    <p:sldId id="275" r:id="rId27"/>
+    <p:sldId id="276" r:id="rId28"/>
   </p:sldIdLst>
   <p:sldSz cx="12192000" cy="6858000" type="screen4x3"/>
   <p:notesSz cx="6858000" cy="9144000"/>
@@ -520,27 +522,37 @@
           <a:lstStyle/>
           <a:p>
             <a:r>
+              <a:t>وتع ّلمه باإلسالم للتعريف المعرفية والرحلة التفاعلية التجارب · الثالث المسار</a:t>
+            </a:r>
+          </a:p>
+          <a:p>
+            <a:r>
               <a:t>رفيق</a:t>
             </a:r>
           </a:p>
           <a:p>
             <a:r>
-              <a:t>األوىل سنته يف الجديد المسلم رفيق</a:t>
-            </a:r>
-          </a:p>
-          <a:p>
-            <a:r>
-              <a:t>.يحتاج حني بإنسان ويصله ،معتمدة مصادر من ويجيبه ،خطوة خطوة بلغته يع ّلمه</a:t>
-            </a:r>
-          </a:p>
-          <a:p>
-            <a:r>
-              <a:t>rafeeq.nan.sa</a:t>
-            </a:r>
-          </a:p>
-          <a:p>
-            <a:r>
-              <a:t>وتع ّلمه باإلسالم للتعريف المعرفية والرحلة التفاعلية التجارب :الثالث المسار2026 أكتوبر · الختامي العرض</a:t>
+              <a:t>األوىل سنتك يف وحدك لست</a:t>
+            </a:r>
+          </a:p>
+          <a:p>
+            <a:r>
+              <a:t>مصادر من ويجيبه ،خطوة خطوة بلغته دينه يع ّلمه :الجديد المسلم رفيق</a:t>
+            </a:r>
+          </a:p>
+          <a:p>
+            <a:r>
+              <a:t>.احتاج مىت بإنسان ويصله ،معتمدة</a:t>
+            </a:r>
+          </a:p>
+          <a:p>
+            <a:r>
+              <a:t>rafeeq.nan.sa/app</a:t>
+            </a:r>
+          </a:p>
+          <a:p>
+            <a:r>
+              <a:t>English · Tagalog · العربية</a:t>
             </a:r>
           </a:p>
         </p:txBody>
@@ -610,32 +622,47 @@
           <a:lstStyle/>
           <a:p>
             <a:r>
-              <a:t>)2 من 2( الصطناعي الذكاء</a:t>
-            </a:r>
-          </a:p>
-          <a:p>
-            <a:r>
-              <a:t>التع ّلم خدمة يف الصطناعي الذكاء</a:t>
-            </a:r>
-          </a:p>
-          <a:p>
-            <a:r>
-              <a:t>.التجربة استمرار يضمن ثابت بديل منها ولكل ،وفاحص محدود مدخل منها لكل ،محددة صغرية مهام</a:t>
-            </a:r>
-          </a:p>
-          <a:p>
-            <a:r>
-              <a:t>الخطأ رشح »لماذا؟«</a:t>
-            </a:r>
-          </a:p>
-          <a:p>
-            <a:r>
-              <a:t>على كلمة 60 يف رش ًحا يكتب .المتع ّلم وإجابة والتمرين المعتمدة البطاقة :المدخل</a:t>
-            </a:r>
-          </a:p>
-          <a:p>
-            <a:r>
-              <a:t>.الفحص اجتاز ما إال ُيعرض وال .ٍثا نموذج يفحصه ثم ،األكرث</a:t>
+              <a:t>التع ّلم يف · الصطناعي الذكاء</a:t>
+            </a:r>
+          </a:p>
+          <a:p>
+            <a:r>
+              <a:t>هو من يعرف وال ،المتع ّلم يخدم ذكاء</a:t>
+            </a:r>
+          </a:p>
+          <a:p>
+            <a:r>
+              <a:t>.طلب أي يف هوية وال اسم يدخل وال ،وفاحص محدود مدخل منها لكل ،محددة صغرية مهام</a:t>
+            </a:r>
+          </a:p>
+          <a:p>
+            <a:r>
+              <a:t>؟</a:t>
+            </a:r>
+          </a:p>
+          <a:p>
+            <a:r>
+              <a:t>»لماذا؟«</a:t>
+            </a:r>
+          </a:p>
+          <a:p>
+            <a:r>
+              <a:t>المتع ّلم بلغة الخطأ سبب يرشح</a:t>
+            </a:r>
+          </a:p>
+          <a:p>
+            <a:r>
+              <a:t>ونموذج ،المعتمدة البطاقة من</a:t>
+            </a:r>
+          </a:p>
+          <a:p>
+            <a:r>
+              <a:t>.عليها يزد لم أنه يتأكد ٍثا</a:t>
+            </a:r>
+          </a:p>
+          <a:p>
+            <a:r>
+              <a:t>←</a:t>
             </a:r>
           </a:p>
           <a:p>
@@ -645,12 +672,22 @@
           </a:p>
           <a:p>
             <a:r>
-              <a:t>من فيه اسم وكل ،جمل 3 يف اآلن يتع ّلمه ما يقرتح ،هوية يحمل ال تع ّلم مل ّخص من</a:t>
-            </a:r>
-          </a:p>
-          <a:p>
-            <a:r>
-              <a:t>.ُيحفظ ال المل ّخص .المل ّخص</a:t>
+              <a:t>يقول ،هوية بال تع ّلم مل ّخص من</a:t>
+            </a:r>
+          </a:p>
+          <a:p>
+            <a:r>
+              <a:t>يتع ّلمه وما يراجعه وما أتقنه ما له</a:t>
+            </a:r>
+          </a:p>
+          <a:p>
+            <a:r>
+              <a:t>.اآلن</a:t>
+            </a:r>
+          </a:p>
+          <a:p>
+            <a:r>
+              <a:t>⌂</a:t>
             </a:r>
           </a:p>
           <a:p>
@@ -660,42 +697,77 @@
           </a:p>
           <a:p>
             <a:r>
-              <a:t>تبقى التالية الخطوة .اليوم يف مرة ،والتق ّدم اليوم وقت بحسب الرئيسية مك ّونات ير ّتب</a:t>
-            </a:r>
-          </a:p>
-          <a:p>
-            <a:r>
-              <a:t>.بديل ثابت ترتيب ومعه ،دائ ًما لأو اً</a:t>
-            </a:r>
-          </a:p>
-          <a:p>
-            <a:r>
-              <a:t>تع ّلمي بهدف السؤال ربط</a:t>
-            </a:r>
-          </a:p>
-          <a:p>
-            <a:r>
-              <a:t>الدرس فيقرتح ،معتمدة قائمة من بهدف المجاب سؤاله يربط :فقط المتع ّلم بإذن</a:t>
-            </a:r>
-          </a:p>
-          <a:p>
-            <a:r>
-              <a:t>.وحده المع ّرف ُيرسل .المناسب</a:t>
-            </a:r>
-          </a:p>
-          <a:p>
-            <a:r>
-              <a:t>المراجعة · ثاب ًتا ر ًدا ويعرض الطلبات يوقف وكلي يومي إنفاق سقف · تعليمات ال بيانات ُيعامل المستخدم نص · طلب أي يف سجل وال مع ّرف وال اسم يدخل ال :مشرتكة ضوابط</a:t>
-            </a:r>
-          </a:p>
-          <a:p>
-            <a:r>
-              <a:t>.لغوي نموذج ال ،مكتوبة خوارزمية التك ّيفية</a:t>
-            </a:r>
-          </a:p>
-          <a:p>
-            <a:r>
-              <a:t>10 / 19</a:t>
+              <a:t>بحسب الرئيسية مك ّونات ير ّتب</a:t>
+            </a:r>
+          </a:p>
+          <a:p>
+            <a:r>
+              <a:t>.اليوم يف مرة ،يومه ووقت تق ّدمه</a:t>
+            </a:r>
+          </a:p>
+          <a:p>
+            <a:r>
+              <a:t>↗</a:t>
+            </a:r>
+          </a:p>
+          <a:p>
+            <a:r>
+              <a:t>الدرس إىل السؤال من</a:t>
+            </a:r>
+          </a:p>
+          <a:p>
+            <a:r>
+              <a:t>،تع ّلمي بهدف سؤاله يربط ،بإذنه</a:t>
+            </a:r>
+          </a:p>
+          <a:p>
+            <a:r>
+              <a:t>.المناسب الدرس عليه فيقرتح</a:t>
+            </a:r>
+          </a:p>
+          <a:p>
+            <a:r>
+              <a:t>هوية بال</a:t>
+            </a:r>
+          </a:p>
+          <a:p>
+            <a:r>
+              <a:t>طلبات يف محادثة سجل وال مع ّرف وال اسم ال</a:t>
+            </a:r>
+          </a:p>
+          <a:p>
+            <a:r>
+              <a:t>.النماذج</a:t>
+            </a:r>
+          </a:p>
+          <a:p>
+            <a:r>
+              <a:t>بيانات المستخدم نص</a:t>
+            </a:r>
+          </a:p>
+          <a:p>
+            <a:r>
+              <a:t>.ُتن َّفذ تعليمات ال ،ُتح َّلل ًماد سؤاله ُيعامل</a:t>
+            </a:r>
+          </a:p>
+          <a:p>
+            <a:r>
+              <a:t>مضبوطة تكلفة</a:t>
+            </a:r>
+          </a:p>
+          <a:p>
+            <a:r>
+              <a:t>يومي إنفاق وسقف ،لإلجابة 0.0015$ قرابة</a:t>
+            </a:r>
+          </a:p>
+          <a:p>
+            <a:r>
+              <a:t>.المزيانية يحمي</a:t>
+            </a:r>
+          </a:p>
+          <a:p>
+            <a:r>
+              <a:t>رفيق10 / 21</a:t>
             </a:r>
           </a:p>
         </p:txBody>
@@ -765,122 +837,142 @@
           <a:lstStyle/>
           <a:p>
             <a:r>
-              <a:t>العلمية والسالمة الموثوقية</a:t>
-            </a:r>
-          </a:p>
-          <a:p>
-            <a:r>
-              <a:t>يحيل؟ أو يمتنع ومىت ،رفيق يجيب مىت</a:t>
-            </a:r>
-          </a:p>
-          <a:p>
-            <a:r>
-              <a:t>.خالفية مسألة يف ير ّجح وال ،شخصية حالة يف يفيت وال ،عنده من حدي ًثا وال آية يكتب ال النموذج</a:t>
-            </a:r>
-          </a:p>
-          <a:p>
-            <a:r>
-              <a:t>اإلجابات يف المعتمدة المصادر</a:t>
-            </a:r>
-          </a:p>
-          <a:p>
-            <a:r>
-              <a:t>المعتمدة وترجماته القرآن نص :QuranEnc</a:t>
-            </a:r>
-          </a:p>
-          <a:p>
-            <a:r>
-              <a:t>ورشحها درجتها مع األحاديث :HadeethEnc</a:t>
-            </a:r>
-          </a:p>
-          <a:p>
-            <a:r>
-              <a:t>الجديد للمسلم المفيد المخترص :IslamHouse موسوعة</a:t>
-            </a:r>
-          </a:p>
-          <a:p>
-            <a:r>
-              <a:t>باز ابن الشيخ موقع فتاوى</a:t>
-            </a:r>
-          </a:p>
-          <a:p>
-            <a:r>
-              <a:t>واإلنجلزيية بالعربية إجابات :وجواب سؤال اإلسالم</a:t>
-            </a:r>
-          </a:p>
-          <a:p>
-            <a:r>
-              <a:t>.وحدها البيانات قاعدة من ُيعرض والحديث القرآن نص</a:t>
-            </a:r>
-          </a:p>
-          <a:p>
-            <a:r>
-              <a:t>الحالة</a:t>
-            </a:r>
-          </a:p>
-          <a:p>
-            <a:r>
-              <a:t>رفيق سلوك</a:t>
-            </a:r>
-          </a:p>
-          <a:p>
-            <a:r>
-              <a:t>مصدر يوجد ال</a:t>
-            </a:r>
-          </a:p>
-          <a:p>
-            <a:r>
-              <a:t>مرشد مع التواصل ويقرتح بوضوح يعتذر</a:t>
-            </a:r>
-          </a:p>
-          <a:p>
-            <a:r>
-              <a:t>شخيص سؤال</a:t>
-            </a:r>
-          </a:p>
-          <a:p>
-            <a:r>
-              <a:t>العلم أهل أو مرشد إىل ويحيله المصادر يف ما يذكر</a:t>
-            </a:r>
-          </a:p>
-          <a:p>
-            <a:r>
-              <a:t>خالفية مسألة</a:t>
-            </a:r>
-          </a:p>
-          <a:p>
-            <a:r>
-              <a:t>ترجيح دون لأقوا اً فيها أن ييب نّ</a:t>
-            </a:r>
-          </a:p>
-          <a:p>
-            <a:r>
-              <a:t>السائل على خطر</a:t>
-            </a:r>
-          </a:p>
-          <a:p>
-            <a:r>
-              <a:t>نموذج دون ،إنسان إىل فورية إحالة</a:t>
-            </a:r>
-          </a:p>
-          <a:p>
-            <a:r>
-              <a:t>الخدمة تعطل</a:t>
-            </a:r>
-          </a:p>
-          <a:p>
-            <a:r>
-              <a:t>المصدر غياب ي ّدعي ال المحاولة؛ وإعادة صادقة رسالة</a:t>
-            </a:r>
-          </a:p>
-          <a:p>
-            <a:r>
-              <a:t>.2026 أكتوبر 6 يف )لغات 3 × أسئلة 3( جاهزة إجابات 9 اعتمد .يعيدها أو الجاهزة واإلجابات والبطاقات الدروس فيها يعتمد مراجعة منصة :الرشعي المراجع</a:t>
-            </a:r>
-          </a:p>
-          <a:p>
-            <a:r>
-              <a:t>11 / 19</a:t>
+              <a:t>البرشية المرافقة</a:t>
+            </a:r>
+          </a:p>
+          <a:p>
+            <a:r>
+              <a:t>شاشة كل يف زر :»إنسا ًنا أريد«</a:t>
+            </a:r>
+          </a:p>
+          <a:p>
+            <a:r>
+              <a:t>.جانبية خدمة ال ،المنتج من جزء اإلنسان .شاشة مع الجديد المسلم يرتك ال رفيق</a:t>
+            </a:r>
+          </a:p>
+          <a:p>
+            <a:r>
+              <a:t>وبلغته جنسه من مرشد</a:t>
+            </a:r>
+          </a:p>
+          <a:p>
+            <a:r>
+              <a:t>صغرية مجموعات</a:t>
+            </a:r>
+          </a:p>
+          <a:p>
+            <a:r>
+              <a:t>العلم أهل إىل إحالة</a:t>
+            </a:r>
+          </a:p>
+          <a:p>
+            <a:r>
+              <a:t>المحادثة أمان</a:t>
+            </a:r>
+          </a:p>
+          <a:p>
+            <a:r>
+              <a:t>الخطر يف</a:t>
+            </a:r>
+          </a:p>
+          <a:p>
+            <a:r>
+              <a:t>خاص دفرت</a:t>
+            </a:r>
+          </a:p>
+          <a:p>
+            <a:r>
+              <a:t>متاح مرشد إىل طلبه يصل</a:t>
+            </a:r>
+          </a:p>
+          <a:p>
+            <a:r>
+              <a:t>بنفسه مرشده يختار أو</a:t>
+            </a:r>
+          </a:p>
+          <a:p>
+            <a:r>
+              <a:t>بينهما خاصة محادثة</a:t>
+            </a:r>
+          </a:p>
+          <a:p>
+            <a:r>
+              <a:t>بلغته رفقة</a:t>
+            </a:r>
+          </a:p>
+          <a:p>
+            <a:r>
+              <a:t>جماعية تع ّلم تحديات</a:t>
+            </a:r>
+          </a:p>
+          <a:p>
+            <a:r>
+              <a:t>مرشد بإرشاف</a:t>
+            </a:r>
+          </a:p>
+          <a:p>
+            <a:r>
+              <a:t>الشخصية للمسألة</a:t>
+            </a:r>
+          </a:p>
+          <a:p>
+            <a:r>
+              <a:t>الرشعي المراجع يتابعها</a:t>
+            </a:r>
+          </a:p>
+          <a:p>
+            <a:r>
+              <a:t>إليه الجواب ويعود</a:t>
+            </a:r>
+          </a:p>
+          <a:p>
+            <a:r>
+              <a:t>بضغطة وحظر تبليغ</a:t>
+            </a:r>
+          </a:p>
+          <a:p>
+            <a:r>
+              <a:t>الفريق يتابعه بالغات طابور</a:t>
+            </a:r>
+          </a:p>
+          <a:p>
+            <a:r>
+              <a:t>مرشد كل بها ّيق قواعد</a:t>
+            </a:r>
+          </a:p>
+          <a:p>
+            <a:r>
+              <a:t>بلده يف الرسمية الطوارئ أرقام</a:t>
+            </a:r>
+          </a:p>
+          <a:p>
+            <a:r>
+              <a:t>اتصال دون حىت تظهر</a:t>
+            </a:r>
+          </a:p>
+          <a:p>
+            <a:r>
+              <a:t>الفريق إىل عاجل وطلب</a:t>
+            </a:r>
+          </a:p>
+          <a:p>
+            <a:r>
+              <a:t>لنفسه فيه يكتب</a:t>
+            </a:r>
+          </a:p>
+          <a:p>
+            <a:r>
+              <a:t>فريق وال مرشد يراه ال</a:t>
+            </a:r>
+          </a:p>
+          <a:p>
+            <a:r>
+              <a:t>جهازه على يبقى</a:t>
+            </a:r>
+          </a:p>
+          <a:p>
+            <a:r>
+              <a:t>رفيق11 / 21</a:t>
             </a:r>
           </a:p>
         </p:txBody>
@@ -950,112 +1042,117 @@
           <a:lstStyle/>
           <a:p>
             <a:r>
-              <a:t>النتائج</a:t>
-            </a:r>
-          </a:p>
-          <a:p>
-            <a:r>
-              <a:t>الفعلي التشغيل من أرقام</a:t>
-            </a:r>
-          </a:p>
-          <a:p>
-            <a:r>
-              <a:t>.2026 أكتوبر 6و 5 يف ،اآللية الختبارات ومن )األسئلة نص دون( الحي الموقع سجالت من</a:t>
-            </a:r>
-          </a:p>
-          <a:p>
-            <a:r>
-              <a:t>14/14</a:t>
-            </a:r>
-          </a:p>
-          <a:p>
-            <a:r>
-              <a:t>يف المصادر من ُأجيب عرب ًيا لسؤا اً</a:t>
-            </a:r>
-          </a:p>
-          <a:p>
-            <a:r>
-              <a:t>)أكتوبر 6( الحي الموقع</a:t>
-            </a:r>
-          </a:p>
-          <a:p>
-            <a:r>
-              <a:t>9/9</a:t>
-            </a:r>
-          </a:p>
-          <a:p>
-            <a:r>
-              <a:t>اختبار يف لألسئلة صحيح تصنيف</a:t>
-            </a:r>
-          </a:p>
-          <a:p>
-            <a:r>
-              <a:t>خطر ،خاليف ،شخيص ،عام :المو ّجه</a:t>
-            </a:r>
-          </a:p>
-          <a:p>
-            <a:r>
-              <a:t>$0.0015</a:t>
-            </a:r>
-          </a:p>
-          <a:p>
-            <a:r>
-              <a:t>وتصل ،تقري ًبا الواحدة اإلجابة تكلفة</a:t>
-            </a:r>
-          </a:p>
-          <a:p>
-            <a:r>
-              <a:t>ثانية 15 إىل 9 يف</a:t>
-            </a:r>
-          </a:p>
-          <a:p>
-            <a:r>
-              <a:t>+1,100</a:t>
-            </a:r>
-          </a:p>
-          <a:p>
-            <a:r>
-              <a:t>وثائق يف مثال لكل ،ناجح آيل اختبار</a:t>
-            </a:r>
-          </a:p>
-          <a:p>
-            <a:r>
-              <a:t>اختبار المزيات</a:t>
-            </a:r>
-          </a:p>
-          <a:p>
-            <a:r>
-              <a:t>تحسني ثم قياس</a:t>
-            </a:r>
-          </a:p>
-          <a:p>
-            <a:r>
-              <a:t>أن وجدنا :اإلنجلزيية اإلجابات رفعنا بهذا .سببها ونعرف مرفوضة إجابة كل نقيس</a:t>
-            </a:r>
-          </a:p>
-          <a:p>
-            <a:r>
-              <a:t>.واحد يوم يف فأصلحناه ،الحديث لنص نس ًخا ُّتع كانت ﷺ النيب على الصالة صيغ</a:t>
-            </a:r>
-          </a:p>
-          <a:p>
-            <a:r>
-              <a:t>تنازل صفر</a:t>
-            </a:r>
-          </a:p>
-          <a:p>
-            <a:r>
-              <a:t>ال يجتاز ال ما .بمصدرها جملة كل يطابق بفحص ثم آلية فحوص بسبعة تمر إجابة كل</a:t>
-            </a:r>
-          </a:p>
-          <a:p>
-            <a:r>
-              <a:t>.إنسان إىل وطريق صادق اعتذار منه لبد اً و ُيعرض ،ُيعرض</a:t>
-            </a:r>
-          </a:p>
-          <a:p>
-            <a:r>
-              <a:t>12 / 19</a:t>
+              <a:t>يومي</a:t>
+            </a:r>
+          </a:p>
+          <a:p>
+            <a:r>
+              <a:t>جهازه على محسوبة ،اليومية عبادته</a:t>
+            </a:r>
+          </a:p>
+          <a:p>
+            <a:r>
+              <a:t>.الجهاز يغادر ال وموقعه ،حساب وال إعالنات بال ،يومه يف المسلم أدوات</a:t>
+            </a:r>
+          </a:p>
+          <a:p>
+            <a:r>
+              <a:t>والقبلة الصالة مواقيت</a:t>
+            </a:r>
+          </a:p>
+          <a:p>
+            <a:r>
+              <a:t>األذكار</a:t>
+            </a:r>
+          </a:p>
+          <a:p>
+            <a:r>
+              <a:t>والمكتبة القرآن</a:t>
+            </a:r>
+          </a:p>
+          <a:p>
+            <a:r>
+              <a:t>والعادات التقويم</a:t>
+            </a:r>
+          </a:p>
+          <a:p>
+            <a:r>
+              <a:t>اليوم مواقيت</a:t>
+            </a:r>
+          </a:p>
+          <a:p>
+            <a:r>
+              <a:t>والمساء الصباح أذكار</a:t>
+            </a:r>
+          </a:p>
+          <a:p>
+            <a:r>
+              <a:t>مدينته من الجهاز على ُتحسب</a:t>
+            </a:r>
+          </a:p>
+          <a:p>
+            <a:r>
+              <a:t>بالبوصلة ح ّية قبلة</a:t>
+            </a:r>
+          </a:p>
+          <a:p>
+            <a:r>
+              <a:t>يختاره محايد تذكري</a:t>
+            </a:r>
+          </a:p>
+          <a:p>
+            <a:r>
+              <a:t>والنوم الصالة وبعد والمساء الصباح</a:t>
+            </a:r>
+          </a:p>
+          <a:p>
+            <a:r>
+              <a:t>وقته بحسب ُتعرض</a:t>
+            </a:r>
+          </a:p>
+          <a:p>
+            <a:r>
+              <a:t>ومصدرها ومعناها بنصهاً</a:t>
+            </a:r>
+          </a:p>
+          <a:p>
+            <a:r>
+              <a:t>آي ًآي ،ق ّراء بعدة استماع</a:t>
+            </a:r>
+          </a:p>
+          <a:p>
+            <a:r>
+              <a:t>أمامه ُتربز المتل ّوة اآلية</a:t>
+            </a:r>
+          </a:p>
+          <a:p>
+            <a:r>
+              <a:t>للمسلم معتمدة ومقاطع كتب</a:t>
+            </a:r>
+          </a:p>
+          <a:p>
+            <a:r>
+              <a:t>الجديد</a:t>
+            </a:r>
+          </a:p>
+          <a:p>
+            <a:r>
+              <a:t>والمناسبات الهجري التاريخ</a:t>
+            </a:r>
+          </a:p>
+          <a:p>
+            <a:r>
+              <a:t>رمضان وضع</a:t>
+            </a:r>
+          </a:p>
+          <a:p>
+            <a:r>
+              <a:t>لنفسه يتابعها عادات</a:t>
+            </a:r>
+          </a:p>
+          <a:p>
+            <a:r>
+              <a:t>رفيق12 / 21</a:t>
             </a:r>
           </a:p>
         </p:txBody>
@@ -1125,47 +1222,102 @@
           <a:lstStyle/>
           <a:p>
             <a:r>
-              <a:t>)2 من 1( المرشوع من صور</a:t>
-            </a:r>
-          </a:p>
-          <a:p>
-            <a:r>
-              <a:t>الحي الموقع من</a:t>
-            </a:r>
-          </a:p>
-          <a:p>
-            <a:r>
-              <a:t>وحدها اللغة اختيار :البدايةلأو اً التالية الخطوة :الرئيسية</a:t>
-            </a:r>
-          </a:p>
-          <a:p>
-            <a:r>
-              <a:t>مع البيانات قاعدة من آية :درس</a:t>
-            </a:r>
-          </a:p>
-          <a:p>
-            <a:r>
-              <a:t>تالوتها</a:t>
-            </a:r>
-          </a:p>
-          <a:p>
-            <a:r>
-              <a:t>البطاقات بعد تمرين</a:t>
-            </a:r>
-          </a:p>
-          <a:p>
-            <a:r>
-              <a:t>معها إجابة كل :التعريف صفحة</a:t>
-            </a:r>
-          </a:p>
-          <a:p>
-            <a:r>
-              <a:t>مصدرها</a:t>
-            </a:r>
-          </a:p>
-          <a:p>
-            <a:r>
-              <a:t>13 / 19</a:t>
+              <a:t>التحفزي</a:t>
+            </a:r>
+          </a:p>
+          <a:p>
+            <a:r>
+              <a:t>العبادة على نقا ًط ا يضع وال ،التع ّلم على يح ّفز</a:t>
+            </a:r>
+          </a:p>
+          <a:p>
+            <a:r>
+              <a:t>.وحده للتع ّلم والتحفزي ،وربه العبد بني العبادة :المنتج أصل يف وتربوي رشعي قرار</a:t>
+            </a:r>
+          </a:p>
+          <a:p>
+            <a:r>
+              <a:t>✦</a:t>
+            </a:r>
+          </a:p>
+          <a:p>
+            <a:r>
+              <a:t>التع ّلم أيام</a:t>
+            </a:r>
+          </a:p>
+          <a:p>
+            <a:r>
+              <a:t>يتع ّلم يوم كل مع تكرب سلسلة</a:t>
+            </a:r>
+          </a:p>
+          <a:p>
+            <a:r>
+              <a:t>.النقطاع بعد بلطف وتعود ،فيه</a:t>
+            </a:r>
+          </a:p>
+          <a:p>
+            <a:r>
+              <a:t>★</a:t>
+            </a:r>
+          </a:p>
+          <a:p>
+            <a:r>
+              <a:t>أوسمة</a:t>
+            </a:r>
+          </a:p>
+          <a:p>
+            <a:r>
+              <a:t>،باسمها وسام يت ّمها وحدة لكل</a:t>
+            </a:r>
+          </a:p>
+          <a:p>
+            <a:r>
+              <a:t>.حسابه يف يراه</a:t>
+            </a:r>
+          </a:p>
+          <a:p>
+            <a:r>
+              <a:t>◔</a:t>
+            </a:r>
+          </a:p>
+          <a:p>
+            <a:r>
+              <a:t>لطيف تذكري</a:t>
+            </a:r>
+          </a:p>
+          <a:p>
+            <a:r>
+              <a:t>بنص ،يختاره الذي الوقت يف</a:t>
+            </a:r>
+          </a:p>
+          <a:p>
+            <a:r>
+              <a:t>.ُيرد لم إن ّويق ،محايد</a:t>
+            </a:r>
+          </a:p>
+          <a:p>
+            <a:r>
+              <a:t>∞</a:t>
+            </a:r>
+          </a:p>
+          <a:p>
+            <a:r>
+              <a:t>جماعية تحديات</a:t>
+            </a:r>
+          </a:p>
+          <a:p>
+            <a:r>
+              <a:t>ترتيب دون ،مجموعته مع يتع ّلم</a:t>
+            </a:r>
+          </a:p>
+          <a:p>
+            <a:r>
+              <a:t>.لألفراد</a:t>
+            </a:r>
+          </a:p>
+          <a:p>
+            <a:r>
+              <a:t>رفيق13 / 21</a:t>
             </a:r>
           </a:p>
         </p:txBody>
@@ -1235,47 +1387,112 @@
           <a:lstStyle/>
           <a:p>
             <a:r>
-              <a:t>)2 من 2( المرشوع من صور</a:t>
-            </a:r>
-          </a:p>
-          <a:p>
-            <a:r>
-              <a:t>الحي الموقع من</a:t>
-            </a:r>
-          </a:p>
-          <a:p>
-            <a:r>
-              <a:t>الجهاز على محسوبة الصالة مواقيت</a:t>
-            </a:r>
-          </a:p>
-          <a:p>
-            <a:r>
-              <a:t>اليومية األذكار</a:t>
-            </a:r>
-          </a:p>
-          <a:p>
-            <a:r>
-              <a:t>المصادر يف والبحث المكتبة</a:t>
-            </a:r>
-          </a:p>
-          <a:p>
-            <a:r>
-              <a:t>واللغة ،حساب بال زائر :حسايب</a:t>
-            </a:r>
-          </a:p>
-          <a:p>
-            <a:r>
-              <a:t>والتزنيالت</a:t>
-            </a:r>
-          </a:p>
-          <a:p>
-            <a:r>
-              <a:t>والخصوصية المحايدة اإلشعارات</a:t>
-            </a:r>
-          </a:p>
-          <a:p>
-            <a:r>
-              <a:t>14 / 19</a:t>
+              <a:t>واألمان الخصوصية</a:t>
+            </a:r>
+          </a:p>
+          <a:p>
+            <a:r>
+              <a:t>إسالمه يخفي لمن مص ّمم</a:t>
+            </a:r>
+          </a:p>
+          <a:p>
+            <a:r>
+              <a:t>.صاحبه يد يف التحكم ونضع ،القليل أقل فنجمع ،حساسة بيانات الد ين المعتقد</a:t>
+            </a:r>
+          </a:p>
+          <a:p>
+            <a:r>
+              <a:t>حساب بال</a:t>
+            </a:r>
+          </a:p>
+          <a:p>
+            <a:r>
+              <a:t>الخفي الوضع</a:t>
+            </a:r>
+          </a:p>
+          <a:p>
+            <a:r>
+              <a:t>له بياناته</a:t>
+            </a:r>
+          </a:p>
+          <a:p>
+            <a:r>
+              <a:t>نفعله ال ما</a:t>
+            </a:r>
+          </a:p>
+          <a:p>
+            <a:r>
+              <a:t>والخصوصية اإلشعارات</a:t>
+            </a:r>
+          </a:p>
+          <a:p>
+            <a:r>
+              <a:t>حساب بال زائر :حسايب</a:t>
+            </a:r>
+          </a:p>
+          <a:p>
+            <a:r>
+              <a:t>تسجيل دون واألسئلة التع ّلم كل</a:t>
+            </a:r>
+          </a:p>
+          <a:p>
+            <a:r>
+              <a:t>مرور وكلمة مستعار اسم الحساب</a:t>
+            </a:r>
+          </a:p>
+          <a:p>
+            <a:r>
+              <a:t>حقيقي اسم وال جوال رقم ال</a:t>
+            </a:r>
+          </a:p>
+          <a:p>
+            <a:r>
+              <a:t>»Notes« يصبح الصفحة عنوان</a:t>
+            </a:r>
+          </a:p>
+          <a:p>
+            <a:r>
+              <a:t>دينية كلمة وال رفيق اسم بال إشعارات</a:t>
+            </a:r>
+          </a:p>
+          <a:p>
+            <a:r>
+              <a:t>شاشة كل يف رسيع خروج زر</a:t>
+            </a:r>
+          </a:p>
+          <a:p>
+            <a:r>
+              <a:t>بضغطة بياناته من نسخة</a:t>
+            </a:r>
+          </a:p>
+          <a:p>
+            <a:r>
+              <a:t>الحساب حذف أو الجهاز مسح</a:t>
+            </a:r>
+          </a:p>
+          <a:p>
+            <a:r>
+              <a:t>بيان أي قبل بلغته خصوصية سياسة</a:t>
+            </a:r>
+          </a:p>
+          <a:p>
+            <a:r>
+              <a:t>إعالنات وال تت ّبع أدوات ال</a:t>
+            </a:r>
+          </a:p>
+          <a:p>
+            <a:r>
+              <a:t>الجهاز يغادر ال الموقع</a:t>
+            </a:r>
+          </a:p>
+          <a:p>
+            <a:r>
+              <a:t>الصطناعي الذكاء طلبات يف هوية ال</a:t>
+            </a:r>
+          </a:p>
+          <a:p>
+            <a:r>
+              <a:t>رفيق14 / 21</a:t>
             </a:r>
           </a:p>
         </p:txBody>
@@ -1345,17 +1562,117 @@
           <a:lstStyle/>
           <a:p>
             <a:r>
-              <a:t>والخصوصية واإلتاحة المستفيد تجربة</a:t>
-            </a:r>
-          </a:p>
-          <a:p>
-            <a:r>
-              <a:t>وليلى ودانيال لجوزيف مص ّمم</a:t>
-            </a:r>
-          </a:p>
-          <a:p>
-            <a:r>
-              <a:t>.ُيكشف أن من خوف أو ،ضعيف اتصال أو ،لغة :حقيقي مستفيد وضع من جاء الواجهة يف قرار كل</a:t>
+              <a:t>متجر بال تطبيق</a:t>
+            </a:r>
+          </a:p>
+          <a:p>
+            <a:r>
+              <a:t>اتصال دون ويعمل ،بضغطة ُيث َّبت</a:t>
+            </a:r>
+          </a:p>
+          <a:p>
+            <a:r>
+              <a:t>.الرئيسية الشاشة على تطبي ًقا ويصري ،حاسوب أو جوال أي على الرابط من يفتح :تق ّدمي ويب تطبيق</a:t>
+            </a:r>
+          </a:p>
+          <a:p>
+            <a:r>
+              <a:t>↓</a:t>
+            </a:r>
+          </a:p>
+          <a:p>
+            <a:r>
+              <a:t>خفيف</a:t>
+            </a:r>
+          </a:p>
+          <a:p>
+            <a:r>
+              <a:t>من أقل كلها المتع ّلم واجهة</a:t>
+            </a:r>
+          </a:p>
+          <a:p>
+            <a:r>
+              <a:t>،مضغوطة واحد ميغابايت</a:t>
+            </a:r>
+          </a:p>
+          <a:p>
+            <a:r>
+              <a:t>التشغيل عند والفيديو والصوت</a:t>
+            </a:r>
+          </a:p>
+          <a:p>
+            <a:r>
+              <a:t>.فقط</a:t>
+            </a:r>
+          </a:p>
+          <a:p>
+            <a:r>
+              <a:t>⌁</a:t>
+            </a:r>
+          </a:p>
+          <a:p>
+            <a:r>
+              <a:t>اتصال دون</a:t>
+            </a:r>
+          </a:p>
+          <a:p>
+            <a:r>
+              <a:t>،دروسه :الطريان وضع يف يفتح</a:t>
+            </a:r>
+          </a:p>
+          <a:p>
+            <a:r>
+              <a:t>.حفظه وما ،واألذكار ،والمواقيت</a:t>
+            </a:r>
+          </a:p>
+          <a:p>
+            <a:r>
+              <a:t>▤</a:t>
+            </a:r>
+          </a:p>
+          <a:p>
+            <a:r>
+              <a:t>التزنيالت مركز</a:t>
+            </a:r>
+          </a:p>
+          <a:p>
+            <a:r>
+              <a:t>أو ،وحدة :معه يبقى ما يختار</a:t>
+            </a:r>
+          </a:p>
+          <a:p>
+            <a:r>
+              <a:t>كل حجم ويرى ،كتاب أو ،سورة</a:t>
+            </a:r>
+          </a:p>
+          <a:p>
+            <a:r>
+              <a:t>.منها</a:t>
+            </a:r>
+          </a:p>
+          <a:p>
+            <a:r>
+              <a:t>◉</a:t>
+            </a:r>
+          </a:p>
+          <a:p>
+            <a:r>
+              <a:t>إشعارات</a:t>
+            </a:r>
+          </a:p>
+          <a:p>
+            <a:r>
+              <a:t>مغلقة ،واآليفون األندرويد على</a:t>
+            </a:r>
+          </a:p>
+          <a:p>
+            <a:r>
+              <a:t>شاشة على ومحايدة ،يف ّعلها حىت</a:t>
+            </a:r>
+          </a:p>
+          <a:p>
+            <a:r>
+              <a:t>.القفل</a:t>
             </a:r>
           </a:p>
           <a:p>
@@ -1365,117 +1682,32 @@
           </a:p>
           <a:p>
             <a:r>
-              <a:t>من ،شاشة كل يف والتاغالوغية واإلنجلزيية العربية</a:t>
-            </a:r>
-          </a:p>
-          <a:p>
-            <a:r>
-              <a:t>مع يبقى العريب الرشعي والنص ،اليسار ومن اليمني</a:t>
-            </a:r>
-          </a:p>
-          <a:p>
-            <a:r>
-              <a:t>.معناه</a:t>
-            </a:r>
-          </a:p>
-          <a:p>
-            <a:r>
-              <a:t>اتصال دون يعمل</a:t>
-            </a:r>
-          </a:p>
-          <a:p>
-            <a:r>
-              <a:t>والمواقيت ،المسار من فتحه ما :زيارة أول بعد</a:t>
-            </a:r>
-          </a:p>
-          <a:p>
-            <a:r>
-              <a:t>معه يبقى ما فيه يختار تزنيالت ومركز .واألذكار والقبلة</a:t>
-            </a:r>
-          </a:p>
-          <a:p>
-            <a:r>
-              <a:t>.بحجمه</a:t>
-            </a:r>
-          </a:p>
-          <a:p>
-            <a:r>
-              <a:t>الباقة على خفيف</a:t>
-            </a:r>
-          </a:p>
-          <a:p>
-            <a:r>
-              <a:t>1 قرابة( فتح أول يف وحدها المتع ّلم واجهة</a:t>
-            </a:r>
-          </a:p>
-          <a:p>
-            <a:r>
-              <a:t>عند والفيديو والصوت ،)مضغوطة ميجابايت</a:t>
-            </a:r>
-          </a:p>
-          <a:p>
-            <a:r>
-              <a:t>.فقط التشغيل</a:t>
-            </a:r>
-          </a:p>
-          <a:p>
-            <a:r>
-              <a:t>الرسيع والخروج الخفي الوضع</a:t>
-            </a:r>
-          </a:p>
-          <a:p>
-            <a:r>
-              <a:t>اسم بال واإلشعارات »Notes« يصبح الصفحة عنوان</a:t>
-            </a:r>
-          </a:p>
-          <a:p>
-            <a:r>
-              <a:t>بيانات ومسح ،رسيع خروج وزر ،دينية كلمة وال رفيق</a:t>
-            </a:r>
-          </a:p>
-          <a:p>
-            <a:r>
-              <a:t>.الجهاز</a:t>
-            </a:r>
-          </a:p>
-          <a:p>
-            <a:r>
-              <a:t>البيانات من قدر أقل</a:t>
-            </a:r>
-          </a:p>
-          <a:p>
-            <a:r>
-              <a:t>مستعار اسم الحساب .للتع ّلم مطلوب حساب ال</a:t>
-            </a:r>
-          </a:p>
-          <a:p>
-            <a:r>
-              <a:t>.اختياري والربيد ،مرور وكلمة</a:t>
-            </a:r>
-          </a:p>
-          <a:p>
-            <a:r>
-              <a:t>الجهاز يغادر ال الموقع</a:t>
-            </a:r>
-          </a:p>
-          <a:p>
-            <a:r>
-              <a:t>،مدن قائمة من الجهاز على ُتحسب المواقيت</a:t>
-            </a:r>
-          </a:p>
-          <a:p>
-            <a:r>
-              <a:t>شاشة على ومحايدة ،يف ّعلها حىت مغلقة واإلشعارات</a:t>
-            </a:r>
-          </a:p>
-          <a:p>
-            <a:r>
-              <a:t>.القفل</a:t>
-            </a:r>
-          </a:p>
-          <a:p>
-            <a:r>
-              <a:t>15 / 19</a:t>
+              <a:t>.والتاغالوغية واإلنجلزيية بالعربية شاشة كل</a:t>
+            </a:r>
+          </a:p>
+          <a:p>
+            <a:r>
+              <a:t>وداكن فاتح</a:t>
+            </a:r>
+          </a:p>
+          <a:p>
+            <a:r>
+              <a:t>.اختياره أو الجهاز يتبع مظهر</a:t>
+            </a:r>
+          </a:p>
+          <a:p>
+            <a:r>
+              <a:t>در ًس ا يقطع ال تحديث</a:t>
+            </a:r>
+          </a:p>
+          <a:p>
+            <a:r>
+              <a:t>.درسه ينهي حىت ينتظر الجديد اإلصدار</a:t>
+            </a:r>
+          </a:p>
+          <a:p>
+            <a:r>
+              <a:t>رفيق15 / 21</a:t>
             </a:r>
           </a:p>
         </p:txBody>
@@ -1545,177 +1777,147 @@
           <a:lstStyle/>
           <a:p>
             <a:r>
-              <a:t>والبنية التقنيات</a:t>
-            </a:r>
-          </a:p>
-          <a:p>
-            <a:r>
-              <a:t>وصيانتها تشغيلها يمكن بسيطة بنية</a:t>
-            </a:r>
-          </a:p>
-          <a:p>
-            <a:r>
-              <a:t>.آيل وتراجع صحة فحص مع ،ُينرش ثم ب الختبارات يمر الرئ يس الفرع إىل دفع كل</a:t>
-            </a:r>
-          </a:p>
-          <a:p>
-            <a:r>
-              <a:t>الجوال</a:t>
-            </a:r>
-          </a:p>
-          <a:p>
-            <a:r>
-              <a:t>قابل ويب تطبيق</a:t>
-            </a:r>
-          </a:p>
-          <a:p>
-            <a:r>
-              <a:t>للتثبيت</a:t>
-            </a:r>
-          </a:p>
-          <a:p>
-            <a:r>
-              <a:t>و Vite و React</a:t>
-            </a:r>
-          </a:p>
-          <a:p>
-            <a:r>
-              <a:t>خدمة وعامل ،TypeScript</a:t>
-            </a:r>
-          </a:p>
-          <a:p>
-            <a:r>
-              <a:t>ونظام ،اتصال دون للعمل</a:t>
-            </a:r>
-          </a:p>
-          <a:p>
-            <a:r>
-              <a:t>إشعارات .مو ّحد تصميم</a:t>
-            </a:r>
-          </a:p>
-          <a:p>
-            <a:r>
-              <a:t>.Web Push</a:t>
-            </a:r>
-          </a:p>
-          <a:p>
-            <a:r>
-              <a:t>⇄</a:t>
-            </a:r>
-          </a:p>
-          <a:p>
-            <a:r>
-              <a:t>الخادم</a:t>
-            </a:r>
-          </a:p>
-          <a:p>
-            <a:r>
-              <a:t>FastAPI (Python)</a:t>
-            </a:r>
-          </a:p>
-          <a:p>
-            <a:r>
-              <a:t>،والتحقق السؤال مسار</a:t>
-            </a:r>
-          </a:p>
-          <a:p>
-            <a:r>
-              <a:t>،والمراجعة والمسار</a:t>
-            </a:r>
-          </a:p>
-          <a:p>
-            <a:r>
-              <a:t>النصوص وواجهة ،والمرافقة</a:t>
-            </a:r>
-          </a:p>
-          <a:p>
-            <a:r>
-              <a:t>مجدولة مهام .الرشعية</a:t>
-            </a:r>
-          </a:p>
-          <a:p>
-            <a:r>
-              <a:t>.للفهرسة</a:t>
-            </a:r>
-          </a:p>
-          <a:p>
-            <a:r>
-              <a:t>⇄</a:t>
-            </a:r>
-          </a:p>
-          <a:p>
-            <a:r>
-              <a:t>البيانات</a:t>
-            </a:r>
-          </a:p>
-          <a:p>
-            <a:r>
-              <a:t>PostgreSQL +</a:t>
-            </a:r>
-          </a:p>
-          <a:p>
-            <a:r>
-              <a:t>pgvector</a:t>
-            </a:r>
-          </a:p>
-          <a:p>
-            <a:r>
-              <a:t>ومتجهاتها المعتمدة المقاطع</a:t>
-            </a:r>
-          </a:p>
-          <a:p>
-            <a:r>
-              <a:t>،نيص وفهرس )ُبع ًدا 1024(</a:t>
-            </a:r>
-          </a:p>
-          <a:p>
-            <a:r>
-              <a:t>.نص دون التكلفة وسجل</a:t>
-            </a:r>
-          </a:p>
-          <a:p>
-            <a:r>
-              <a:t>⇄</a:t>
-            </a:r>
-          </a:p>
-          <a:p>
-            <a:r>
-              <a:t>النماذج</a:t>
-            </a:r>
-          </a:p>
-          <a:p>
-            <a:r>
-              <a:t>OpenRouter</a:t>
-            </a:r>
-          </a:p>
-          <a:p>
-            <a:r>
-              <a:t>للتأليف Gemma 4</a:t>
-            </a:r>
-          </a:p>
-          <a:p>
-            <a:r>
-              <a:t>و ،والفحص والتصنيف</a:t>
-            </a:r>
-          </a:p>
-          <a:p>
-            <a:r>
-              <a:t>و ،احتياط ًيا DeepSeek</a:t>
-            </a:r>
-          </a:p>
-          <a:p>
-            <a:r>
-              <a:t>.للمتجهات bge-m3</a:t>
-            </a:r>
-          </a:p>
-          <a:p>
-            <a:r>
-              <a:t>github.com/rafeeq-muslim/rafeeq :الكود .GitHub Actions من آيل ونرش ،واحد خادم على nginx خلف Docker حاويات :الستضافة</a:t>
-            </a:r>
-          </a:p>
-          <a:p>
-            <a:r>
-              <a:t>16 / 19</a:t>
+              <a:t>2 من 1 · الستار خلف</a:t>
+            </a:r>
+          </a:p>
+          <a:p>
+            <a:r>
+              <a:t>لوحته الجديد المسلم يخدم من لكل</a:t>
+            </a:r>
+          </a:p>
+          <a:p>
+            <a:r>
+              <a:t>.فقط متع ّلم واجهة ال ،كاملة منظومة رفيق</a:t>
+            </a:r>
+          </a:p>
+          <a:p>
+            <a:r>
+              <a:t>المرشد لوحة</a:t>
+            </a:r>
+          </a:p>
+          <a:p>
+            <a:r>
+              <a:t>متطوع</a:t>
+            </a:r>
+          </a:p>
+          <a:p>
+            <a:r>
+              <a:t>الطلبات صندوق</a:t>
+            </a:r>
+          </a:p>
+          <a:p>
+            <a:r>
+              <a:t>ويرد يقبلها ،جنسه ومن بلغته »إنسا ًنا أريد« طلبات</a:t>
+            </a:r>
+          </a:p>
+          <a:p>
+            <a:r>
+              <a:t>يرشدهم من</a:t>
+            </a:r>
+          </a:p>
+          <a:p>
+            <a:r>
+              <a:t>وأوسمته تق ّدمه برؤية له أذن من وتق ّدم ،محادثاتهم</a:t>
+            </a:r>
+          </a:p>
+          <a:p>
+            <a:r>
+              <a:t>المجموعات</a:t>
+            </a:r>
+          </a:p>
+          <a:p>
+            <a:r>
+              <a:t>تحدياتها ويدير مجموعته ينئش</a:t>
+            </a:r>
+          </a:p>
+          <a:p>
+            <a:r>
+              <a:t>والحد التوفر</a:t>
+            </a:r>
+          </a:p>
+          <a:p>
+            <a:r>
+              <a:t>يرشدهم من لعدد أعلى وحد ،توفره أوقات</a:t>
+            </a:r>
+          </a:p>
+          <a:p>
+            <a:r>
+              <a:t>المرشد قواعد</a:t>
+            </a:r>
+          </a:p>
+          <a:p>
+            <a:r>
+              <a:t>محادثة أول قبل بها ّيق</a:t>
+            </a:r>
+          </a:p>
+          <a:p>
+            <a:r>
+              <a:t>الرشعي المراجع مكتب</a:t>
+            </a:r>
+          </a:p>
+          <a:p>
+            <a:r>
+              <a:t>مراجع</a:t>
+            </a:r>
+          </a:p>
+          <a:p>
+            <a:r>
+              <a:t>المحتوى اعتماد</a:t>
+            </a:r>
+          </a:p>
+          <a:p>
+            <a:r>
+              <a:t>أو يعتمدها :الجاهزة واإلجابات والبطاقات الدروس</a:t>
+            </a:r>
+          </a:p>
+          <a:p>
+            <a:r>
+              <a:t>يعيدها</a:t>
+            </a:r>
+          </a:p>
+          <a:p>
+            <a:r>
+              <a:t>الق ّراء عينات</a:t>
+            </a:r>
+          </a:p>
+          <a:p>
+            <a:r>
+              <a:t>إتاحته قبل قارئ كل إىل يستمع</a:t>
+            </a:r>
+          </a:p>
+          <a:p>
+            <a:r>
+              <a:t>»لماذا؟« رشوح</a:t>
+            </a:r>
+          </a:p>
+          <a:p>
+            <a:r>
+              <a:t>النموذج كتبه مما عينات يراجع</a:t>
+            </a:r>
+          </a:p>
+          <a:p>
+            <a:r>
+              <a:t>التحديات نصوص</a:t>
+            </a:r>
+          </a:p>
+          <a:p>
+            <a:r>
+              <a:t>الجماعية التحديات نصوص يعتمد</a:t>
+            </a:r>
+          </a:p>
+          <a:p>
+            <a:r>
+              <a:t>المحالة المسائل</a:t>
+            </a:r>
+          </a:p>
+          <a:p>
+            <a:r>
+              <a:t>العلم أهل إىل المساعد أحاله ع ّما يجيب</a:t>
+            </a:r>
+          </a:p>
+          <a:p>
+            <a:r>
+              <a:t>رفيق16 / 21</a:t>
             </a:r>
           </a:p>
         </p:txBody>
@@ -1785,137 +1987,117 @@
           <a:lstStyle/>
           <a:p>
             <a:r>
-              <a:t>المضافة القيمة</a:t>
-            </a:r>
-          </a:p>
-          <a:p>
-            <a:r>
-              <a:t>البدائل؟ تق ّدمه وال رفيق يق ّدمه الذي ما</a:t>
-            </a:r>
-          </a:p>
-          <a:p>
-            <a:r>
-              <a:t>.لغات وعدة البرشي والمرشد المو ّثق والمساعد التع ّلمي المسار يجمع منت ًجا نجد لم ،تطبيقات 9و برنام ًجا 14 شمل مسح يف</a:t>
-            </a:r>
-          </a:p>
-          <a:p>
-            <a:r>
-              <a:t>عامة اصطناعي ذكاء محادثة</a:t>
-            </a:r>
-          </a:p>
-          <a:p>
-            <a:r>
-              <a:t>ثابتة ومواقع PDF كتيبات</a:t>
-            </a:r>
-          </a:p>
-          <a:p>
-            <a:r>
-              <a:t>التواصل وسائل</a:t>
-            </a:r>
-          </a:p>
-          <a:p>
-            <a:r>
-              <a:t>رفيق</a:t>
-            </a:r>
-          </a:p>
-          <a:p>
-            <a:r>
-              <a:t>المصدر</a:t>
-            </a:r>
-          </a:p>
-          <a:p>
-            <a:r>
-              <a:t>ن ًص ا يخرتع وقد ،معروف غري</a:t>
-            </a:r>
-          </a:p>
-          <a:p>
-            <a:r>
-              <a:t>موثوق</a:t>
-            </a:r>
-          </a:p>
-          <a:p>
-            <a:r>
-              <a:t>متضارب</a:t>
-            </a:r>
-          </a:p>
-          <a:p>
-            <a:r>
-              <a:t>البيانات قاعدة من والنص ،معتمدة مصادر</a:t>
-            </a:r>
-          </a:p>
-          <a:p>
-            <a:r>
-              <a:t>التد ّرج</a:t>
-            </a:r>
-          </a:p>
-          <a:p>
-            <a:r>
-              <a:t>يوجد ال</a:t>
-            </a:r>
-          </a:p>
-          <a:p>
-            <a:r>
-              <a:t>للجميع واحد كتاب</a:t>
-            </a:r>
-          </a:p>
-          <a:p>
-            <a:r>
-              <a:t>يوجد ال</a:t>
-            </a:r>
-          </a:p>
-          <a:p>
-            <a:r>
-              <a:t>اإلتقان بحسب ومراجعة مسار</a:t>
-            </a:r>
-          </a:p>
-          <a:p>
-            <a:r>
-              <a:t>لغته</a:t>
-            </a:r>
-          </a:p>
-          <a:p>
-            <a:r>
-              <a:t>ضمان دون ،نعم</a:t>
-            </a:r>
-          </a:p>
-          <a:p>
-            <a:r>
-              <a:t>بالتاغالوغية وقليل ،محدود</a:t>
-            </a:r>
-          </a:p>
-          <a:p>
-            <a:r>
-              <a:t>متفاوت</a:t>
-            </a:r>
-          </a:p>
-          <a:p>
-            <a:r>
-              <a:t>معتمدة بمصطلحات لغات ثالث</a:t>
-            </a:r>
-          </a:p>
-          <a:p>
-            <a:r>
-              <a:t>اإلنسان</a:t>
-            </a:r>
-          </a:p>
-          <a:p>
-            <a:r>
-              <a:t>ال</a:t>
-            </a:r>
-          </a:p>
-          <a:p>
-            <a:r>
-              <a:t>ال</a:t>
-            </a:r>
-          </a:p>
-          <a:p>
-            <a:r>
-              <a:t>غرباء</a:t>
-            </a:r>
-          </a:p>
-          <a:p>
-            <a:r>
-              <a:t>الخطر يف وإحالة ،وبلغته جنسه من مرشد</a:t>
+              <a:t>2 من 2 · الستار خلف</a:t>
+            </a:r>
+          </a:p>
+          <a:p>
+            <a:r>
+              <a:t>األشخاص تعرف وال ،األثر تعرف إدارة</a:t>
+            </a:r>
+          </a:p>
+          <a:p>
+            <a:r>
+              <a:t>.دور لكل محددة وصالحيات ،هوية بال مج ّمعة مؤرشات</a:t>
+            </a:r>
+          </a:p>
+          <a:p>
+            <a:r>
+              <a:t>واإلدارة الفريق</a:t>
+            </a:r>
+          </a:p>
+          <a:p>
+            <a:r>
+              <a:t>رفيق فريق</a:t>
+            </a:r>
+          </a:p>
+          <a:p>
+            <a:r>
+              <a:t>المؤرشات</a:t>
+            </a:r>
+          </a:p>
+          <a:p>
+            <a:r>
+              <a:t>هوية دون مج ّمعة ،والعودة واألسئلة التع ّلم</a:t>
+            </a:r>
+          </a:p>
+          <a:p>
+            <a:r>
+              <a:t>البالغات طابور</a:t>
+            </a:r>
+          </a:p>
+          <a:p>
+            <a:r>
+              <a:t>العاجلة والطلبات المحادثات بالغات</a:t>
+            </a:r>
+          </a:p>
+          <a:p>
+            <a:r>
+              <a:t>التغطية</a:t>
+            </a:r>
+          </a:p>
+          <a:p>
+            <a:r>
+              <a:t>جنس وألي لغة وبأي ،مرشدون يتوفر أين</a:t>
+            </a:r>
+          </a:p>
+          <a:p>
+            <a:r>
+              <a:t>المستخدمون</a:t>
+            </a:r>
+          </a:p>
+          <a:p>
+            <a:r>
+              <a:t>الدعوة ورموز األدوار</a:t>
+            </a:r>
+          </a:p>
+          <a:p>
+            <a:r>
+              <a:t>األهلة ترايئ</a:t>
+            </a:r>
+          </a:p>
+          <a:p>
+            <a:r>
+              <a:t>الهجرية األشهر بدايات متابعة</a:t>
+            </a:r>
+          </a:p>
+          <a:p>
+            <a:r>
+              <a:t>الدعوية الجهة من ّس ق</a:t>
+            </a:r>
+          </a:p>
+          <a:p>
+            <a:r>
+              <a:t>دعوي مكتب</a:t>
+            </a:r>
+          </a:p>
+          <a:p>
+            <a:r>
+              <a:t>النضمام رموز</a:t>
+            </a:r>
+          </a:p>
+          <a:p>
+            <a:r>
+              <a:t>الجهة باسم ،لغة لكل QRو ورابط رمز</a:t>
+            </a:r>
+          </a:p>
+          <a:p>
+            <a:r>
+              <a:t>الجهة مرشدو</a:t>
+            </a:r>
+          </a:p>
+          <a:p>
+            <a:r>
+              <a:t>توفرهم ويدير يعتمدهم</a:t>
+            </a:r>
+          </a:p>
+          <a:p>
+            <a:r>
+              <a:t>مج ّمعة لوحة</a:t>
+            </a:r>
+          </a:p>
+          <a:p>
+            <a:r>
+              <a:t>فردية بيانات بال ،الجهة منسويب نشاط</a:t>
             </a:r>
           </a:p>
           <a:p>
@@ -1925,32 +2107,12 @@
           </a:p>
           <a:p>
             <a:r>
-              <a:t>ُتحفظ المحادثة</a:t>
-            </a:r>
-          </a:p>
-          <a:p>
-            <a:r>
-              <a:t>جيدة</a:t>
-            </a:r>
-          </a:p>
-          <a:p>
-            <a:r>
-              <a:t>مكشوفة</a:t>
-            </a:r>
-          </a:p>
-          <a:p>
-            <a:r>
-              <a:t>النموذج طلبات يف هوية وال ،خفي وضع</a:t>
-            </a:r>
-          </a:p>
-          <a:p>
-            <a:r>
-              <a:t>.)مكتيب بحث ،2026 أكتوبر ،السوق قسم( docs/agents/evidence.md :المسح</a:t>
-            </a:r>
-          </a:p>
-          <a:p>
-            <a:r>
-              <a:t>17 / 19</a:t>
+              <a:t>شاء مىت بالجهة ارتباطه يفك المتع ّلم</a:t>
+            </a:r>
+          </a:p>
+          <a:p>
+            <a:r>
+              <a:t>رفيق17 / 21</a:t>
             </a:r>
           </a:p>
         </p:txBody>
@@ -2020,152 +2182,122 @@
           <a:lstStyle/>
           <a:p>
             <a:r>
-              <a:t>الستمرار وخطة التشغيل واقعية</a:t>
-            </a:r>
-          </a:p>
-          <a:p>
-            <a:r>
-              <a:t>ليستمر ومه ّيأ ،اليوم يعمل</a:t>
-            </a:r>
-          </a:p>
-          <a:p>
-            <a:r>
-              <a:t>.المسؤوليات وواضح الكلفة قليل وتشغيله ،اآلن المستخدمني ويخدم منشور رفيق</a:t>
-            </a:r>
-          </a:p>
-          <a:p>
-            <a:r>
-              <a:t>تشغيل</a:t>
-            </a:r>
-          </a:p>
-          <a:p>
-            <a:r>
-              <a:t>آيل ونرش واحد خادم</a:t>
-            </a:r>
-          </a:p>
-          <a:p>
-            <a:r>
-              <a:t>مع ،تلقائ ًيا ُينرش ثم ب الختبارات يمر تحديث كل</a:t>
-            </a:r>
-          </a:p>
-          <a:p>
-            <a:r>
-              <a:t>.يشء اختل إن آيل وتراجع صحة فحص</a:t>
-            </a:r>
-          </a:p>
-          <a:p>
-            <a:r>
-              <a:t>تكلفة</a:t>
-            </a:r>
-          </a:p>
-          <a:p>
-            <a:r>
-              <a:t>لإلجابة سنت من أقل</a:t>
-            </a:r>
-          </a:p>
-          <a:p>
-            <a:r>
-              <a:t>إنفاق سقف مع ،المجاب للسؤال 0.0015$ قرابة</a:t>
-            </a:r>
-          </a:p>
-          <a:p>
-            <a:r>
-              <a:t>يضمن احتياطي ونموذج ،المزيانية يضبط وكلي يومي</a:t>
-            </a:r>
-          </a:p>
-          <a:p>
-            <a:r>
-              <a:t>.الستمرار</a:t>
-            </a:r>
-          </a:p>
-          <a:p>
-            <a:r>
-              <a:t>محتوى</a:t>
-            </a:r>
-          </a:p>
-          <a:p>
-            <a:r>
-              <a:t>المنتج داخل رشعية مراجعة</a:t>
-            </a:r>
-          </a:p>
-          <a:p>
-            <a:r>
-              <a:t>أي ويسحب المحتوى يعتمد الرشعي المراجع مكتب</a:t>
-            </a:r>
-          </a:p>
-          <a:p>
-            <a:r>
-              <a:t>سجل يف مو ّثقة مر ّخصة ومصادر ،بضغطة نسخة</a:t>
-            </a:r>
-          </a:p>
-          <a:p>
-            <a:r>
-              <a:t>.واحد</a:t>
-            </a:r>
-          </a:p>
-          <a:p>
-            <a:r>
-              <a:t>انتشار</a:t>
-            </a:r>
-          </a:p>
-          <a:p>
-            <a:r>
-              <a:t>الدعوية الجهات عرب</a:t>
-            </a:r>
-          </a:p>
-          <a:p>
-            <a:r>
-              <a:t>ويرى ،مرشديه ويدير ،برمز ينضم دعوي مكتب كل</a:t>
-            </a:r>
-          </a:p>
-          <a:p>
-            <a:r>
-              <a:t>.مج ّمعة لوحة يف أثره</a:t>
-            </a:r>
-          </a:p>
-          <a:p>
-            <a:r>
-              <a:t>تو ّس ع</a:t>
-            </a:r>
-          </a:p>
-          <a:p>
-            <a:r>
-              <a:t>نفسها بالبنية جديدة لغات</a:t>
-            </a:r>
-          </a:p>
-          <a:p>
-            <a:r>
-              <a:t>لغة وإضافة ،اللغات عرشات تتيح المعتمدة المصادر</a:t>
-            </a:r>
-          </a:p>
-          <a:p>
-            <a:r>
-              <a:t>.المنتج تغيري تحتاج ال</a:t>
-            </a:r>
-          </a:p>
-          <a:p>
-            <a:r>
-              <a:t>انفتاح</a:t>
-            </a:r>
-          </a:p>
-          <a:p>
-            <a:r>
-              <a:t>ومو ّثق من ّظ م كود</a:t>
-            </a:r>
-          </a:p>
-          <a:p>
-            <a:r>
-              <a:t>يف كلها والتشغيل والمصادر والقواعد المزيات وثائق</a:t>
-            </a:r>
-          </a:p>
-          <a:p>
-            <a:r>
-              <a:t>.تشغيله يستطيع فريق وأي ،المستودع</a:t>
-            </a:r>
-          </a:p>
-          <a:p>
-            <a:r>
-              <a:t>18 / 19</a:t>
+              <a:t>والمصادر الموثوقية</a:t>
+            </a:r>
+          </a:p>
+          <a:p>
+            <a:r>
+              <a:t>ومراجع وترخيص مصدر له نص كل</a:t>
+            </a:r>
+          </a:p>
+          <a:p>
+            <a:r>
+              <a:t>.ترخيص وبأي ،وكيف ،منه نأخذه ما :مصدر كل يو ّثق المستودع يف واحد سجل</a:t>
+            </a:r>
+          </a:p>
+          <a:p>
+            <a:r>
+              <a:t>المصدر</a:t>
+            </a:r>
+          </a:p>
+          <a:p>
+            <a:r>
+              <a:t>نأخذه ما</a:t>
+            </a:r>
+          </a:p>
+          <a:p>
+            <a:r>
+              <a:t>QuranEncالمعتمدة معانيه وترجمات القرآن نص</a:t>
+            </a:r>
+          </a:p>
+          <a:p>
+            <a:r>
+              <a:t>HadeethEncورشحها بدرجتها األحاديث</a:t>
+            </a:r>
+          </a:p>
+          <a:p>
+            <a:r>
+              <a:t>IslamHouseوالتالوات ،الجديد المسلم ومقاطع كتب</a:t>
+            </a:r>
+          </a:p>
+          <a:p>
+            <a:r>
+              <a:t>Quranpediaًآي ًآي الق ّراء تالوات</a:t>
+            </a:r>
+          </a:p>
+          <a:p>
+            <a:r>
+              <a:t>وجواب سؤال اإلسالم · باز ابن موقع</a:t>
+            </a:r>
+          </a:p>
+          <a:p>
+            <a:r>
+              <a:t>وإجابات فتاوى</a:t>
+            </a:r>
+          </a:p>
+          <a:p>
+            <a:r>
+              <a:t>الحالة</a:t>
+            </a:r>
+          </a:p>
+          <a:p>
+            <a:r>
+              <a:t>رفيق يفعله ماٍ</a:t>
+            </a:r>
+          </a:p>
+          <a:p>
+            <a:r>
+              <a:t>كا مصدر ال</a:t>
+            </a:r>
+          </a:p>
+          <a:p>
+            <a:r>
+              <a:t>مرش ًدا ويقرتح ،ذلك يقول</a:t>
+            </a:r>
+          </a:p>
+          <a:p>
+            <a:r>
+              <a:t>شخصية مسألة</a:t>
+            </a:r>
+          </a:p>
+          <a:p>
+            <a:r>
+              <a:t>العلم أهل إىل يحيلها</a:t>
+            </a:r>
+          </a:p>
+          <a:p>
+            <a:r>
+              <a:t>خالفية مسألة</a:t>
+            </a:r>
+          </a:p>
+          <a:p>
+            <a:r>
+              <a:t>ترجيح دون األقوال يعرض</a:t>
+            </a:r>
+          </a:p>
+          <a:p>
+            <a:r>
+              <a:t>السائل على خطر</a:t>
+            </a:r>
+          </a:p>
+          <a:p>
+            <a:r>
+              <a:t>فو ًرا طوارئ وأرقام إنسان</a:t>
+            </a:r>
+          </a:p>
+          <a:p>
+            <a:r>
+              <a:t>حديث أو قرآن نص</a:t>
+            </a:r>
+          </a:p>
+          <a:p>
+            <a:r>
+              <a:t>النموذج من ال ،البيانات قاعدة من</a:t>
+            </a:r>
+          </a:p>
+          <a:p>
+            <a:r>
+              <a:t>رفيق18 / 21</a:t>
             </a:r>
           </a:p>
         </p:txBody>
@@ -2235,97 +2367,187 @@
           <a:lstStyle/>
           <a:p>
             <a:r>
-              <a:t>الفريق</a:t>
-            </a:r>
-          </a:p>
-          <a:p>
-            <a:r>
-              <a:t>العويمر عبدالعزيز بن نارص</a:t>
-            </a:r>
-          </a:p>
-          <a:p>
-            <a:r>
-              <a:t>المنصة</a:t>
-            </a:r>
-          </a:p>
-          <a:p>
-            <a:r>
-              <a:t>العويمر خالد بن نارص</a:t>
-            </a:r>
-          </a:p>
-          <a:p>
-            <a:r>
-              <a:t>اليومية والممارسة التصميم نظام</a:t>
-            </a:r>
-          </a:p>
-          <a:p>
-            <a:r>
-              <a:t>الفوزان صالح بن مهند</a:t>
-            </a:r>
-          </a:p>
-          <a:p>
-            <a:r>
-              <a:t>والتحفزي التع ّلم</a:t>
-            </a:r>
-          </a:p>
-          <a:p>
-            <a:r>
-              <a:t>العمري عبدالعزيز بن مس ّلم</a:t>
-            </a:r>
-          </a:p>
-          <a:p>
-            <a:r>
-              <a:t>واألسئلة المعرفة</a:t>
-            </a:r>
-          </a:p>
-          <a:p>
-            <a:r>
-              <a:t>بنفسك ج ّربه</a:t>
-            </a:r>
-          </a:p>
-          <a:p>
-            <a:r>
-              <a:t>الموقع</a:t>
-            </a:r>
-          </a:p>
-          <a:p>
-            <a:r>
-              <a:t>rafeeq.nan.sa</a:t>
-            </a:r>
-          </a:p>
-          <a:p>
-            <a:r>
-              <a:t>التطبيق</a:t>
-            </a:r>
-          </a:p>
-          <a:p>
-            <a:r>
-              <a:t>rafeeq.nan.sa/app</a:t>
-            </a:r>
-          </a:p>
-          <a:p>
-            <a:r>
-              <a:t>الفيديو</a:t>
-            </a:r>
-          </a:p>
-          <a:p>
-            <a:r>
-              <a:t>youtube.com/shorts/NN3KVPgEf-4</a:t>
-            </a:r>
-          </a:p>
-          <a:p>
-            <a:r>
-              <a:t>الكود</a:t>
-            </a:r>
-          </a:p>
-          <a:p>
-            <a:r>
-              <a:t>github.com/rafeeq-muslim/rafeeq</a:t>
-            </a:r>
-          </a:p>
-          <a:p>
-            <a:r>
-              <a:t>.يحتاج حني بإنسان ويصله ،موثوقة مصادر من ويجيبه ،بلغته األوىل سنته يف الجديد المسلم يرافق · رفيق</a:t>
+              <a:t>والنتائج التقنيات</a:t>
+            </a:r>
+          </a:p>
+          <a:p>
+            <a:r>
+              <a:t>الفعلي التشغيل من وأرقام ،بسيطة بنية</a:t>
+            </a:r>
+          </a:p>
+          <a:p>
+            <a:r>
+              <a:t>.آيل وتراجع صحة فحص مع ،تلقائ ًيا ُينرش ثم ب الختبارات يمر تحديث كل</a:t>
+            </a:r>
+          </a:p>
+          <a:p>
+            <a:r>
+              <a:t>◧</a:t>
+            </a:r>
+          </a:p>
+          <a:p>
+            <a:r>
+              <a:t>الواجهة</a:t>
+            </a:r>
+          </a:p>
+          <a:p>
+            <a:r>
+              <a:t>تطبيق ،TypeScript و React</a:t>
+            </a:r>
+          </a:p>
+          <a:p>
+            <a:r>
+              <a:t>،اتصال دون يعمل تق ّدمي ويب</a:t>
+            </a:r>
+          </a:p>
+          <a:p>
+            <a:r>
+              <a:t>.خاص تصميم بنظام</a:t>
+            </a:r>
+          </a:p>
+          <a:p>
+            <a:r>
+              <a:t>⚙</a:t>
+            </a:r>
+          </a:p>
+          <a:p>
+            <a:r>
+              <a:t>الخادم</a:t>
+            </a:r>
+          </a:p>
+          <a:p>
+            <a:r>
+              <a:t>السؤال مسار :FastAPI</a:t>
+            </a:r>
+          </a:p>
+          <a:p>
+            <a:r>
+              <a:t>.والمرافقة ،والتع ّلم ،والتحقق</a:t>
+            </a:r>
+          </a:p>
+          <a:p>
+            <a:r>
+              <a:t>▦</a:t>
+            </a:r>
+          </a:p>
+          <a:p>
+            <a:r>
+              <a:t>البيانات</a:t>
+            </a:r>
+          </a:p>
+          <a:p>
+            <a:r>
+              <a:t>:pgvector و PostgreSQL</a:t>
+            </a:r>
+          </a:p>
+          <a:p>
+            <a:r>
+              <a:t>وفهرسها المعتمدة المقاطع</a:t>
+            </a:r>
+          </a:p>
+          <a:p>
+            <a:r>
+              <a:t>.الداليل</a:t>
+            </a:r>
+          </a:p>
+          <a:p>
+            <a:r>
+              <a:t>✧</a:t>
+            </a:r>
+          </a:p>
+          <a:p>
+            <a:r>
+              <a:t>النماذج</a:t>
+            </a:r>
+          </a:p>
+          <a:p>
+            <a:r>
+              <a:t>و DeepSeek و Gemma</a:t>
+            </a:r>
+          </a:p>
+          <a:p>
+            <a:r>
+              <a:t>.OpenRouter عرب BGE-M3</a:t>
+            </a:r>
+          </a:p>
+          <a:p>
+            <a:r>
+              <a:t>14/14</a:t>
+            </a:r>
+          </a:p>
+          <a:p>
+            <a:r>
+              <a:t>14/14</a:t>
+            </a:r>
+          </a:p>
+          <a:p>
+            <a:r>
+              <a:t>يف المصادر من ُأجيب عرب ًيا لسؤا اً</a:t>
+            </a:r>
+          </a:p>
+          <a:p>
+            <a:r>
+              <a:t>الحي الموقع</a:t>
+            </a:r>
+          </a:p>
+          <a:p>
+            <a:r>
+              <a:t>9/9</a:t>
+            </a:r>
+          </a:p>
+          <a:p>
+            <a:r>
+              <a:t>9/9</a:t>
+            </a:r>
+          </a:p>
+          <a:p>
+            <a:r>
+              <a:t>يف السؤال لنوع صحيح تصنيف</a:t>
+            </a:r>
+          </a:p>
+          <a:p>
+            <a:r>
+              <a:t>المو ّجه اختبار</a:t>
+            </a:r>
+          </a:p>
+          <a:p>
+            <a:r>
+              <a:t>$0.0015</a:t>
+            </a:r>
+          </a:p>
+          <a:p>
+            <a:r>
+              <a:t>$0.0015</a:t>
+            </a:r>
+          </a:p>
+          <a:p>
+            <a:r>
+              <a:t>إىل 9 يف ،الواحدة اإلجابة تكلفة</a:t>
+            </a:r>
+          </a:p>
+          <a:p>
+            <a:r>
+              <a:t>ثانية 15</a:t>
+            </a:r>
+          </a:p>
+          <a:p>
+            <a:r>
+              <a:t>+1,100</a:t>
+            </a:r>
+          </a:p>
+          <a:p>
+            <a:r>
+              <a:t>+1,100</a:t>
+            </a:r>
+          </a:p>
+          <a:p>
+            <a:r>
+              <a:t>القواعد يحرس ناجح آيل اختبار</a:t>
+            </a:r>
+          </a:p>
+          <a:p>
+            <a:r>
+              <a:t>رفيق19 / 21</a:t>
             </a:r>
           </a:p>
         </p:txBody>
@@ -2400,12 +2622,12 @@
           </a:p>
           <a:p>
             <a:r>
-              <a:t>األوىل سنتهم يف وحدهم ُيرتكون ثم ،اآلالف ُيسلم</a:t>
-            </a:r>
-          </a:p>
-          <a:p>
-            <a:r>
-              <a:t>.ضعيفة اإلسالم يوم بعد والمتابعة ،ومتضارب متف ّرق بلغتهم والمتاح ،بالعربية الموثوق المحتوى أغلب</a:t>
+              <a:t>وحدهم ُيرتكون ثم ،باآلالف اإلسالم يدخلون</a:t>
+            </a:r>
+          </a:p>
+          <a:p>
+            <a:r>
+              <a:t>.ضعيفة اإلسالم يوم بعد والمتابعة ،ومتضارب متف ّرق بلغاتهم وما ،بالعربية أغلبه الموثوق المحتوى :السنوات أصعب األوىل السنة</a:t>
             </a:r>
           </a:p>
           <a:p>
@@ -2415,17 +2637,22 @@
           </a:p>
           <a:p>
             <a:r>
-              <a:t>2019 بني المملكة يف جدي ًدا مسل ًما</a:t>
-            </a:r>
-          </a:p>
-          <a:p>
-            <a:r>
-              <a:t>2023 يف 163,319 منهم ،2023و</a:t>
-            </a:r>
-          </a:p>
-          <a:p>
-            <a:r>
-              <a:t>وحده</a:t>
+              <a:t>347,646</a:t>
+            </a:r>
+          </a:p>
+          <a:p>
+            <a:r>
+              <a:t>بني المملكة يف جدي ًدا مسل ًما</a:t>
+            </a:r>
+          </a:p>
+          <a:p>
+            <a:r>
+              <a:t>163,319 منهم ،2023و 2019</a:t>
+            </a:r>
+          </a:p>
+          <a:p>
+            <a:r>
+              <a:t>وحده 2023 يف</a:t>
             </a:r>
           </a:p>
           <a:p>
@@ -2435,12 +2662,17 @@
           </a:p>
           <a:p>
             <a:r>
-              <a:t>إسالمهم إعالن بعد وحيدين أصبحوا</a:t>
-            </a:r>
-          </a:p>
-          <a:p>
-            <a:r>
-              <a:t>حولهم لمن</a:t>
+              <a:t>43%</a:t>
+            </a:r>
+          </a:p>
+          <a:p>
+            <a:r>
+              <a:t>أعلنوا أن بعد وحيدين أصبحوا</a:t>
+            </a:r>
+          </a:p>
+          <a:p>
+            <a:r>
+              <a:t>حولهم لمن إسالمهم</a:t>
             </a:r>
           </a:p>
           <a:p>
@@ -2450,12 +2682,17 @@
           </a:p>
           <a:p>
             <a:r>
-              <a:t>وتل ّقى ،شكوكهم عن أجوبة يجدوا لم</a:t>
-            </a:r>
-          </a:p>
-          <a:p>
-            <a:r>
-              <a:t>خاطئة معلومات مثلهم</a:t>
+              <a:t>54%</a:t>
+            </a:r>
+          </a:p>
+          <a:p>
+            <a:r>
+              <a:t>،أسئلتهم عن أجوبة يجدوا لم</a:t>
+            </a:r>
+          </a:p>
+          <a:p>
+            <a:r>
+              <a:t>خاطئة معلومات مثلهم وتل ّقى</a:t>
             </a:r>
           </a:p>
           <a:p>
@@ -2465,57 +2702,372 @@
           </a:p>
           <a:p>
             <a:r>
-              <a:t>أنه مع ،مفي ًدا اإلنرتنت وجدوا فقط</a:t>
-            </a:r>
-          </a:p>
-          <a:p>
-            <a:r>
-              <a:t>استخدا ًم ا المساعدة مصادر أكرث ثاين</a:t>
-            </a:r>
-          </a:p>
-          <a:p>
-            <a:r>
-              <a:t>وافد عامل · جوزيف</a:t>
-            </a:r>
-          </a:p>
-          <a:p>
-            <a:r>
-              <a:t>دروس وال ،محدودان ورصيده ووقته ،التاغالوغية يتكلم</a:t>
-            </a:r>
-          </a:p>
-          <a:p>
-            <a:r>
-              <a:t>.بلغته</a:t>
-            </a:r>
-          </a:p>
-          <a:p>
-            <a:r>
-              <a:t>اإلنرتنت عرب أسلم · دانيال</a:t>
-            </a:r>
-          </a:p>
-          <a:p>
-            <a:r>
-              <a:t>.المحتوى من يثق بمن يعرف وال ،مدينته يف مسلمني يعرف ال</a:t>
-            </a:r>
-          </a:p>
-          <a:p>
-            <a:r>
-              <a:t>إسالمها تخفي · ليلى</a:t>
-            </a:r>
-          </a:p>
-          <a:p>
-            <a:r>
-              <a:t>.إنسان إىل فور ًيا طري ًقا وتحتاج ،التطبيق أحد يرى أن تخىش</a:t>
-            </a:r>
-          </a:p>
-          <a:p>
-            <a:r>
-              <a:t>.)2015( الغرب يف جدي ًدا مسل ًما 114 على أصول مركز استبانة ؛)2024 يناير ،واس عرب( اإلسالمية الشؤون وزارة :المصادر</a:t>
-            </a:r>
-          </a:p>
-          <a:p>
-            <a:r>
-              <a:t>02 / 19</a:t>
+              <a:t>38%</a:t>
+            </a:r>
+          </a:p>
+          <a:p>
+            <a:r>
+              <a:t>مع ،مفي ًدا اإلنرتنت وجدوا فقط</a:t>
+            </a:r>
+          </a:p>
+          <a:p>
+            <a:r>
+              <a:t>إليه يلجؤون ما أكرث ثاين أنه</a:t>
+            </a:r>
+          </a:p>
+          <a:p>
+            <a:r>
+              <a:t>.)2015( جدي ًدا مسل ًما 114 على أصول مركز استبانة ؛)2024 يناير ،واس( اإلسالمية الشؤون وزارة :المصادر</a:t>
+            </a:r>
+          </a:p>
+          <a:p>
+            <a:r>
+              <a:t>رفيق02 / 21</a:t>
+            </a:r>
+          </a:p>
+        </p:txBody>
+      </p:sp>
+      <p:sp>
+        <p:nvSpPr>
+          <p:cNvPr id="4" name="Slide Number Placeholder 3"/>
+          <p:cNvSpPr>
+            <a:spLocks noGrp="1"/>
+          </p:cNvSpPr>
+          <p:nvPr>
+            <p:ph type="sldNum" idx="5" sz="quarter"/>
+          </p:nvPr>
+        </p:nvSpPr>
+        <p:spPr/>
+      </p:sp>
+    </p:spTree>
+  </p:cSld>
+  <p:clrMapOvr>
+    <a:masterClrMapping/>
+  </p:clrMapOvr>
+</p:notes>
+</file>
+
+<file path=ppt/notesSlides/notesSlide20.xml><?xml version="1.0" encoding="utf-8"?>
+<p:notes xmlns:a="http://schemas.openxmlformats.org/drawingml/2006/main" xmlns:p="http://schemas.openxmlformats.org/presentationml/2006/main" xmlns:r="http://schemas.openxmlformats.org/officeDocument/2006/relationships">
+  <p:cSld>
+    <p:spTree>
+      <p:nvGrpSpPr>
+        <p:cNvPr id="1" name=""/>
+        <p:cNvGrpSpPr/>
+        <p:nvPr/>
+      </p:nvGrpSpPr>
+      <p:grpSpPr>
+        <a:xfrm>
+          <a:off x="0" y="0"/>
+          <a:ext cx="0" cy="0"/>
+          <a:chOff x="0" y="0"/>
+          <a:chExt cx="0" cy="0"/>
+        </a:xfrm>
+      </p:grpSpPr>
+      <p:sp>
+        <p:nvSpPr>
+          <p:cNvPr id="2" name="Slide Image Placeholder 1"/>
+          <p:cNvSpPr>
+            <a:spLocks noGrp="1"/>
+          </p:cNvSpPr>
+          <p:nvPr>
+            <p:ph type="sldImg" idx="2"/>
+          </p:nvPr>
+        </p:nvSpPr>
+        <p:spPr/>
+      </p:sp>
+      <p:sp>
+        <p:nvSpPr>
+          <p:cNvPr id="3" name="Notes Placeholder 2"/>
+          <p:cNvSpPr>
+            <a:spLocks noGrp="1"/>
+          </p:cNvSpPr>
+          <p:nvPr>
+            <p:ph type="body" idx="3" sz="quarter"/>
+          </p:nvPr>
+        </p:nvSpPr>
+        <p:spPr/>
+        <p:txBody>
+          <a:bodyPr/>
+          <a:lstStyle/>
+          <a:p>
+            <a:r>
+              <a:t>و الستمرار المضافة القيمة</a:t>
+            </a:r>
+          </a:p>
+          <a:p>
+            <a:r>
+              <a:t>غريه يف يجتمع ال رفيق يجمعه ما</a:t>
+            </a:r>
+          </a:p>
+          <a:p>
+            <a:r>
+              <a:t>.واحد تطبيق يف ،لغات بثالث ،يومية وأدوات ،برشي ومرشد ،مو ّثق ومساعد ،تع ّلمي مسار</a:t>
+            </a:r>
+          </a:p>
+          <a:p>
+            <a:r>
+              <a:t>عامة اصطناعي ذكاء محادثة مقابل</a:t>
+            </a:r>
+          </a:p>
+          <a:p>
+            <a:r>
+              <a:t>يكتبه ال رشعي ونص ،جملة لكل معروف مصدر</a:t>
+            </a:r>
+          </a:p>
+          <a:p>
+            <a:r>
+              <a:t>.الحاجة عند وإنسان ،نموذج</a:t>
+            </a:r>
+          </a:p>
+          <a:p>
+            <a:r>
+              <a:t>والمواقع الكت ّيبات مقابل</a:t>
+            </a:r>
+          </a:p>
+          <a:p>
+            <a:r>
+              <a:t>،معه تتك ّيف ومراجعة ،مستواه يعرف تد ّرج</a:t>
+            </a:r>
+          </a:p>
+          <a:p>
+            <a:r>
+              <a:t>.وبلغته</a:t>
+            </a:r>
+          </a:p>
+          <a:p>
+            <a:r>
+              <a:t>التواصل وسائل مقابل</a:t>
+            </a:r>
+          </a:p>
+          <a:p>
+            <a:r>
+              <a:t>،جنسه من موثوق ومرشد ،معتمد محتوى</a:t>
+            </a:r>
+          </a:p>
+          <a:p>
+            <a:r>
+              <a:t>.تحميه وخصوصية</a:t>
+            </a:r>
+          </a:p>
+          <a:p>
+            <a:r>
+              <a:t>جديدة لغات</a:t>
+            </a:r>
+          </a:p>
+          <a:p>
+            <a:r>
+              <a:t>والبنية ،اللغات عرشات تتيح المعتمدة المصادر</a:t>
+            </a:r>
+          </a:p>
+          <a:p>
+            <a:r>
+              <a:t>.تستقبلها نفسها</a:t>
+            </a:r>
+          </a:p>
+          <a:p>
+            <a:r>
+              <a:t>الدعوية الجهات عرب</a:t>
+            </a:r>
+          </a:p>
+          <a:p>
+            <a:r>
+              <a:t>،مرشديه ويدير ،برمز ينضم دعوي مكتب كل</a:t>
+            </a:r>
+          </a:p>
+          <a:p>
+            <a:r>
+              <a:t>.أثره ويرى</a:t>
+            </a:r>
+          </a:p>
+          <a:p>
+            <a:r>
+              <a:t>الكلفة قليل تشغيل</a:t>
+            </a:r>
+          </a:p>
+          <a:p>
+            <a:r>
+              <a:t>ومراجعة ،لإلجابة سنت من وأقل ،واحد خادم</a:t>
+            </a:r>
+          </a:p>
+          <a:p>
+            <a:r>
+              <a:t>.المنتج داخل رشعية</a:t>
+            </a:r>
+          </a:p>
+          <a:p>
+            <a:r>
+              <a:t>رفيق20 / 21</a:t>
+            </a:r>
+          </a:p>
+        </p:txBody>
+      </p:sp>
+      <p:sp>
+        <p:nvSpPr>
+          <p:cNvPr id="4" name="Slide Number Placeholder 3"/>
+          <p:cNvSpPr>
+            <a:spLocks noGrp="1"/>
+          </p:cNvSpPr>
+          <p:nvPr>
+            <p:ph type="sldNum" idx="5" sz="quarter"/>
+          </p:nvPr>
+        </p:nvSpPr>
+        <p:spPr/>
+      </p:sp>
+    </p:spTree>
+  </p:cSld>
+  <p:clrMapOvr>
+    <a:masterClrMapping/>
+  </p:clrMapOvr>
+</p:notes>
+</file>
+
+<file path=ppt/notesSlides/notesSlide21.xml><?xml version="1.0" encoding="utf-8"?>
+<p:notes xmlns:a="http://schemas.openxmlformats.org/drawingml/2006/main" xmlns:p="http://schemas.openxmlformats.org/presentationml/2006/main" xmlns:r="http://schemas.openxmlformats.org/officeDocument/2006/relationships">
+  <p:cSld>
+    <p:spTree>
+      <p:nvGrpSpPr>
+        <p:cNvPr id="1" name=""/>
+        <p:cNvGrpSpPr/>
+        <p:nvPr/>
+      </p:nvGrpSpPr>
+      <p:grpSpPr>
+        <a:xfrm>
+          <a:off x="0" y="0"/>
+          <a:ext cx="0" cy="0"/>
+          <a:chOff x="0" y="0"/>
+          <a:chExt cx="0" cy="0"/>
+        </a:xfrm>
+      </p:grpSpPr>
+      <p:sp>
+        <p:nvSpPr>
+          <p:cNvPr id="2" name="Slide Image Placeholder 1"/>
+          <p:cNvSpPr>
+            <a:spLocks noGrp="1"/>
+          </p:cNvSpPr>
+          <p:nvPr>
+            <p:ph type="sldImg" idx="2"/>
+          </p:nvPr>
+        </p:nvSpPr>
+        <p:spPr/>
+      </p:sp>
+      <p:sp>
+        <p:nvSpPr>
+          <p:cNvPr id="3" name="Notes Placeholder 2"/>
+          <p:cNvSpPr>
+            <a:spLocks noGrp="1"/>
+          </p:cNvSpPr>
+          <p:nvPr>
+            <p:ph type="body" idx="3" sz="quarter"/>
+          </p:nvPr>
+        </p:nvSpPr>
+        <p:spPr/>
+        <p:txBody>
+          <a:bodyPr/>
+          <a:lstStyle/>
+          <a:p>
+            <a:r>
+              <a:t>الفريق</a:t>
+            </a:r>
+          </a:p>
+          <a:p>
+            <a:r>
+              <a:t>عبدالعزيز بن نارص</a:t>
+            </a:r>
+          </a:p>
+          <a:p>
+            <a:r>
+              <a:t>العويمر</a:t>
+            </a:r>
+          </a:p>
+          <a:p>
+            <a:r>
+              <a:t>المنصة</a:t>
+            </a:r>
+          </a:p>
+          <a:p>
+            <a:r>
+              <a:t>العويمر خالد بن نارص</a:t>
+            </a:r>
+          </a:p>
+          <a:p>
+            <a:r>
+              <a:t>اليومية والممارسة التصميم نظام</a:t>
+            </a:r>
+          </a:p>
+          <a:p>
+            <a:r>
+              <a:t>الفوزان صالح بن مهند</a:t>
+            </a:r>
+          </a:p>
+          <a:p>
+            <a:r>
+              <a:t>والتحفزي التع ّلم</a:t>
+            </a:r>
+          </a:p>
+          <a:p>
+            <a:r>
+              <a:t>عبدالعزيز بن مس ّلم</a:t>
+            </a:r>
+          </a:p>
+          <a:p>
+            <a:r>
+              <a:t>العمري</a:t>
+            </a:r>
+          </a:p>
+          <a:p>
+            <a:r>
+              <a:t>واألسئلة المعرفة</a:t>
+            </a:r>
+          </a:p>
+          <a:p>
+            <a:r>
+              <a:t>اآلن ج ّربه</a:t>
+            </a:r>
+          </a:p>
+          <a:p>
+            <a:r>
+              <a:t>.تثبيت ودون حساب دون ،الرابط من يفتح</a:t>
+            </a:r>
+          </a:p>
+          <a:p>
+            <a:r>
+              <a:t>التطبيق</a:t>
+            </a:r>
+          </a:p>
+          <a:p>
+            <a:r>
+              <a:t>rafeeq.nan.sa/app</a:t>
+            </a:r>
+          </a:p>
+          <a:p>
+            <a:r>
+              <a:t>التعريف صفحة</a:t>
+            </a:r>
+          </a:p>
+          <a:p>
+            <a:r>
+              <a:t>rafeeq.nan.sa</a:t>
+            </a:r>
+          </a:p>
+          <a:p>
+            <a:r>
+              <a:t>الفيديو</a:t>
+            </a:r>
+          </a:p>
+          <a:p>
+            <a:r>
+              <a:t>youtube.com/shorts/NN3KVPgEf-4</a:t>
+            </a:r>
+          </a:p>
+          <a:p>
+            <a:r>
+              <a:t>الكود</a:t>
+            </a:r>
+          </a:p>
+          <a:p>
+            <a:r>
+              <a:t>github.com/rafeeq-muslim/rafeeq</a:t>
             </a:r>
           </a:p>
         </p:txBody>
@@ -2585,112 +3137,97 @@
           <a:lstStyle/>
           <a:p>
             <a:r>
-              <a:t>النجاح ومعيار المستفيد</a:t>
-            </a:r>
-          </a:p>
-          <a:p>
-            <a:r>
-              <a:t>الثالث المسار يطلبه بما النجاح نقيس</a:t>
-            </a:r>
-          </a:p>
-          <a:p>
-            <a:r>
-              <a:t>.ومراجعني مرشدين من يرافقه ومن ،التاغالوغية أو اإلنجلزيية أو بالعربية ،األوىل سنته يف الجديد المسلم :المستفيد</a:t>
-            </a:r>
-          </a:p>
-          <a:p>
-            <a:r>
-              <a:t>المسار نجاح معيار</a:t>
-            </a:r>
-          </a:p>
-          <a:p>
-            <a:r>
-              <a:t>فهم تحسني يف ،المستهدفة الفئة مع اختباره عند ،الحل أسهم هل</a:t>
-            </a:r>
-          </a:p>
-          <a:p>
-            <a:r>
-              <a:t>،الرحلة واستمرارية وتسلسله المحتوى مالءمة يف أو ،إسالمي مفهوم</a:t>
-            </a:r>
-          </a:p>
-          <a:p>
-            <a:r>
-              <a:t>الحساسة أو الدينية السمات استنتاج وعدم بالخصوصية اللزتام مع</a:t>
-            </a:r>
-          </a:p>
-          <a:p>
-            <a:r>
-              <a:t>للمستخدم؟</a:t>
-            </a:r>
-          </a:p>
-          <a:p>
-            <a:r>
-              <a:t>الجانب</a:t>
-            </a:r>
-          </a:p>
-          <a:p>
-            <a:r>
-              <a:t>رفيق يف نقيسه كيف</a:t>
-            </a:r>
-          </a:p>
-          <a:p>
-            <a:r>
-              <a:t>الفهم</a:t>
-            </a:r>
-          </a:p>
-          <a:p>
-            <a:r>
-              <a:t>المراجعة يف يو ًم ا 30و 7 بعد منه التحقق ثم ،التمارين يف تع ّلمي هدف كل إتقان</a:t>
-            </a:r>
-          </a:p>
-          <a:p>
-            <a:r>
-              <a:t>مالءمة</a:t>
-            </a:r>
-          </a:p>
-          <a:p>
-            <a:r>
-              <a:t>التسلسل</a:t>
-            </a:r>
-          </a:p>
-          <a:p>
-            <a:r>
-              <a:t>6 من متد ّرج ومسار ،المناسبة الوحدات يفتح اختياري مستوى تحديد اختبار</a:t>
-            </a:r>
-          </a:p>
-          <a:p>
-            <a:r>
-              <a:t>وحدات</a:t>
-            </a:r>
-          </a:p>
-          <a:p>
-            <a:r>
-              <a:t>الستمرار)الفريق مؤرشات( الوحدات وإتمام ،والسلسلة ،يو ًم ا 30و 7 بعد العودة</a:t>
-            </a:r>
-          </a:p>
-          <a:p>
-            <a:r>
-              <a:t>اإلحالة</a:t>
-            </a:r>
-          </a:p>
-          <a:p>
-            <a:r>
-              <a:t>آل ًيا ذلك و ُيخترب ،إنسان إىل يصل شخيص أو خ ِط ر سؤال كل</a:t>
-            </a:r>
-          </a:p>
-          <a:p>
-            <a:r>
-              <a:t>الخصوصية</a:t>
-            </a:r>
-          </a:p>
-          <a:p>
-            <a:r>
-              <a:t>النموذج طلبات يف مع ّرف أي يدخل ال ُيص ّنف؛ وال المستخدم دين ُيستنتج ال</a:t>
-            </a:r>
-          </a:p>
-          <a:p>
-            <a:r>
-              <a:t>03 / 19</a:t>
+              <a:t>رفيق ُص نع لمن</a:t>
+            </a:r>
+          </a:p>
+          <a:p>
+            <a:r>
+              <a:t>قرار كل يف نراها وجوه ثالثة</a:t>
+            </a:r>
+          </a:p>
+          <a:p>
+            <a:r>
+              <a:t>.ُيكشف أن من خوف أو ،ضيق وقت أو ،لغة :منهم واحد حاجة من جاءت رفيق يف شاشة كل</a:t>
+            </a:r>
+          </a:p>
+          <a:p>
+            <a:r>
+              <a:t>ج</a:t>
+            </a:r>
+          </a:p>
+          <a:p>
+            <a:r>
+              <a:t>جوزيف</a:t>
+            </a:r>
+          </a:p>
+          <a:p>
+            <a:r>
+              <a:t>،التاغالوغية لغته .أسابيع قبل أسلم وافد عامل</a:t>
+            </a:r>
+          </a:p>
+          <a:p>
+            <a:r>
+              <a:t>درو ًس ا يحتاج .محدودان جواله ورصيد ووقته</a:t>
+            </a:r>
+          </a:p>
+          <a:p>
+            <a:r>
+              <a:t>.اتصال دون تعمل بلغته قصرية</a:t>
+            </a:r>
+          </a:p>
+          <a:p>
+            <a:r>
+              <a:t>د</a:t>
+            </a:r>
+          </a:p>
+          <a:p>
+            <a:r>
+              <a:t>دانيال</a:t>
+            </a:r>
+          </a:p>
+          <a:p>
+            <a:r>
+              <a:t>.مدينته يف مسل ًما يعرف وال اإلنرتنت عرب أسلم</a:t>
+            </a:r>
+          </a:p>
+          <a:p>
+            <a:r>
+              <a:t>حني يسأله وإنسا ًنا ،بمصدرها يثق إجابة يحتاج</a:t>
+            </a:r>
+          </a:p>
+          <a:p>
+            <a:r>
+              <a:t>.الشاشة تكفي ال</a:t>
+            </a:r>
+          </a:p>
+          <a:p>
+            <a:r>
+              <a:t>ل</a:t>
+            </a:r>
+          </a:p>
+          <a:p>
+            <a:r>
+              <a:t>ليلى</a:t>
+            </a:r>
+          </a:p>
+          <a:p>
+            <a:r>
+              <a:t>تحتاج .أرستها عن إسالمها وتخفي أسلمت</a:t>
+            </a:r>
+          </a:p>
+          <a:p>
+            <a:r>
+              <a:t>،رسي ًعا وخرو ًجا ،خف ًيا وض ًعا :يكشفها ال تطبي ًقا</a:t>
+            </a:r>
+          </a:p>
+          <a:p>
+            <a:r>
+              <a:t>.يعينها من إىل آم ًنا وطري ًقا</a:t>
+            </a:r>
+          </a:p>
+          <a:p>
+            <a:r>
+              <a:t>رفيق03 / 21</a:t>
             </a:r>
           </a:p>
         </p:txBody>
@@ -2765,97 +3302,112 @@
           </a:p>
           <a:p>
             <a:r>
-              <a:t>بلغته الجديد المسلم يرافق ويب تطبيق :رفيق</a:t>
-            </a:r>
-          </a:p>
-          <a:p>
-            <a:r>
-              <a:t>.محله يحل وال اإلنسان يساند الصطناعي الذكاء .زيارة أول بعد اتصال دون ويعمل ،المتصفح من و ُيث ّبت ،متجر دون جوال أي على يعمل</a:t>
-            </a:r>
-          </a:p>
-          <a:p>
-            <a:r>
-              <a:t>01</a:t>
-            </a:r>
-          </a:p>
-          <a:p>
-            <a:r>
-              <a:t>متد ّرج تع ّلم مسار</a:t>
-            </a:r>
-          </a:p>
-          <a:p>
-            <a:r>
-              <a:t>قصرية بطاقات …والصالة ،والطهارة ،الشهادتان :لغات بثالث در ًس ا 25و وحدات 6</a:t>
-            </a:r>
-          </a:p>
-          <a:p>
-            <a:r>
-              <a:t>.إتقا ًنا األقل لألهداف تك ّيفية ومراجعة ،وتمارين</a:t>
-            </a:r>
-          </a:p>
-          <a:p>
-            <a:r>
-              <a:t>02</a:t>
-            </a:r>
-          </a:p>
-          <a:p>
-            <a:r>
-              <a:t>معتمدة بمصادر »رفيق اسأل«</a:t>
-            </a:r>
-          </a:p>
-          <a:p>
-            <a:r>
-              <a:t>قبل إجابة تظهر وال ،إجابة كل مع المصدر ويعرض ،فقط معتمدة نصوص من يجيب</a:t>
-            </a:r>
-          </a:p>
-          <a:p>
-            <a:r>
-              <a:t>.التحقق تجتاز أن</a:t>
-            </a:r>
-          </a:p>
-          <a:p>
-            <a:r>
-              <a:t>03</a:t>
-            </a:r>
-          </a:p>
-          <a:p>
-            <a:r>
-              <a:t>واإلحالة البرشية المرافقة</a:t>
-            </a:r>
-          </a:p>
-          <a:p>
-            <a:r>
-              <a:t>المستفيد جنس من ومرشد ،والمساعد والمراجعة الدرس يف »إنسا ًنا أريد« زر</a:t>
-            </a:r>
-          </a:p>
-          <a:p>
-            <a:r>
-              <a:t>.صغرية ومجموعات ،وبلغته</a:t>
-            </a:r>
-          </a:p>
-          <a:p>
-            <a:r>
-              <a:t>04</a:t>
-            </a:r>
-          </a:p>
-          <a:p>
-            <a:r>
-              <a:t>اليوم أدوات</a:t>
-            </a:r>
-          </a:p>
-          <a:p>
-            <a:r>
-              <a:t>مختارة ومكتبة ،للقرآن واستماع ،وأذكار ،الجهاز على محسوبة والقبلة الصالة مواقيت</a:t>
-            </a:r>
-          </a:p>
-          <a:p>
-            <a:r>
-              <a:t>.لمرحلته</a:t>
-            </a:r>
-          </a:p>
-          <a:p>
-            <a:r>
-              <a:t>04 / 19</a:t>
+              <a:t>واحد تطبيق يف وإنسان ،ومساعد ،مسار :رفيق</a:t>
+            </a:r>
+          </a:p>
+          <a:p>
+            <a:r>
+              <a:t>.والتاغالوغية واإلنجلزيية بالعربية ،اتصال ودون حساب دون يعمل ،متجر دون جوال أي على ُيث َّبت ويب تطبيق</a:t>
+            </a:r>
+          </a:p>
+          <a:p>
+            <a:r>
+              <a:t>١</a:t>
+            </a:r>
+          </a:p>
+          <a:p>
+            <a:r>
+              <a:t>يتع ّلم</a:t>
+            </a:r>
+          </a:p>
+          <a:p>
+            <a:r>
+              <a:t>قصرية دروس من متد ّرج مسار</a:t>
+            </a:r>
+          </a:p>
+          <a:p>
+            <a:r>
+              <a:t>الشهادتني من يبدأ ،وتمارين</a:t>
+            </a:r>
+          </a:p>
+          <a:p>
+            <a:r>
+              <a:t>.والصالة والوضوء</a:t>
+            </a:r>
+          </a:p>
+          <a:p>
+            <a:r>
+              <a:t>٢</a:t>
+            </a:r>
+          </a:p>
+          <a:p>
+            <a:r>
+              <a:t>يسأل</a:t>
+            </a:r>
+          </a:p>
+          <a:p>
+            <a:r>
+              <a:t>المصادر من يجيب مساعد</a:t>
+            </a:r>
+          </a:p>
+          <a:p>
+            <a:r>
+              <a:t>مصدر ويعرض ،وحدها المعتمدة</a:t>
+            </a:r>
+          </a:p>
+          <a:p>
+            <a:r>
+              <a:t>.إجابة كل</a:t>
+            </a:r>
+          </a:p>
+          <a:p>
+            <a:r>
+              <a:t>٣</a:t>
+            </a:r>
+          </a:p>
+          <a:p>
+            <a:r>
+              <a:t>ُيرا َفق</a:t>
+            </a:r>
+          </a:p>
+          <a:p>
+            <a:r>
+              <a:t>،شاشة كل يف »إنسا ًنا أريد« زر</a:t>
+            </a:r>
+          </a:p>
+          <a:p>
+            <a:r>
+              <a:t>.وبلغته جنسه من بمرشد يصله</a:t>
+            </a:r>
+          </a:p>
+          <a:p>
+            <a:r>
+              <a:t>٤</a:t>
+            </a:r>
+          </a:p>
+          <a:p>
+            <a:r>
+              <a:t>يومه يعيش</a:t>
+            </a:r>
+          </a:p>
+          <a:p>
+            <a:r>
+              <a:t>واألذكار والقبلة الصالة مواقيت</a:t>
+            </a:r>
+          </a:p>
+          <a:p>
+            <a:r>
+              <a:t>على ومحفوظة محسوبة ،والقرآن</a:t>
+            </a:r>
+          </a:p>
+          <a:p>
+            <a:r>
+              <a:t>.جهازه</a:t>
+            </a:r>
+          </a:p>
+          <a:p>
+            <a:r>
+              <a:t>رفيق04 / 21</a:t>
             </a:r>
           </a:p>
         </p:txBody>
@@ -2930,7 +3482,7 @@
           </a:p>
           <a:p>
             <a:r>
-              <a:t>المتابعة إىل فتح أول من المستفيد رحلة</a:t>
+              <a:t>المتابعة إىل فتح أول من واحدة رحلة</a:t>
             </a:r>
           </a:p>
           <a:p>
@@ -2950,27 +3502,17 @@
           </a:p>
           <a:p>
             <a:r>
-              <a:t>ثالثة ثم ،لغته يختار</a:t>
-            </a:r>
-          </a:p>
-          <a:p>
-            <a:r>
-              <a:t>مستوى واختبار ،وعود</a:t>
-            </a:r>
-          </a:p>
-          <a:p>
-            <a:r>
-              <a:t>حساب ال .اختياري</a:t>
-            </a:r>
-          </a:p>
-          <a:p>
-            <a:r>
-              <a:t>.مطلوب</a:t>
-            </a:r>
-          </a:p>
-          <a:p>
-            <a:r>
-              <a:t>←</a:t>
+              <a:t>دون ويبدأ ،لغته يختار</a:t>
+            </a:r>
+          </a:p>
+          <a:p>
+            <a:r>
+              <a:t>سؤال أي ودون حساب</a:t>
+            </a:r>
+          </a:p>
+          <a:p>
+            <a:r>
+              <a:t>شخيص</a:t>
             </a:r>
           </a:p>
           <a:p>
@@ -2985,22 +3527,12 @@
           </a:p>
           <a:p>
             <a:r>
-              <a:t>يف لأو اً التالية الخطوة</a:t>
-            </a:r>
-          </a:p>
-          <a:p>
-            <a:r>
-              <a:t>ودرس ،مر ّتبة رئيسية</a:t>
-            </a:r>
-          </a:p>
-          <a:p>
-            <a:r>
-              <a:t>.دقائق من</a:t>
-            </a:r>
-          </a:p>
-          <a:p>
-            <a:r>
-              <a:t>←</a:t>
+              <a:t>،دائ ًما أمامه التالية الخطوة</a:t>
+            </a:r>
+          </a:p>
+          <a:p>
+            <a:r>
+              <a:t>دقائق يف ودرس</a:t>
             </a:r>
           </a:p>
           <a:p>
@@ -3015,22 +3547,12 @@
           </a:p>
           <a:p>
             <a:r>
-              <a:t>السبب ُيرشح الخطأ عند</a:t>
-            </a:r>
-          </a:p>
-          <a:p>
-            <a:r>
-              <a:t>البطاقة نص من</a:t>
-            </a:r>
-          </a:p>
-          <a:p>
-            <a:r>
-              <a:t>.المعتمدة</a:t>
-            </a:r>
-          </a:p>
-          <a:p>
-            <a:r>
-              <a:t>←</a:t>
+              <a:t>سببه ورشح ،آمن الخطأ</a:t>
+            </a:r>
+          </a:p>
+          <a:p>
+            <a:r>
+              <a:t>المعتمد النص من بلغته</a:t>
             </a:r>
           </a:p>
           <a:p>
@@ -3045,22 +3567,12 @@
           </a:p>
           <a:p>
             <a:r>
-              <a:t>على أهداف خمسة</a:t>
-            </a:r>
-          </a:p>
-          <a:p>
-            <a:r>
-              <a:t>7 بعد والتحقق ،األكرث</a:t>
-            </a:r>
-          </a:p>
-          <a:p>
-            <a:r>
-              <a:t>.يو ًم ا 30و</a:t>
-            </a:r>
-          </a:p>
-          <a:p>
-            <a:r>
-              <a:t>←</a:t>
+              <a:t>بعد ،يتقنه لم ما إليه يعود</a:t>
+            </a:r>
+          </a:p>
+          <a:p>
+            <a:r>
+              <a:t>أسابيع ثم أيام</a:t>
             </a:r>
           </a:p>
           <a:p>
@@ -3075,12 +3587,7 @@
           </a:p>
           <a:p>
             <a:r>
-              <a:t>أي يف بلغته رفيق يسأل</a:t>
-            </a:r>
-          </a:p>
-          <a:p>
-            <a:r>
-              <a:t>.لحظة←</a:t>
+              <a:t>لحظة أي يف بلغته يسأل</a:t>
             </a:r>
           </a:p>
           <a:p>
@@ -3100,37 +3607,57 @@
           </a:p>
           <a:p>
             <a:r>
-              <a:t>أو ،بمصدرها إجابة</a:t>
-            </a:r>
-          </a:p>
-          <a:p>
-            <a:r>
-              <a:t>إحالة أو ،واضح اعتذار</a:t>
-            </a:r>
-          </a:p>
-          <a:p>
-            <a:r>
-              <a:t>.مرشد إىل</a:t>
-            </a:r>
-          </a:p>
-          <a:p>
-            <a:r>
-              <a:t>.اتصال دون معه يبقى المسار من ُيفتح ما.درس أول بعد بهدوء و ُيعرض ،اختياري الحساب</a:t>
-            </a:r>
-          </a:p>
-          <a:p>
-            <a:r>
-              <a:t>طلب أي دون إنسان إىل فورية إحالة :الخطر يف</a:t>
-            </a:r>
-          </a:p>
-          <a:p>
-            <a:r>
-              <a:t>.للنموذج</a:t>
-            </a:r>
-          </a:p>
-          <a:p>
-            <a:r>
-              <a:t>05 / 19</a:t>
+              <a:t>طريق أو ،بمصدرها إجابة</a:t>
+            </a:r>
+          </a:p>
+          <a:p>
+            <a:r>
+              <a:t>مرشد إىل مبارش</a:t>
+            </a:r>
+          </a:p>
+          <a:p>
+            <a:r>
+              <a:t>اتصال دون يعمل</a:t>
+            </a:r>
+          </a:p>
+          <a:p>
+            <a:r>
+              <a:t>المواقيت ومعه ،معه يبقى المسار من فتحه ما</a:t>
+            </a:r>
+          </a:p>
+          <a:p>
+            <a:r>
+              <a:t>.واألذكار</a:t>
+            </a:r>
+          </a:p>
+          <a:p>
+            <a:r>
+              <a:t>اختياري الحساب</a:t>
+            </a:r>
+          </a:p>
+          <a:p>
+            <a:r>
+              <a:t>.تق ّدمه إليه وينتقل ،درس أول بعد بهدوء ُيعرض</a:t>
+            </a:r>
+          </a:p>
+          <a:p>
+            <a:r>
+              <a:t>لأو اً الخطر</a:t>
+            </a:r>
+          </a:p>
+          <a:p>
+            <a:r>
+              <a:t>أي قبل ،فو ًرا إنسان إىل يصل خطر على يدل ما</a:t>
+            </a:r>
+          </a:p>
+          <a:p>
+            <a:r>
+              <a:t>.نموذج</a:t>
+            </a:r>
+          </a:p>
+          <a:p>
+            <a:r>
+              <a:t>رفيق05 / 21</a:t>
             </a:r>
           </a:p>
         </p:txBody>
@@ -3200,142 +3727,112 @@
           <a:lstStyle/>
           <a:p>
             <a:r>
-              <a:t>)3 من 1( رفيق يف ما</a:t>
-            </a:r>
-          </a:p>
-          <a:p>
-            <a:r>
-              <a:t>واحد مكان يف ويسأل يتع ّلم</a:t>
-            </a:r>
-          </a:p>
-          <a:p>
-            <a:r>
-              <a:t>.إجابة كل مصدر ويعرض المعتمدة المصادر من يجيبه ومساعد ،المتع ّلم وصل أين يعرف متد ّرج مسار</a:t>
-            </a:r>
-          </a:p>
-          <a:p>
-            <a:r>
-              <a:t>التع ّلمي المسار</a:t>
-            </a:r>
-          </a:p>
-          <a:p>
-            <a:r>
-              <a:t>والصالة والطهارة الشهادتني من تبدأ قصرية ودروس وحدات</a:t>
-            </a:r>
-          </a:p>
-          <a:p>
-            <a:r>
-              <a:t>بطاقات مجموعة كل بعد التفاعلية التمارين من أنواع ثالثة</a:t>
-            </a:r>
-          </a:p>
-          <a:p>
-            <a:r>
-              <a:t>الح ًقا السؤال يعود ثم ،وسببه الصواب يرى :آمن الخطأ</a:t>
-            </a:r>
-          </a:p>
-          <a:p>
-            <a:r>
-              <a:t>المناسبة الوحدة يف يضعه اختياري مستوى تحديد اختبار</a:t>
-            </a:r>
-          </a:p>
-          <a:p>
-            <a:r>
-              <a:t>متباعدة فرتات على ،بعد يتقنه لم ما مع تتك ّيف مراجعة</a:t>
-            </a:r>
-          </a:p>
-          <a:p>
-            <a:r>
-              <a:t>نفسه الدرس</a:t>
-            </a:r>
-          </a:p>
-          <a:p>
-            <a:r>
-              <a:t>وتالوتها بلغته معناها ومعها المصحف بخط كاملة آيات بطاقات</a:t>
-            </a:r>
-          </a:p>
-          <a:p>
-            <a:r>
-              <a:t>المعتمدة البطاقة نص من الخطأ لسبب بلغته رشح :»لماذا؟«</a:t>
-            </a:r>
-          </a:p>
-          <a:p>
-            <a:r>
-              <a:t>التالية وخطوته أتقنه بما درس كل بعد يخربه تعليمي مو ّجه</a:t>
-            </a:r>
-          </a:p>
-          <a:p>
-            <a:r>
-              <a:t>والصالة الوضوء لخطوات وصور فيديو</a:t>
-            </a:r>
-          </a:p>
-          <a:p>
-            <a:r>
-              <a:t>يومه يف يحتاجه ما ثم ، لأو اً التالية الخطوة :مر ّتبة رئيسية</a:t>
-            </a:r>
-          </a:p>
-          <a:p>
-            <a:r>
-              <a:t>»رفيق اسأل«</a:t>
-            </a:r>
-          </a:p>
-          <a:p>
-            <a:r>
-              <a:t>مصادرها بطاقات إجابة كل ومع ،وحدها المعتمدة المصادر من إجابة</a:t>
-            </a:r>
-          </a:p>
-          <a:p>
-            <a:r>
-              <a:t>السؤال يحتاج حني المعتمدة الفتوى مواقع يف حي بحث</a:t>
-            </a:r>
-          </a:p>
-          <a:p>
-            <a:r>
-              <a:t>الشائعة لألسئلة الرشعي المراجع اعتمدها جاهزة إجابات</a:t>
-            </a:r>
-          </a:p>
-          <a:p>
-            <a:r>
-              <a:t>بإنسان ويصله الطوارئ أرقام فيعرض ، لأو اً ُيكتشف الخطر</a:t>
-            </a:r>
-          </a:p>
-          <a:p>
-            <a:r>
-              <a:t>اتصال دون إليها للرجوع واألحاديث واآليات اإلجابات حفظ</a:t>
-            </a:r>
-          </a:p>
-          <a:p>
-            <a:r>
-              <a:t>المعرفة</a:t>
-            </a:r>
-          </a:p>
-          <a:p>
-            <a:r>
-              <a:t>حي بحث مع ،الجديد للمسلم معتمدة ومقاطع كتب من مكتبة</a:t>
-            </a:r>
-          </a:p>
-          <a:p>
-            <a:r>
-              <a:t>المتل ّوة اآلية إبراز مع ًآي ًآي ،ق ّراء بعدة القرآن إىل الستماع</a:t>
-            </a:r>
-          </a:p>
-          <a:p>
-            <a:r>
-              <a:t>منها التالوة يبدأ آية أي على الضغط</a:t>
-            </a:r>
-          </a:p>
-          <a:p>
-            <a:r>
-              <a:t>بمعناه قصري حديث أو آية :اليوم بطاقة</a:t>
-            </a:r>
-          </a:p>
-          <a:p>
-            <a:r>
-              <a:t>مصدره ومعه ،دائ ًما البيانات قاعدة من الرشعي النص</a:t>
-            </a:r>
-          </a:p>
-          <a:p>
-            <a:r>
-              <a:t>06 / 19</a:t>
+              <a:t>المسار · المتع ّلم</a:t>
+            </a:r>
+          </a:p>
+          <a:p>
+            <a:r>
+              <a:t>التالية خطوته ما دائ ًم ا يعرف</a:t>
+            </a:r>
+          </a:p>
+          <a:p>
+            <a:r>
+              <a:t>.يومه يف يحتاجه ما ثم ، لأو اً القادم الدرس تضع مر ّتبة رئيسية</a:t>
+            </a:r>
+          </a:p>
+          <a:p>
+            <a:r>
+              <a:t>ودروس وحدات من مسار</a:t>
+            </a:r>
+          </a:p>
+          <a:p>
+            <a:r>
+              <a:t>مستواه من يبدأ</a:t>
+            </a:r>
+          </a:p>
+          <a:p>
+            <a:r>
+              <a:t>معه تتك ّيف مراجعة</a:t>
+            </a:r>
+          </a:p>
+          <a:p>
+            <a:r>
+              <a:t>له ُتر َّتب رئيسية</a:t>
+            </a:r>
+          </a:p>
+          <a:p>
+            <a:r>
+              <a:t>وحدها اللغة :البداية</a:t>
+            </a:r>
+          </a:p>
+          <a:p>
+            <a:r>
+              <a:t>المر ّتبة الرئيسية</a:t>
+            </a:r>
+          </a:p>
+          <a:p>
+            <a:r>
+              <a:t>در ًس ا وعرشون وخمسة وحدات ست</a:t>
+            </a:r>
+          </a:p>
+          <a:p>
+            <a:r>
+              <a:t>والصالة الوضوء ثم بالشهادتني يبدأ</a:t>
+            </a:r>
+          </a:p>
+          <a:p>
+            <a:r>
+              <a:t>دقائق يف ُينجز قصري درس</a:t>
+            </a:r>
+          </a:p>
+          <a:p>
+            <a:r>
+              <a:t>اختياري مستوى تحديد اختبار</a:t>
+            </a:r>
+          </a:p>
+          <a:p>
+            <a:r>
+              <a:t>المناسبة الوحدة له يفتح</a:t>
+            </a:r>
+          </a:p>
+          <a:p>
+            <a:r>
+              <a:t>يعرفه ما يعيد ال</a:t>
+            </a:r>
+          </a:p>
+          <a:p>
+            <a:r>
+              <a:t>أهدافه أضعف تختار</a:t>
+            </a:r>
+          </a:p>
+          <a:p>
+            <a:r>
+              <a:t>يو ًم ا 30 ثم أيام 7 بعد تعود</a:t>
+            </a:r>
+          </a:p>
+          <a:p>
+            <a:r>
+              <a:t>شاء مىت قصرية جلسة</a:t>
+            </a:r>
+          </a:p>
+          <a:p>
+            <a:r>
+              <a:t>لأو اً التالية الخطوة</a:t>
+            </a:r>
+          </a:p>
+          <a:p>
+            <a:r>
+              <a:t>والقرآن واألذكار الصالة :»يومي«</a:t>
+            </a:r>
+          </a:p>
+          <a:p>
+            <a:r>
+              <a:t>رفيق واسأل اليوم بطاقة</a:t>
+            </a:r>
+          </a:p>
+          <a:p>
+            <a:r>
+              <a:t>رفيق06 / 21</a:t>
             </a:r>
           </a:p>
         </p:txBody>
@@ -3405,147 +3902,107 @@
           <a:lstStyle/>
           <a:p>
             <a:r>
-              <a:t>)3 من 2( رفيق يف ما</a:t>
-            </a:r>
-          </a:p>
-          <a:p>
-            <a:r>
-              <a:t>ليومه وأدوات ،يرافقه إنسان</a:t>
-            </a:r>
-          </a:p>
-          <a:p>
-            <a:r>
-              <a:t>.خصوصيته ويحفظ ،اليومية عبادته على ويعينه ،بمرشد يصله :شاشة مع الجديد المسلم يرتك ال رفيق</a:t>
-            </a:r>
-          </a:p>
-          <a:p>
-            <a:r>
-              <a:t>البرشية المرافقة</a:t>
-            </a:r>
-          </a:p>
-          <a:p>
-            <a:r>
-              <a:t>جنسه من مرشد إىل الطلب ويصل ،شاشة كل يف »إنسا ًنا أريد«</a:t>
-            </a:r>
-          </a:p>
-          <a:p>
-            <a:r>
-              <a:t>بلغته صغرية ومجموعات ،بنفسه يختاره مرشد</a:t>
-            </a:r>
-          </a:p>
-          <a:p>
-            <a:r>
-              <a:t>الفريق يتابعه بالغات وطابور ،وحظر تبليغ</a:t>
-            </a:r>
-          </a:p>
-          <a:p>
-            <a:r>
-              <a:t>العلم أهل إىل الشخصية المسألة إحالة</a:t>
-            </a:r>
-          </a:p>
-          <a:p>
-            <a:r>
-              <a:t>اتصال دون حىت حارضة الرسمية الطوارئ أرقام</a:t>
-            </a:r>
-          </a:p>
-          <a:p>
-            <a:r>
-              <a:t>غريه يراه ال خاص دفرت</a:t>
-            </a:r>
-          </a:p>
-          <a:p>
-            <a:r>
-              <a:t>اليومية الممارسة</a:t>
-            </a:r>
-          </a:p>
-          <a:p>
-            <a:r>
-              <a:t>يغادره ال والموقع ،الجهاز على ُتحسب الصالة مواقيت</a:t>
-            </a:r>
-          </a:p>
-          <a:p>
-            <a:r>
-              <a:t>بالبوصلة ح ّية قبلة</a:t>
-            </a:r>
-          </a:p>
-          <a:p>
-            <a:r>
-              <a:t>الوقت بحسب ،والنوم الصالة وبعد والمساء الصباح أذكار</a:t>
-            </a:r>
-          </a:p>
-          <a:p>
-            <a:r>
-              <a:t>والمناسبات رمضان ووضع ،الهجري التاريخ</a:t>
-            </a:r>
-          </a:p>
-          <a:p>
-            <a:r>
-              <a:t>العبادة على نقاط دون ،لنفسه يتابعها عادات</a:t>
-            </a:r>
-          </a:p>
-          <a:p>
-            <a:r>
-              <a:t>التحفزي</a:t>
-            </a:r>
-          </a:p>
-          <a:p>
-            <a:r>
-              <a:t>النقطاع عند لوم بال ،وسلسلتها التع ّلم أيام</a:t>
-            </a:r>
-          </a:p>
-          <a:p>
-            <a:r>
-              <a:t>وحده التع ّلم على أوسمة</a:t>
-            </a:r>
-          </a:p>
-          <a:p>
-            <a:r>
-              <a:t>يختاره الذي الوقت يف محايد بنص لطيف تذكري</a:t>
-            </a:r>
-          </a:p>
-          <a:p>
-            <a:r>
-              <a:t>المجموعة داخل جماعية تع ّلم تحديات</a:t>
-            </a:r>
-          </a:p>
-          <a:p>
-            <a:r>
-              <a:t>المنصة</a:t>
-            </a:r>
-          </a:p>
-          <a:p>
-            <a:r>
-              <a:t>شاشة كل يف والتاغالوغية واإلنجلزيية العربية</a:t>
-            </a:r>
-          </a:p>
-          <a:p>
-            <a:r>
-              <a:t>مرور وكلمة مستعار اسم والحساب ،حساب دون يعمل</a:t>
-            </a:r>
-          </a:p>
-          <a:p>
-            <a:r>
-              <a:t>باألحجام تزنيالت مركز وفيه ،اتصال دون ويفتح ،تطبي ًقا ُيث َّبت</a:t>
-            </a:r>
-          </a:p>
-          <a:p>
-            <a:r>
-              <a:t>واألندرويد اآليفون على تصل إشعارات</a:t>
-            </a:r>
-          </a:p>
-          <a:p>
-            <a:r>
-              <a:t>الجهاز ومسح ،البيانات من ونسخة ،خفي ووضع ،رسيع خروج</a:t>
-            </a:r>
-          </a:p>
-          <a:p>
-            <a:r>
-              <a:t>وداكن فاتح مظهر</a:t>
-            </a:r>
-          </a:p>
-          <a:p>
-            <a:r>
-              <a:t>07 / 19</a:t>
+              <a:t>الدرس · المتع ّلم</a:t>
+            </a:r>
+          </a:p>
+          <a:p>
+            <a:r>
+              <a:t>آمن والخطأ ،بالفعل يتع ّلم</a:t>
+            </a:r>
+          </a:p>
+          <a:p>
+            <a:r>
+              <a:t>.ومصدره ومعناه بلفظه رشعي نص وكل ،تمارين ثم قصرية بطاقات</a:t>
+            </a:r>
+          </a:p>
+          <a:p>
+            <a:r>
+              <a:t>اآليات بطاقات</a:t>
+            </a:r>
+          </a:p>
+          <a:p>
+            <a:r>
+              <a:t>التمارين من أنواع ثالثة</a:t>
+            </a:r>
+          </a:p>
+          <a:p>
+            <a:r>
+              <a:t>»لماذا؟«التعليمي المو ّجه</a:t>
+            </a:r>
+          </a:p>
+          <a:p>
+            <a:r>
+              <a:t>وتالوتها بمعناها آية</a:t>
+            </a:r>
+          </a:p>
+          <a:p>
+            <a:r>
+              <a:t>البطاقات بعد تمرين</a:t>
+            </a:r>
+          </a:p>
+          <a:p>
+            <a:r>
+              <a:t>المصحف بخط اآلية</a:t>
+            </a:r>
+          </a:p>
+          <a:p>
+            <a:r>
+              <a:t>معتمدة ترجمة من بلغته معناها</a:t>
+            </a:r>
+          </a:p>
+          <a:p>
+            <a:r>
+              <a:t>بضغطة تالوتها</a:t>
+            </a:r>
+          </a:p>
+          <a:p>
+            <a:r>
+              <a:t>بطاقات مجموعة كل بعد</a:t>
+            </a:r>
+          </a:p>
+          <a:p>
+            <a:r>
+              <a:t>وسببه الصواب يرى</a:t>
+            </a:r>
+          </a:p>
+          <a:p>
+            <a:r>
+              <a:t>الح ًقا يعود الخاطئ السؤال</a:t>
+            </a:r>
+          </a:p>
+          <a:p>
+            <a:r>
+              <a:t>خطئه لسبب بلغته رشح</a:t>
+            </a:r>
+          </a:p>
+          <a:p>
+            <a:r>
+              <a:t>وحده المعتمدة البطاقة نص من</a:t>
+            </a:r>
+          </a:p>
+          <a:p>
+            <a:r>
+              <a:t>ُيعرض أن قبل ُيفحص</a:t>
+            </a:r>
+          </a:p>
+          <a:p>
+            <a:r>
+              <a:t>درس كل بعد قصرية رسالة</a:t>
+            </a:r>
+          </a:p>
+          <a:p>
+            <a:r>
+              <a:t>يراجعه وما أتقنه ما</a:t>
+            </a:r>
+          </a:p>
+          <a:p>
+            <a:r>
+              <a:t>التالية وخطوته</a:t>
+            </a:r>
+          </a:p>
+          <a:p>
+            <a:r>
+              <a:t>رفيق07 / 21</a:t>
             </a:r>
           </a:p>
         </p:txBody>
@@ -3615,117 +4072,127 @@
           <a:lstStyle/>
           <a:p>
             <a:r>
-              <a:t>)3 من 3( رفيق يف ما</a:t>
-            </a:r>
-          </a:p>
-          <a:p>
-            <a:r>
-              <a:t>لوحاتهم الجديد المسلم يخدمون ولمن</a:t>
-            </a:r>
-          </a:p>
-          <a:p>
-            <a:r>
-              <a:t>.المتع ّلم إىل يصل أن قبل يراجعه من محتوى ولكل ،شاشته دور لكل :كاملة منظومة رفيق</a:t>
-            </a:r>
-          </a:p>
-          <a:p>
-            <a:r>
-              <a:t>المرشد لوحة</a:t>
-            </a:r>
-          </a:p>
-          <a:p>
-            <a:r>
-              <a:t>يرشدهم من مع والمحادثات الطلبات صندوق</a:t>
-            </a:r>
-          </a:p>
-          <a:p>
-            <a:r>
-              <a:t>تق ّدمه برؤية المتع ّلم له أذن من تق ّدم</a:t>
-            </a:r>
-          </a:p>
-          <a:p>
-            <a:r>
-              <a:t>وتحدياتها المجموعات إدارة</a:t>
-            </a:r>
-          </a:p>
-          <a:p>
-            <a:r>
-              <a:t>يرشدهم من لعدد أعلى وحد التوفر أوقات</a:t>
-            </a:r>
-          </a:p>
-          <a:p>
-            <a:r>
-              <a:t>الرشعي المراجع مكتب</a:t>
-            </a:r>
-          </a:p>
-          <a:p>
-            <a:r>
-              <a:t>إعادتها أو الجاهزة واإلجابات والبطاقات الدروس اعتماد</a:t>
-            </a:r>
-          </a:p>
-          <a:p>
-            <a:r>
-              <a:t>إتاحتهم قبل الق ّراء عينات إىل الستماع</a:t>
-            </a:r>
-          </a:p>
-          <a:p>
-            <a:r>
-              <a:t>»لماذا؟« رشوح عينات مراجعة</a:t>
-            </a:r>
-          </a:p>
-          <a:p>
-            <a:r>
-              <a:t>المساعد من المحالة والمسائل ،التحديات نصوص</a:t>
-            </a:r>
-          </a:p>
-          <a:p>
-            <a:r>
-              <a:t>واإلدارة الفريق</a:t>
-            </a:r>
-          </a:p>
-          <a:p>
-            <a:r>
-              <a:t>هوية دون ،واألسئلة التع ّلم عن مج ّمعة مؤرشات</a:t>
-            </a:r>
-          </a:p>
-          <a:p>
-            <a:r>
-              <a:t>المرشدين وتغطية البالغات طابور</a:t>
-            </a:r>
-          </a:p>
-          <a:p>
-            <a:r>
-              <a:t>الدعوة ورموز واألدوار المستخدمون</a:t>
-            </a:r>
-          </a:p>
-          <a:p>
-            <a:r>
-              <a:t>األهلة ترايئ متابعة</a:t>
-            </a:r>
-          </a:p>
-          <a:p>
-            <a:r>
-              <a:t>الدعوية الجهة من ّس ق</a:t>
-            </a:r>
-          </a:p>
-          <a:p>
-            <a:r>
-              <a:t>لغة بكل للجهة انضمام وروابط رموز</a:t>
-            </a:r>
-          </a:p>
-          <a:p>
-            <a:r>
-              <a:t>وإدارتهم الجهة مرشدي اعتماد</a:t>
-            </a:r>
-          </a:p>
-          <a:p>
-            <a:r>
-              <a:t>فردية بيانات بال ،الجهة منسويب لنشاط مج ّمعة لوحة</a:t>
-            </a:r>
-          </a:p>
-          <a:p>
-            <a:r>
-              <a:t>08 / 19</a:t>
+              <a:t>رفيق اسأل</a:t>
+            </a:r>
+          </a:p>
+          <a:p>
+            <a:r>
+              <a:t>إىل طريق أو ،مصدرها معها إجابة</a:t>
+            </a:r>
+          </a:p>
+          <a:p>
+            <a:r>
+              <a:t>إنسان</a:t>
+            </a:r>
+          </a:p>
+          <a:p>
+            <a:r>
+              <a:t>.جملة كل جاءت أين من ويريه ،المعتمدة المصادر يف مما المساعد فيجيبه ،بلغته يسأل</a:t>
+            </a:r>
+          </a:p>
+          <a:p>
+            <a:r>
+              <a:t>وحدها المصادر من</a:t>
+            </a:r>
+          </a:p>
+          <a:p>
+            <a:r>
+              <a:t>حي بحث</a:t>
+            </a:r>
+          </a:p>
+          <a:p>
+            <a:r>
+              <a:t>معتمدة إجابات</a:t>
+            </a:r>
+          </a:p>
+          <a:p>
+            <a:r>
+              <a:t>ح ّده يعرف</a:t>
+            </a:r>
+          </a:p>
+          <a:p>
+            <a:r>
+              <a:t>مصدرها معها إجابة كل</a:t>
+            </a:r>
+          </a:p>
+          <a:p>
+            <a:r>
+              <a:t>المصادر يف والبحث المكتبة</a:t>
+            </a:r>
+          </a:p>
+          <a:p>
+            <a:r>
+              <a:t>إجابة كل مع مصدر بطاقة</a:t>
+            </a:r>
+          </a:p>
+          <a:p>
+            <a:r>
+              <a:t>قاعدة من والحديث اآلية نص</a:t>
+            </a:r>
+          </a:p>
+          <a:p>
+            <a:r>
+              <a:t>البيانات</a:t>
+            </a:r>
+          </a:p>
+          <a:p>
+            <a:r>
+              <a:t>رشع ًّيا ن ًّص ا النموذج يكتب ال</a:t>
+            </a:r>
+          </a:p>
+          <a:p>
+            <a:r>
+              <a:t>المعتمدة الفتوى مواقع يف</a:t>
+            </a:r>
+          </a:p>
+          <a:p>
+            <a:r>
+              <a:t>المفهرس من أكرث السؤال يحتاج حني</a:t>
+            </a:r>
+          </a:p>
+          <a:p>
+            <a:r>
+              <a:t>بحث أين ويذكر</a:t>
+            </a:r>
+          </a:p>
+          <a:p>
+            <a:r>
+              <a:t>الشائعة لألسئلة</a:t>
+            </a:r>
+          </a:p>
+          <a:p>
+            <a:r>
+              <a:t>الرشعي المراجع راجعها</a:t>
+            </a:r>
+          </a:p>
+          <a:p>
+            <a:r>
+              <a:t>لغات بثالث فو ًرا تظهر</a:t>
+            </a:r>
+          </a:p>
+          <a:p>
+            <a:r>
+              <a:t>أهل إىل ُتحال الشخصية المسألة</a:t>
+            </a:r>
+          </a:p>
+          <a:p>
+            <a:r>
+              <a:t>العلم</a:t>
+            </a:r>
+          </a:p>
+          <a:p>
+            <a:r>
+              <a:t>ترجيح دون أقوالها ُتعرض الخالفية</a:t>
+            </a:r>
+          </a:p>
+          <a:p>
+            <a:r>
+              <a:t>فو ًرا إنسان إىل يصل الخطر</a:t>
+            </a:r>
+          </a:p>
+          <a:p>
+            <a:r>
+              <a:t>رفيق08 / 21</a:t>
             </a:r>
           </a:p>
         </p:txBody>
@@ -3795,157 +4262,222 @@
           <a:lstStyle/>
           <a:p>
             <a:r>
-              <a:t>)2 من 1( الصطناعي الذكاء</a:t>
-            </a:r>
-          </a:p>
-          <a:p>
-            <a:r>
-              <a:t>المصادر يف بما إال يجيب ال :»رفيق اسأل«</a:t>
-            </a:r>
-          </a:p>
-          <a:p>
-            <a:r>
-              <a:t>.ثانية 45و خارجية طلبات 8 :سؤال كل سقف .اإلجابة إيقاف تستطيع مرحلة وكل ،سؤال لكل مراحل ست</a:t>
-            </a:r>
-          </a:p>
-          <a:p>
-            <a:r>
-              <a:t>المرحلة</a:t>
-            </a:r>
-          </a:p>
-          <a:p>
-            <a:r>
-              <a:t>النموذج</a:t>
-            </a:r>
-          </a:p>
-          <a:p>
-            <a:r>
-              <a:t>تفعله ما</a:t>
-            </a:r>
-          </a:p>
-          <a:p>
-            <a:r>
-              <a:t>رفضت أو فشلت إذا</a:t>
-            </a:r>
-          </a:p>
-          <a:p>
-            <a:r>
-              <a:t>الخطر فحص .1نموذج باللأو اً تعمل ،لغات بثالث معتمدة خطر عبارات</a:t>
-            </a:r>
-          </a:p>
-          <a:p>
-            <a:r>
-              <a:t>اتصال أي دون ،إنسان إىل فورية وإحالة ثابت رد</a:t>
-            </a:r>
-          </a:p>
-          <a:p>
-            <a:r>
-              <a:t>بالشبكة</a:t>
-            </a:r>
-          </a:p>
-          <a:p>
-            <a:r>
-              <a:t>المو ّجه .2رسيع</a:t>
-            </a:r>
-          </a:p>
-          <a:p>
-            <a:r>
-              <a:t>ودرجته …تجاوز محاولة ،النطاق خارج ،خطر ،شخيص ،خاليف ،عام :السؤال يص ّنف</a:t>
-            </a:r>
-          </a:p>
-          <a:p>
-            <a:r>
-              <a:t>D إىل A من</a:t>
-            </a:r>
-          </a:p>
-          <a:p>
-            <a:r>
-              <a:t>إنسان إىل والخطر ،مرشد إىل ُيحال الشخيص</a:t>
-            </a:r>
-          </a:p>
-          <a:p>
-            <a:r>
-              <a:t>السرتجاع .3</a:t>
-            </a:r>
-          </a:p>
-          <a:p>
-            <a:r>
-              <a:t>bge-m3مقاطع 8 حىت ،السائل بلغة المعتمدة المصادر يف م ًعا ونيص داليل بحث</a:t>
-            </a:r>
-          </a:p>
-          <a:p>
-            <a:r>
-              <a:t>ذلك و ُيع َلن بالنيص يكمل الداليل البحث تعطل إن</a:t>
-            </a:r>
-          </a:p>
-          <a:p>
-            <a:r>
-              <a:t>المؤلف .4رئ يس</a:t>
-            </a:r>
-          </a:p>
-          <a:p>
-            <a:r>
-              <a:t>كتابة بدل حديث أو آية كل مكان عالمة ويضع ،وحدها المقاطع من اإلجابة يكتب</a:t>
-            </a:r>
-          </a:p>
-          <a:p>
-            <a:r>
-              <a:t>نصه</a:t>
-            </a:r>
-          </a:p>
-          <a:p>
-            <a:r>
-              <a:t>مرشد مع التواصل واقرتاح اعتذار ← »يكفي ال«</a:t>
-            </a:r>
-          </a:p>
-          <a:p>
-            <a:r>
-              <a:t>المدقق .5رسيع + كود</a:t>
-            </a:r>
-          </a:p>
-          <a:p>
-            <a:r>
-              <a:t>كل دعم فحص ثم )…اللغة ،منسوخ نص ال ، لفع اً مسرتجعة المراجع( آلية فحوص 7</a:t>
-            </a:r>
-          </a:p>
-          <a:p>
-            <a:r>
-              <a:t>بالمصدر جملة</a:t>
-            </a:r>
-          </a:p>
-          <a:p>
-            <a:r>
-              <a:t>تظهر ال وإال ،جديد من كامل فحص ثم واحد إصالح</a:t>
-            </a:r>
-          </a:p>
-          <a:p>
-            <a:r>
-              <a:t>اإلجابة</a:t>
-            </a:r>
-          </a:p>
-          <a:p>
-            <a:r>
-              <a:t>العرض .6</a:t>
-            </a:r>
-          </a:p>
-          <a:p>
-            <a:r>
-              <a:t>—المصدر بطاقة مع ،بمع ّرفه البيانات قاعدة من ُيعرض والحديث اآلية نص</a:t>
-            </a:r>
-          </a:p>
-          <a:p>
-            <a:r>
-              <a:t>اإلجابة ُتعرض ال العرض قبل المصدر ُحذف إن</a:t>
-            </a:r>
-          </a:p>
-          <a:p>
-            <a:r>
-              <a:t>docs/engineering/ai-agents.md :المصدر .بالطلبات يحتفظون ال ومز ّودون ،0 حرارة .deepseek-v4-pro و الحتياطي ،gemma-4-26b-a4b-it والرسيع ،gemma-4-31b-it الرئ يس :OpenRouter عرب النماذج</a:t>
-            </a:r>
-          </a:p>
-          <a:p>
-            <a:r>
-              <a:t>09 / 19</a:t>
+              <a:t>يجيب كيف · الصطناعي الذكاء</a:t>
+            </a:r>
+          </a:p>
+          <a:p>
+            <a:r>
+              <a:t>اإلجابة توقف أن تستطيع مرحلة وكل ،مراحل ست</a:t>
+            </a:r>
+          </a:p>
+          <a:p>
+            <a:r>
+              <a:t>.ُيعرض ال يجتاز ال وما ،ُيد َّقق ثم يصوغ ثم يسرتجع :بالمصادر مق َّيد رفيق يف الصطناعي الذكاء</a:t>
+            </a:r>
+          </a:p>
+          <a:p>
+            <a:r>
+              <a:t>1</a:t>
+            </a:r>
+          </a:p>
+          <a:p>
+            <a:r>
+              <a:t>الخطر فحص</a:t>
+            </a:r>
+          </a:p>
+          <a:p>
+            <a:r>
+              <a:t>بثالث معتمدة عبارات</a:t>
+            </a:r>
+          </a:p>
+          <a:p>
+            <a:r>
+              <a:t>نموذج أي قبل ،لغات</a:t>
+            </a:r>
+          </a:p>
+          <a:p>
+            <a:r>
+              <a:t>2</a:t>
+            </a:r>
+          </a:p>
+          <a:p>
+            <a:r>
+              <a:t>المو ّجه</a:t>
+            </a:r>
+          </a:p>
+          <a:p>
+            <a:r>
+              <a:t>،عام :السؤال يص ّنف</a:t>
+            </a:r>
+          </a:p>
+          <a:p>
+            <a:r>
+              <a:t>خارج ،خاليف ،شخيص</a:t>
+            </a:r>
+          </a:p>
+          <a:p>
+            <a:r>
+              <a:t>النطاق</a:t>
+            </a:r>
+          </a:p>
+          <a:p>
+            <a:r>
+              <a:t>3</a:t>
+            </a:r>
+          </a:p>
+          <a:p>
+            <a:r>
+              <a:t>السرتجاع</a:t>
+            </a:r>
+          </a:p>
+          <a:p>
+            <a:r>
+              <a:t>يف ونيص داليل بحث</a:t>
+            </a:r>
+          </a:p>
+          <a:p>
+            <a:r>
+              <a:t>بلغة المعتمدة المصادر</a:t>
+            </a:r>
+          </a:p>
+          <a:p>
+            <a:r>
+              <a:t>السائل</a:t>
+            </a:r>
+          </a:p>
+          <a:p>
+            <a:r>
+              <a:t>4</a:t>
+            </a:r>
+          </a:p>
+          <a:p>
+            <a:r>
+              <a:t>المؤلف</a:t>
+            </a:r>
+          </a:p>
+          <a:p>
+            <a:r>
+              <a:t>المقاطع من اإلجابة يصوغ</a:t>
+            </a:r>
+          </a:p>
+          <a:p>
+            <a:r>
+              <a:t>اآلية مكان ويرتك ،وحدها</a:t>
+            </a:r>
+          </a:p>
+          <a:p>
+            <a:r>
+              <a:t>والحديث</a:t>
+            </a:r>
+          </a:p>
+          <a:p>
+            <a:r>
+              <a:t>5</a:t>
+            </a:r>
+          </a:p>
+          <a:p>
+            <a:r>
+              <a:t>المدقق</a:t>
+            </a:r>
+          </a:p>
+          <a:p>
+            <a:r>
+              <a:t>ثم ،آلية فحوص سبعة</a:t>
+            </a:r>
+          </a:p>
+          <a:p>
+            <a:r>
+              <a:t>جملة كل مطابقة</a:t>
+            </a:r>
+          </a:p>
+          <a:p>
+            <a:r>
+              <a:t>بمصدرها</a:t>
+            </a:r>
+          </a:p>
+          <a:p>
+            <a:r>
+              <a:t>6</a:t>
+            </a:r>
+          </a:p>
+          <a:p>
+            <a:r>
+              <a:t>العرض</a:t>
+            </a:r>
+          </a:p>
+          <a:p>
+            <a:r>
+              <a:t>قاعدة من الرشعي النص</a:t>
+            </a:r>
+          </a:p>
+          <a:p>
+            <a:r>
+              <a:t>المصدر بطاقة مع ،البيانات</a:t>
+            </a:r>
+          </a:p>
+          <a:p>
+            <a:r>
+              <a:t>G</a:t>
+            </a:r>
+          </a:p>
+          <a:p>
+            <a:r>
+              <a:t>Gemma</a:t>
+            </a:r>
+          </a:p>
+          <a:p>
+            <a:r>
+              <a:t>:OpenRouter عرب ،المفتوحة Google نماذج</a:t>
+            </a:r>
+          </a:p>
+          <a:p>
+            <a:r>
+              <a:t>.وتدقيقها اإلجابة وصياغة للتصنيف</a:t>
+            </a:r>
+          </a:p>
+          <a:p>
+            <a:r>
+              <a:t>D</a:t>
+            </a:r>
+          </a:p>
+          <a:p>
+            <a:r>
+              <a:t>DeepSeek</a:t>
+            </a:r>
+          </a:p>
+          <a:p>
+            <a:r>
+              <a:t>فتستمر ،تلقائ ًيا العمل ليتو ىّ احتياطي نموذج</a:t>
+            </a:r>
+          </a:p>
+          <a:p>
+            <a:r>
+              <a:t>.الخدمة</a:t>
+            </a:r>
+          </a:p>
+          <a:p>
+            <a:r>
+              <a:t>B</a:t>
+            </a:r>
+          </a:p>
+          <a:p>
+            <a:r>
+              <a:t>BGE-M3</a:t>
+            </a:r>
+          </a:p>
+          <a:p>
+            <a:r>
+              <a:t>المقطع يجد اللغات متعدد بحث نموذج</a:t>
+            </a:r>
+          </a:p>
+          <a:p>
+            <a:r>
+              <a:t>.والتاغالوغية واإلنجلزيية بالعربية المناسب</a:t>
+            </a:r>
+          </a:p>
+          <a:p>
+            <a:r>
+              <a:t>رفيق09 / 21</a:t>
             </a:r>
           </a:p>
         </p:txBody>
@@ -7404,6 +7936,90 @@
 </file>
 
 <file path=ppt/slides/slide2.xml><?xml version="1.0" encoding="utf-8"?>
+<p:sld xmlns:a="http://schemas.openxmlformats.org/drawingml/2006/main" xmlns:p="http://schemas.openxmlformats.org/presentationml/2006/main" xmlns:r="http://schemas.openxmlformats.org/officeDocument/2006/relationships">
+  <p:cSld>
+    <p:spTree>
+      <p:nvGrpSpPr>
+        <p:cNvPr id="1" name=""/>
+        <p:cNvGrpSpPr/>
+        <p:nvPr/>
+      </p:nvGrpSpPr>
+      <p:grpSpPr/>
+      <p:pic>
+        <p:nvPicPr>
+          <p:cNvPr id="2" name="Picture 1" descr="image.jpg"/>
+          <p:cNvPicPr>
+            <a:picLocks noChangeAspect="1"/>
+          </p:cNvPicPr>
+          <p:nvPr/>
+        </p:nvPicPr>
+        <p:blipFill>
+          <a:blip r:embed="rId2"/>
+          <a:stretch>
+            <a:fillRect/>
+          </a:stretch>
+        </p:blipFill>
+        <p:spPr>
+          <a:xfrm>
+            <a:off x="0" y="0"/>
+            <a:ext cx="12192000" cy="6858000"/>
+          </a:xfrm>
+          <a:prstGeom prst="rect">
+            <a:avLst/>
+          </a:prstGeom>
+        </p:spPr>
+      </p:pic>
+    </p:spTree>
+  </p:cSld>
+  <p:clrMapOvr>
+    <a:masterClrMapping/>
+  </p:clrMapOvr>
+</p:sld>
+</file>
+
+<file path=ppt/slides/slide20.xml><?xml version="1.0" encoding="utf-8"?>
+<p:sld xmlns:a="http://schemas.openxmlformats.org/drawingml/2006/main" xmlns:p="http://schemas.openxmlformats.org/presentationml/2006/main" xmlns:r="http://schemas.openxmlformats.org/officeDocument/2006/relationships">
+  <p:cSld>
+    <p:spTree>
+      <p:nvGrpSpPr>
+        <p:cNvPr id="1" name=""/>
+        <p:cNvGrpSpPr/>
+        <p:nvPr/>
+      </p:nvGrpSpPr>
+      <p:grpSpPr/>
+      <p:pic>
+        <p:nvPicPr>
+          <p:cNvPr id="2" name="Picture 1" descr="image.jpg"/>
+          <p:cNvPicPr>
+            <a:picLocks noChangeAspect="1"/>
+          </p:cNvPicPr>
+          <p:nvPr/>
+        </p:nvPicPr>
+        <p:blipFill>
+          <a:blip r:embed="rId2"/>
+          <a:stretch>
+            <a:fillRect/>
+          </a:stretch>
+        </p:blipFill>
+        <p:spPr>
+          <a:xfrm>
+            <a:off x="0" y="0"/>
+            <a:ext cx="12192000" cy="6858000"/>
+          </a:xfrm>
+          <a:prstGeom prst="rect">
+            <a:avLst/>
+          </a:prstGeom>
+        </p:spPr>
+      </p:pic>
+    </p:spTree>
+  </p:cSld>
+  <p:clrMapOvr>
+    <a:masterClrMapping/>
+  </p:clrMapOvr>
+</p:sld>
+</file>
+
+<file path=ppt/slides/slide21.xml><?xml version="1.0" encoding="utf-8"?>
 <p:sld xmlns:a="http://schemas.openxmlformats.org/drawingml/2006/main" xmlns:p="http://schemas.openxmlformats.org/presentationml/2006/main" xmlns:r="http://schemas.openxmlformats.org/officeDocument/2006/relationships">
   <p:cSld>
     <p:spTree>

</xml_diff>

<commit_message>
submission: deck v5 (thank-you slide, brand apricot flower, Arabic-Indic digits; 29 slides)
</commit_message>
<xml_diff>
--- a/docs/submission/rafeeq-deck.pptx
+++ b/docs/submission/rafeeq-deck.pptx
@@ -33,6 +33,7 @@
     <p:sldId id="281" r:id="rId33"/>
     <p:sldId id="282" r:id="rId34"/>
     <p:sldId id="283" r:id="rId35"/>
+    <p:sldId id="284" r:id="rId36"/>
   </p:sldIdLst>
   <p:sldSz cx="12192000" cy="6858000" type="screen4x3"/>
   <p:notesSz cx="6858000" cy="9144000"/>
@@ -759,12 +760,12 @@
           </a:p>
           <a:p>
             <a:r>
-              <a:t> · الذكاء الاصطناعي15%</a:t>
-            </a:r>
-          </a:p>
-          <a:p>
-            <a:r>
-              <a:t>10 / 28</a:t>
+              <a:t> · الذكاء الاصطناعي٪٥١</a:t>
+            </a:r>
+          </a:p>
+          <a:p>
+            <a:r>
+              <a:t>٩٢ / ٠١</a:t>
             </a:r>
           </a:p>
         </p:txBody>
@@ -974,12 +975,12 @@
           </a:p>
           <a:p>
             <a:r>
-              <a:t> · الذكاء الاصطناعي15%</a:t>
-            </a:r>
-          </a:p>
-          <a:p>
-            <a:r>
-              <a:t>11 / 28</a:t>
+              <a:t> · الذكاء الاصطناعي٪٥١</a:t>
+            </a:r>
+          </a:p>
+          <a:p>
+            <a:r>
+              <a:t>٩٢ / ١١</a:t>
             </a:r>
           </a:p>
         </p:txBody>
@@ -1074,7 +1075,7 @@
           </a:p>
           <a:p>
             <a:r>
-              <a:t>1</a:t>
+              <a:t>١</a:t>
             </a:r>
           </a:p>
           <a:p>
@@ -1094,7 +1095,7 @@
           </a:p>
           <a:p>
             <a:r>
-              <a:t>2</a:t>
+              <a:t>٢</a:t>
             </a:r>
           </a:p>
           <a:p>
@@ -1119,7 +1120,7 @@
           </a:p>
           <a:p>
             <a:r>
-              <a:t>3</a:t>
+              <a:t>٣</a:t>
             </a:r>
           </a:p>
           <a:p>
@@ -1144,7 +1145,7 @@
           </a:p>
           <a:p>
             <a:r>
-              <a:t>4</a:t>
+              <a:t>٤</a:t>
             </a:r>
           </a:p>
           <a:p>
@@ -1169,7 +1170,7 @@
           </a:p>
           <a:p>
             <a:r>
-              <a:t>5</a:t>
+              <a:t>٥</a:t>
             </a:r>
           </a:p>
           <a:p>
@@ -1194,7 +1195,7 @@
           </a:p>
           <a:p>
             <a:r>
-              <a:t>6</a:t>
+              <a:t>٦</a:t>
             </a:r>
           </a:p>
           <a:p>
@@ -1284,12 +1285,12 @@
           </a:p>
           <a:p>
             <a:r>
-              <a:t> · الذكاء الاصطناعي15%</a:t>
-            </a:r>
-          </a:p>
-          <a:p>
-            <a:r>
-              <a:t>12 / 28</a:t>
+              <a:t> · الذكاء الاصطناعي٪٥١</a:t>
+            </a:r>
+          </a:p>
+          <a:p>
+            <a:r>
+              <a:t>٩٢ / ٢١</a:t>
             </a:r>
           </a:p>
         </p:txBody>
@@ -1519,7 +1520,7 @@
           </a:p>
           <a:p>
             <a:r>
-              <a:t> للإجابة، وسقف إنفاق يومي0.0015$ قرابة</a:t>
+              <a:t>٥١٠٠٫٠ دولار للإجابة، وسقف إنفاق يومي قرابة</a:t>
             </a:r>
           </a:p>
           <a:p>
@@ -1534,12 +1535,12 @@
           </a:p>
           <a:p>
             <a:r>
-              <a:t> · الذكاء الاصطناعي15%</a:t>
-            </a:r>
-          </a:p>
-          <a:p>
-            <a:r>
-              <a:t>13 / 28</a:t>
+              <a:t> · الذكاء الاصطناعي٪٥١</a:t>
+            </a:r>
+          </a:p>
+          <a:p>
+            <a:r>
+              <a:t>٩٢ / ٣١</a:t>
             </a:r>
           </a:p>
         </p:txBody>
@@ -1749,7 +1750,7 @@
           </a:p>
           <a:p>
             <a:r>
-              <a:t>. اختبار آلي يحرس القواعد1,100</a:t>
+              <a:t>.٠٠١٬١ اختبار آلي يحرس القواعد</a:t>
             </a:r>
           </a:p>
           <a:p>
@@ -1759,12 +1760,12 @@
           </a:p>
           <a:p>
             <a:r>
-              <a:t> · الموثوقية20%</a:t>
-            </a:r>
-          </a:p>
-          <a:p>
-            <a:r>
-              <a:t>14 / 28</a:t>
+              <a:t> · الموثوقية٪٠٢</a:t>
+            </a:r>
+          </a:p>
+          <a:p>
+            <a:r>
+              <a:t>٩٢ / ٤١</a:t>
             </a:r>
           </a:p>
         </p:txBody>
@@ -1974,12 +1975,12 @@
           </a:p>
           <a:p>
             <a:r>
-              <a:t> · المشكلة والجمهور25%</a:t>
-            </a:r>
-          </a:p>
-          <a:p>
-            <a:r>
-              <a:t>15 / 28</a:t>
+              <a:t> · المشكلة والجمهور٪٥٢</a:t>
+            </a:r>
+          </a:p>
+          <a:p>
+            <a:r>
+              <a:t>٩٢ / ٥١</a:t>
             </a:r>
           </a:p>
         </p:txBody>
@@ -2164,12 +2165,12 @@
           </a:p>
           <a:p>
             <a:r>
-              <a:t> · المشكلة والجمهور25%</a:t>
-            </a:r>
-          </a:p>
-          <a:p>
-            <a:r>
-              <a:t>16 / 28</a:t>
+              <a:t> · المشكلة والجمهور٪٥٢</a:t>
+            </a:r>
+          </a:p>
+          <a:p>
+            <a:r>
+              <a:t>٩٢ / ٦١</a:t>
             </a:r>
           </a:p>
         </p:txBody>
@@ -2309,7 +2310,7 @@
           </a:p>
           <a:p>
             <a:r>
-              <a:t>. يوم تع ّم66 و30 و7</a:t>
+              <a:t>.٧ و٠٣ و٦٦ يوم تع ّم</a:t>
             </a:r>
           </a:p>
           <a:p>
@@ -2399,12 +2400,12 @@
           </a:p>
           <a:p>
             <a:r>
-              <a:t> · الأصالة15%</a:t>
-            </a:r>
-          </a:p>
-          <a:p>
-            <a:r>
-              <a:t>17 / 28</a:t>
+              <a:t> · الأصالة٪٥١</a:t>
+            </a:r>
+          </a:p>
+          <a:p>
+            <a:r>
+              <a:t>٩٢ / ٧١</a:t>
             </a:r>
           </a:p>
         </p:txBody>
@@ -2594,12 +2595,12 @@
           </a:p>
           <a:p>
             <a:r>
-              <a:t> · الموثوقية20%</a:t>
-            </a:r>
-          </a:p>
-          <a:p>
-            <a:r>
-              <a:t>18 / 28</a:t>
+              <a:t> · الموثوقية٪٠٢</a:t>
+            </a:r>
+          </a:p>
+          <a:p>
+            <a:r>
+              <a:t>٩٢ / ٨١</a:t>
             </a:r>
           </a:p>
         </p:txBody>
@@ -2834,12 +2835,12 @@
           </a:p>
           <a:p>
             <a:r>
-              <a:t> · قابلية التنفيذ15%</a:t>
-            </a:r>
-          </a:p>
-          <a:p>
-            <a:r>
-              <a:t>19 / 28</a:t>
+              <a:t> · قابلية التنفيذ٪٥١</a:t>
+            </a:r>
+          </a:p>
+          <a:p>
+            <a:r>
+              <a:t>٩٢ / ٩١</a:t>
             </a:r>
           </a:p>
         </p:txBody>
@@ -2924,12 +2925,7 @@
           </a:p>
           <a:p>
             <a:r>
-              <a:t>25%</a:t>
-            </a:r>
-          </a:p>
-          <a:p>
-            <a:r>
-              <a:t>25%</a:t>
+              <a:t>٥٢٪٥٢٪</a:t>
             </a:r>
           </a:p>
           <a:p>
@@ -2954,12 +2950,7 @@
           </a:p>
           <a:p>
             <a:r>
-              <a:t>20%</a:t>
-            </a:r>
-          </a:p>
-          <a:p>
-            <a:r>
-              <a:t>20%</a:t>
+              <a:t>٠٢٪٠٢٪</a:t>
             </a:r>
           </a:p>
           <a:p>
@@ -2979,12 +2970,7 @@
           </a:p>
           <a:p>
             <a:r>
-              <a:t>15%</a:t>
-            </a:r>
-          </a:p>
-          <a:p>
-            <a:r>
-              <a:t>15%</a:t>
+              <a:t>٥١٪٥١٪</a:t>
             </a:r>
           </a:p>
           <a:p>
@@ -3004,12 +2990,7 @@
           </a:p>
           <a:p>
             <a:r>
-              <a:t>15%</a:t>
-            </a:r>
-          </a:p>
-          <a:p>
-            <a:r>
-              <a:t>15%</a:t>
+              <a:t>٥١٪٥١٪</a:t>
             </a:r>
           </a:p>
           <a:p>
@@ -3029,12 +3010,7 @@
           </a:p>
           <a:p>
             <a:r>
-              <a:t>15%</a:t>
-            </a:r>
-          </a:p>
-          <a:p>
-            <a:r>
-              <a:t>15%</a:t>
+              <a:t>٥١٪٥١٪</a:t>
             </a:r>
           </a:p>
           <a:p>
@@ -3054,12 +3030,7 @@
           </a:p>
           <a:p>
             <a:r>
-              <a:t>10%</a:t>
-            </a:r>
-          </a:p>
-          <a:p>
-            <a:r>
-              <a:t>10%</a:t>
+              <a:t>٠١٪٠١٪</a:t>
             </a:r>
           </a:p>
           <a:p>
@@ -3079,7 +3050,12 @@
           </a:p>
           <a:p>
             <a:r>
-              <a:t>رفيق02 / 28</a:t>
+              <a:t>رفيق</a:t>
+            </a:r>
+          </a:p>
+          <a:p>
+            <a:r>
+              <a:t>٩٢ / ٢٠</a:t>
             </a:r>
           </a:p>
         </p:txBody>
@@ -3149,7 +3125,7 @@
           <a:lstStyle/>
           <a:p>
             <a:r>
-              <a:t>2  من1 · خلف الستار</a:t>
+              <a:t>٢ ١ من · خلف الستار</a:t>
             </a:r>
           </a:p>
           <a:p>
@@ -3294,12 +3270,12 @@
           </a:p>
           <a:p>
             <a:r>
-              <a:t> · الموثوقية20%</a:t>
-            </a:r>
-          </a:p>
-          <a:p>
-            <a:r>
-              <a:t>20 / 28</a:t>
+              <a:t> · الموثوقية٪٠٢</a:t>
+            </a:r>
+          </a:p>
+          <a:p>
+            <a:r>
+              <a:t>٩٢ / ٠٢</a:t>
             </a:r>
           </a:p>
         </p:txBody>
@@ -3369,7 +3345,7 @@
           <a:lstStyle/>
           <a:p>
             <a:r>
-              <a:t>2  من2 · خلف الستار</a:t>
+              <a:t>٢ ٢ من · خلف الستار</a:t>
             </a:r>
           </a:p>
           <a:p>
@@ -3504,12 +3480,12 @@
           </a:p>
           <a:p>
             <a:r>
-              <a:t> · الفريق10%</a:t>
-            </a:r>
-          </a:p>
-          <a:p>
-            <a:r>
-              <a:t>21 / 28</a:t>
+              <a:t> · الفريق٪٠١</a:t>
+            </a:r>
+          </a:p>
+          <a:p>
+            <a:r>
+              <a:t>٩٢ / ١٢</a:t>
             </a:r>
           </a:p>
         </p:txBody>
@@ -3699,12 +3675,12 @@
           </a:p>
           <a:p>
             <a:r>
-              <a:t> · الموثوقية20%</a:t>
-            </a:r>
-          </a:p>
-          <a:p>
-            <a:r>
-              <a:t>22 / 28</a:t>
+              <a:t> · الموثوقية٪٠٢</a:t>
+            </a:r>
+          </a:p>
+          <a:p>
+            <a:r>
+              <a:t>٩٢ / ٢٢</a:t>
             </a:r>
           </a:p>
         </p:txBody>
@@ -3879,12 +3855,12 @@
           </a:p>
           <a:p>
             <a:r>
-              <a:t>14/14</a:t>
-            </a:r>
-          </a:p>
-          <a:p>
-            <a:r>
-              <a:t>14/14</a:t>
+              <a:t>٤١/٤١</a:t>
+            </a:r>
+          </a:p>
+          <a:p>
+            <a:r>
+              <a:t>٤١/٤١</a:t>
             </a:r>
           </a:p>
           <a:p>
@@ -3909,12 +3885,7 @@
           </a:p>
           <a:p>
             <a:r>
-              <a:t>9/9</a:t>
-            </a:r>
-          </a:p>
-          <a:p>
-            <a:r>
-              <a:t>9/9</a:t>
+              <a:t>٩/٩ ٩/٩</a:t>
             </a:r>
           </a:p>
           <a:p>
@@ -3929,32 +3900,27 @@
           </a:p>
           <a:p>
             <a:r>
-              <a:t>$0.0015</a:t>
-            </a:r>
-          </a:p>
-          <a:p>
-            <a:r>
-              <a:t>$0.0015</a:t>
-            </a:r>
-          </a:p>
-          <a:p>
-            <a:r>
-              <a:t> إلى9 تكلفة الإجابة الواحدة، في</a:t>
-            </a:r>
-          </a:p>
-          <a:p>
-            <a:r>
-              <a:t> ثانية15</a:t>
-            </a:r>
-          </a:p>
-          <a:p>
-            <a:r>
-              <a:t>+1,100</a:t>
-            </a:r>
-          </a:p>
-          <a:p>
-            <a:r>
-              <a:t>+1,100</a:t>
+              <a:t>٥١٠٠٫٠ دولار</a:t>
+            </a:r>
+          </a:p>
+          <a:p>
+            <a:r>
+              <a:t>٥١٠٠٫٠ دولار</a:t>
+            </a:r>
+          </a:p>
+          <a:p>
+            <a:r>
+              <a:t>٥١ ٩ إلى تكلفة الإجابة الواحدة، في</a:t>
+            </a:r>
+          </a:p>
+          <a:p>
+            <a:r>
+              <a:t>ثانية</a:t>
+            </a:r>
+          </a:p>
+          <a:p>
+            <a:r>
+              <a:t>+٠٠١٬١+٠٠١٬١</a:t>
             </a:r>
           </a:p>
           <a:p>
@@ -3969,12 +3935,12 @@
           </a:p>
           <a:p>
             <a:r>
-              <a:t> · قابلية التنفيذ15%</a:t>
-            </a:r>
-          </a:p>
-          <a:p>
-            <a:r>
-              <a:t>23 / 28</a:t>
+              <a:t> · قابلية التنفيذ٪٥١</a:t>
+            </a:r>
+          </a:p>
+          <a:p>
+            <a:r>
+              <a:t>٩٢ / ٣٢</a:t>
             </a:r>
           </a:p>
         </p:txBody>
@@ -4159,12 +4125,12 @@
           </a:p>
           <a:p>
             <a:r>
-              <a:t> · الأصالة15%</a:t>
-            </a:r>
-          </a:p>
-          <a:p>
-            <a:r>
-              <a:t>24 / 28</a:t>
+              <a:t> · الأصالة٪٥١</a:t>
+            </a:r>
+          </a:p>
+          <a:p>
+            <a:r>
+              <a:t>٩٢ / ٤٢</a:t>
             </a:r>
           </a:p>
         </p:txBody>
@@ -4249,12 +4215,12 @@
           </a:p>
           <a:p>
             <a:r>
-              <a:t>6 · 25</a:t>
-            </a:r>
-          </a:p>
-          <a:p>
-            <a:r>
-              <a:t>6 · 25</a:t>
+              <a:t>٥٢ · ٦</a:t>
+            </a:r>
+          </a:p>
+          <a:p>
+            <a:r>
+              <a:t>٥٢ · ٦</a:t>
             </a:r>
           </a:p>
           <a:p>
@@ -4269,17 +4235,17 @@
           </a:p>
           <a:p>
             <a:r>
-              <a:t>+1,100</a:t>
-            </a:r>
-          </a:p>
-          <a:p>
-            <a:r>
-              <a:t>+1,100</a:t>
-            </a:r>
-          </a:p>
-          <a:p>
-            <a:r>
-              <a:t>اختبار آلي ناجح4</a:t>
+              <a:t>+٠٠١٬١+٠٠١٬١</a:t>
+            </a:r>
+          </a:p>
+          <a:p>
+            <a:r>
+              <a:t>اختبار آلي ناجح</a:t>
+            </a:r>
+          </a:p>
+          <a:p>
+            <a:r>
+              <a:t>٤</a:t>
             </a:r>
           </a:p>
           <a:p>
@@ -4294,7 +4260,7 @@
           </a:p>
           <a:p>
             <a:r>
-              <a:t>3</a:t>
+              <a:t>٣</a:t>
             </a:r>
           </a:p>
           <a:p>
@@ -4359,12 +4325,12 @@
           </a:p>
           <a:p>
             <a:r>
-              <a:t> · قابلية التنفيذ15%</a:t>
-            </a:r>
-          </a:p>
-          <a:p>
-            <a:r>
-              <a:t>25 / 28</a:t>
+              <a:t> · قابلية التنفيذ٪٥١</a:t>
+            </a:r>
+          </a:p>
+          <a:p>
+            <a:r>
+              <a:t>٩٢ / ٥٢</a:t>
             </a:r>
           </a:p>
         </p:txBody>
@@ -4569,12 +4535,12 @@
           </a:p>
           <a:p>
             <a:r>
-              <a:t> · الفريق10%</a:t>
-            </a:r>
-          </a:p>
-          <a:p>
-            <a:r>
-              <a:t>26 / 28</a:t>
+              <a:t> · الفريق٪٠١</a:t>
+            </a:r>
+          </a:p>
+          <a:p>
+            <a:r>
+              <a:t>٩٢ / ٦٢</a:t>
             </a:r>
           </a:p>
         </p:txBody>
@@ -4674,12 +4640,22 @@
           </a:p>
           <a:p>
             <a:r>
-              <a:t>25%وضوح المشكلة وملاءمتها للمسار والجمهور.أرقام مو ّقة، وثلاث شخصيات، ورحلة متدّرجة من أول فتح إلى المتابعة، بلغة المستفيد</a:t>
-            </a:r>
-          </a:p>
-          <a:p>
-            <a:r>
-              <a:t>20%الموثوقية والسلامة العلمية</a:t>
+              <a:t>٪٥٢</a:t>
+            </a:r>
+          </a:p>
+          <a:p>
+            <a:r>
+              <a:t>وضوح المشكلة وملاءمتها للمسار والجمهور.أرقام مو ّقة، وثلاث شخصيات، ورحلة متدّرجة من أول فتح إلى المتابعة، بلغة المستفيد</a:t>
+            </a:r>
+          </a:p>
+          <a:p>
+            <a:r>
+              <a:t>٪٠٢</a:t>
+            </a:r>
+          </a:p>
+          <a:p>
+            <a:r>
+              <a:t>الموثوقية والسلامة العلمية</a:t>
             </a:r>
           </a:p>
           <a:p>
@@ -4694,7 +4670,12 @@
           </a:p>
           <a:p>
             <a:r>
-              <a:t>15%توظيف الذكاء الاصطناعيDeepSeek  وGemma مسار الإجابة بست مراحل، و«لماذا؟»، والمو ّه التعليمي، وترتيب الرئيسية، بنماذج</a:t>
+              <a:t>٪٥١</a:t>
+            </a:r>
+          </a:p>
+          <a:p>
+            <a:r>
+              <a:t>توظيف الذكاء الاصطناعيDeepSeek  وGemma مسار الإجابة بست مراحل، و«لماذا؟»، والمو ّه التعليمي، وترتيب الرئيسية، بنماذج</a:t>
             </a:r>
           </a:p>
           <a:p>
@@ -4704,22 +4685,42 @@
           </a:p>
           <a:p>
             <a:r>
-              <a:t>15%قابلية التنفيذ. اختبار آلي1,100 الموقع الحي، والمستودع، والفيديو، وأكثر من</a:t>
-            </a:r>
-          </a:p>
-          <a:p>
-            <a:r>
-              <a:t>15%الأصالة والقيمة المضافة.مسار ومساعد مو ّق ومرشد بشري وأدوات يومية وخصوصية لمن يخفي إسلامه، في تطبيق واحد</a:t>
-            </a:r>
-          </a:p>
-          <a:p>
-            <a:r>
-              <a:t>10%القدرة على التنفيذ.فريق من أربعة، لكل مجال مالكه، وأربع لوحات أدوار مبنية</a:t>
-            </a:r>
-          </a:p>
-          <a:p>
-            <a:r>
-              <a:t>رفيق27 / 28</a:t>
+              <a:t>٪٥١</a:t>
+            </a:r>
+          </a:p>
+          <a:p>
+            <a:r>
+              <a:t>قابلية التنفيذ.٠٠١٬١ اختبار آلي الموقع الحي، والمستودع، والفيديو، وأكثر من</a:t>
+            </a:r>
+          </a:p>
+          <a:p>
+            <a:r>
+              <a:t>٪٥١</a:t>
+            </a:r>
+          </a:p>
+          <a:p>
+            <a:r>
+              <a:t>الأصالة والقيمة المضافة.مسار ومساعد مو ّق ومرشد بشري وأدوات يومية وخصوصية لمن يخفي إسلامه، في تطبيق واحد</a:t>
+            </a:r>
+          </a:p>
+          <a:p>
+            <a:r>
+              <a:t>٪٠١</a:t>
+            </a:r>
+          </a:p>
+          <a:p>
+            <a:r>
+              <a:t>القدرة على التنفيذ.فريق من أربعة، لكل مجال مالكه، وأربع لوحات أدوار مبنية</a:t>
+            </a:r>
+          </a:p>
+          <a:p>
+            <a:r>
+              <a:t>رفيق</a:t>
+            </a:r>
+          </a:p>
+          <a:p>
+            <a:r>
+              <a:t>٩٢ / ٧٢</a:t>
             </a:r>
           </a:p>
         </p:txBody>
@@ -4919,6 +4920,96 @@
 </p:notes>
 </file>
 
+<file path=ppt/notesSlides/notesSlide29.xml><?xml version="1.0" encoding="utf-8"?>
+<p:notes xmlns:a="http://schemas.openxmlformats.org/drawingml/2006/main" xmlns:p="http://schemas.openxmlformats.org/presentationml/2006/main" xmlns:r="http://schemas.openxmlformats.org/officeDocument/2006/relationships">
+  <p:cSld>
+    <p:spTree>
+      <p:nvGrpSpPr>
+        <p:cNvPr id="1" name=""/>
+        <p:cNvGrpSpPr/>
+        <p:nvPr/>
+      </p:nvGrpSpPr>
+      <p:grpSpPr>
+        <a:xfrm>
+          <a:off x="0" y="0"/>
+          <a:ext cx="0" cy="0"/>
+          <a:chOff x="0" y="0"/>
+          <a:chExt cx="0" cy="0"/>
+        </a:xfrm>
+      </p:grpSpPr>
+      <p:sp>
+        <p:nvSpPr>
+          <p:cNvPr id="2" name="Slide Image Placeholder 1"/>
+          <p:cNvSpPr>
+            <a:spLocks noGrp="1"/>
+          </p:cNvSpPr>
+          <p:nvPr>
+            <p:ph type="sldImg" idx="2"/>
+          </p:nvPr>
+        </p:nvSpPr>
+        <p:spPr/>
+      </p:sp>
+      <p:sp>
+        <p:nvSpPr>
+          <p:cNvPr id="3" name="Notes Placeholder 2"/>
+          <p:cNvSpPr>
+            <a:spLocks noGrp="1"/>
+          </p:cNvSpPr>
+          <p:nvPr>
+            <p:ph type="body" idx="3" sz="quarter"/>
+          </p:nvPr>
+        </p:nvSpPr>
+        <p:spPr/>
+        <p:txBody>
+          <a:bodyPr/>
+          <a:lstStyle/>
+          <a:p>
+            <a:r>
+              <a:t>شك ًا لكم</a:t>
+            </a:r>
+          </a:p>
+          <a:p>
+            <a:r>
+              <a:t>رفيق · لست وحدك في سنتك الأولى</a:t>
+            </a:r>
+          </a:p>
+          <a:p>
+            <a:r>
+              <a:t>rafeeq.nan.sa/app</a:t>
+            </a:r>
+          </a:p>
+          <a:p>
+            <a:r>
+              <a:t>youtube.com/shorts/NN3KVPgEf-4</a:t>
+            </a:r>
+          </a:p>
+          <a:p>
+            <a:r>
+              <a:t>github.com/rafeeq-muslim/rafeeq</a:t>
+            </a:r>
+          </a:p>
+        </p:txBody>
+      </p:sp>
+      <p:sp>
+        <p:nvSpPr>
+          <p:cNvPr id="4" name="Slide Number Placeholder 3"/>
+          <p:cNvSpPr>
+            <a:spLocks noGrp="1"/>
+          </p:cNvSpPr>
+          <p:nvPr>
+            <p:ph type="sldNum" idx="5" sz="quarter"/>
+          </p:nvPr>
+        </p:nvSpPr>
+        <p:spPr/>
+      </p:sp>
+    </p:spTree>
+  </p:cSld>
+  <p:clrMapOvr>
+    <a:masterClrMapping/>
+  </p:clrMapOvr>
+</p:notes>
+</file>
+
 <file path=ppt/notesSlides/notesSlide3.xml><?xml version="1.0" encoding="utf-8"?>
 <p:notes xmlns:a="http://schemas.openxmlformats.org/drawingml/2006/main" xmlns:p="http://schemas.openxmlformats.org/presentationml/2006/main" xmlns:r="http://schemas.openxmlformats.org/officeDocument/2006/relationships">
   <p:cSld>
@@ -4979,12 +5070,12 @@
           </a:p>
           <a:p>
             <a:r>
-              <a:t>347,646</a:t>
-            </a:r>
-          </a:p>
-          <a:p>
-            <a:r>
-              <a:t>347,646</a:t>
+              <a:t>٦٤٦٬٧٤٣</a:t>
+            </a:r>
+          </a:p>
+          <a:p>
+            <a:r>
+              <a:t>٦٤٦٬٧٤٣</a:t>
             </a:r>
           </a:p>
           <a:p>
@@ -4994,22 +5085,17 @@
           </a:p>
           <a:p>
             <a:r>
-              <a:t> في163,319 ، منهم2023 و2019</a:t>
-            </a:r>
-          </a:p>
-          <a:p>
-            <a:r>
-              <a:t> وحده2023</a:t>
-            </a:r>
-          </a:p>
-          <a:p>
-            <a:r>
-              <a:t>43%</a:t>
-            </a:r>
-          </a:p>
-          <a:p>
-            <a:r>
-              <a:t>43%</a:t>
+              <a:t>٩١٣٬٣٦١ في ٩١٠٢ و٣٢٠٢، منهم</a:t>
+            </a:r>
+          </a:p>
+          <a:p>
+            <a:r>
+              <a:t>٣٢٠٢ وحده</a:t>
+            </a:r>
+          </a:p>
+          <a:p>
+            <a:r>
+              <a:t>٣٤٪٣٤٪</a:t>
             </a:r>
           </a:p>
           <a:p>
@@ -5024,12 +5110,7 @@
           </a:p>
           <a:p>
             <a:r>
-              <a:t>54%</a:t>
-            </a:r>
-          </a:p>
-          <a:p>
-            <a:r>
-              <a:t>54%</a:t>
+              <a:t>٤٥٪٤٥٪</a:t>
             </a:r>
           </a:p>
           <a:p>
@@ -5044,12 +5125,7 @@
           </a:p>
           <a:p>
             <a:r>
-              <a:t>38%</a:t>
-            </a:r>
-          </a:p>
-          <a:p>
-            <a:r>
-              <a:t>38%</a:t>
+              <a:t>٨٣٪٨٣٪</a:t>
             </a:r>
           </a:p>
           <a:p>
@@ -5064,7 +5140,7 @@
           </a:p>
           <a:p>
             <a:r>
-              <a:t>.)2015(  مسل ًا جدي ًا114 )؛ استبانة مركز أصول على2024 المصادر: وزارة الشؤون الإسلامية (واس، يناير</a:t>
+              <a:t>.)٥١٠٢( ٤١١ مسل ًا جدي ًا ٤٢٠٢)؛ استبانة مركز أصول على المصادر: وزارة الشؤون الإسلامية (واس، يناير</a:t>
             </a:r>
           </a:p>
           <a:p>
@@ -5074,12 +5150,12 @@
           </a:p>
           <a:p>
             <a:r>
-              <a:t> · المشكلة والجمهور25%</a:t>
-            </a:r>
-          </a:p>
-          <a:p>
-            <a:r>
-              <a:t>03 / 28</a:t>
+              <a:t> · المشكلة والجمهور٪٥٢</a:t>
+            </a:r>
+          </a:p>
+          <a:p>
+            <a:r>
+              <a:t>٩٢ / ٣٠</a:t>
             </a:r>
           </a:p>
         </p:txBody>
@@ -5254,12 +5330,12 @@
           </a:p>
           <a:p>
             <a:r>
-              <a:t> · المشكلة والجمهور25%</a:t>
-            </a:r>
-          </a:p>
-          <a:p>
-            <a:r>
-              <a:t>04 / 28</a:t>
+              <a:t> · المشكلة والجمهور٪٥٢</a:t>
+            </a:r>
+          </a:p>
+          <a:p>
+            <a:r>
+              <a:t>٩٢ / ٤٠</a:t>
             </a:r>
           </a:p>
         </p:txBody>
@@ -5444,12 +5520,12 @@
           </a:p>
           <a:p>
             <a:r>
-              <a:t> · المشكلة والجمهور25%</a:t>
-            </a:r>
-          </a:p>
-          <a:p>
-            <a:r>
-              <a:t>05 / 28</a:t>
+              <a:t> · المشكلة والجمهور٪٥٢</a:t>
+            </a:r>
+          </a:p>
+          <a:p>
+            <a:r>
+              <a:t>٩٢ / ٥٠</a:t>
             </a:r>
           </a:p>
         </p:txBody>
@@ -5534,7 +5610,7 @@
           </a:p>
           <a:p>
             <a:r>
-              <a:t>1</a:t>
+              <a:t>١</a:t>
             </a:r>
           </a:p>
           <a:p>
@@ -5559,7 +5635,7 @@
           </a:p>
           <a:p>
             <a:r>
-              <a:t>2</a:t>
+              <a:t>٢</a:t>
             </a:r>
           </a:p>
           <a:p>
@@ -5579,7 +5655,7 @@
           </a:p>
           <a:p>
             <a:r>
-              <a:t>3</a:t>
+              <a:t>٣</a:t>
             </a:r>
           </a:p>
           <a:p>
@@ -5599,7 +5675,7 @@
           </a:p>
           <a:p>
             <a:r>
-              <a:t>4</a:t>
+              <a:t>٤</a:t>
             </a:r>
           </a:p>
           <a:p>
@@ -5619,7 +5695,7 @@
           </a:p>
           <a:p>
             <a:r>
-              <a:t>5</a:t>
+              <a:t>٥</a:t>
             </a:r>
           </a:p>
           <a:p>
@@ -5634,7 +5710,7 @@
           </a:p>
           <a:p>
             <a:r>
-              <a:t>6</a:t>
+              <a:t>٦</a:t>
             </a:r>
           </a:p>
           <a:p>
@@ -5709,12 +5785,12 @@
           </a:p>
           <a:p>
             <a:r>
-              <a:t> · المشكلة والجمهور25%</a:t>
-            </a:r>
-          </a:p>
-          <a:p>
-            <a:r>
-              <a:t>06 / 28</a:t>
+              <a:t> · المشكلة والجمهور٪٥٢</a:t>
+            </a:r>
+          </a:p>
+          <a:p>
+            <a:r>
+              <a:t>٩٢ / ٦٠</a:t>
             </a:r>
           </a:p>
         </p:txBody>
@@ -5869,7 +5945,7 @@
           </a:p>
           <a:p>
             <a:r>
-              <a:t> يو ًا30  أيام ثم7 تعود بعد</a:t>
+              <a:t>٠٣ يو ًا ٧ أيام ثم تعود بعد</a:t>
             </a:r>
           </a:p>
           <a:p>
@@ -5899,12 +5975,12 @@
           </a:p>
           <a:p>
             <a:r>
-              <a:t> · المشكلة والجمهور25%</a:t>
-            </a:r>
-          </a:p>
-          <a:p>
-            <a:r>
-              <a:t>07 / 28</a:t>
+              <a:t> · المشكلة والجمهور٪٥٢</a:t>
+            </a:r>
+          </a:p>
+          <a:p>
+            <a:r>
+              <a:t>٩٢ / ٧٠</a:t>
             </a:r>
           </a:p>
         </p:txBody>
@@ -6094,12 +6170,12 @@
           </a:p>
           <a:p>
             <a:r>
-              <a:t> · المشكلة والجمهور25%</a:t>
-            </a:r>
-          </a:p>
-          <a:p>
-            <a:r>
-              <a:t>08 / 28</a:t>
+              <a:t> · المشكلة والجمهور٪٥٢</a:t>
+            </a:r>
+          </a:p>
+          <a:p>
+            <a:r>
+              <a:t>٩٢ / ٨٠</a:t>
             </a:r>
           </a:p>
         </p:txBody>
@@ -6309,12 +6385,12 @@
           </a:p>
           <a:p>
             <a:r>
-              <a:t> · المشكلة والجمهور25%</a:t>
-            </a:r>
-          </a:p>
-          <a:p>
-            <a:r>
-              <a:t>09 / 28</a:t>
+              <a:t> · المشكلة والجمهور٪٥٢</a:t>
+            </a:r>
+          </a:p>
+          <a:p>
+            <a:r>
+              <a:t>٩٢ / ٩٠</a:t>
             </a:r>
           </a:p>
         </p:txBody>
@@ -10192,6 +10268,48 @@
 </p:sld>
 </file>
 
+<file path=ppt/slides/slide29.xml><?xml version="1.0" encoding="utf-8"?>
+<p:sld xmlns:a="http://schemas.openxmlformats.org/drawingml/2006/main" xmlns:p="http://schemas.openxmlformats.org/presentationml/2006/main" xmlns:r="http://schemas.openxmlformats.org/officeDocument/2006/relationships">
+  <p:cSld>
+    <p:spTree>
+      <p:nvGrpSpPr>
+        <p:cNvPr id="1" name=""/>
+        <p:cNvGrpSpPr/>
+        <p:nvPr/>
+      </p:nvGrpSpPr>
+      <p:grpSpPr/>
+      <p:pic>
+        <p:nvPicPr>
+          <p:cNvPr id="2" name="Picture 1" descr="image.jpg"/>
+          <p:cNvPicPr>
+            <a:picLocks noChangeAspect="1"/>
+          </p:cNvPicPr>
+          <p:nvPr/>
+        </p:nvPicPr>
+        <p:blipFill>
+          <a:blip r:embed="rId2"/>
+          <a:stretch>
+            <a:fillRect/>
+          </a:stretch>
+        </p:blipFill>
+        <p:spPr>
+          <a:xfrm>
+            <a:off x="0" y="0"/>
+            <a:ext cx="12192000" cy="6858000"/>
+          </a:xfrm>
+          <a:prstGeom prst="rect">
+            <a:avLst/>
+          </a:prstGeom>
+        </p:spPr>
+      </p:pic>
+    </p:spTree>
+  </p:cSld>
+  <p:clrMapOvr>
+    <a:masterClrMapping/>
+  </p:clrMapOvr>
+</p:sld>
+</file>
+
 <file path=ppt/slides/slide3.xml><?xml version="1.0" encoding="utf-8"?>
 <p:sld xmlns:a="http://schemas.openxmlformats.org/drawingml/2006/main" xmlns:p="http://schemas.openxmlformats.org/presentationml/2006/main" xmlns:r="http://schemas.openxmlformats.org/officeDocument/2006/relationships">
   <p:cSld>

</xml_diff>